<commit_message>
Use full-site data for category and paid analysis
</commit_message>
<xml_diff>
--- a/skill-final-v1.pptx
+++ b/skill-final-v1.pptx
@@ -37193,7 +37193,7 @@
                 <a:ea typeface="微软雅黑"/>
                 <a:cs typeface="微软雅黑"/>
               </a:rPr>
-              <a:t>SkillHub 生态画像：Top1000 里，开发类拿走 21.8% 下载，付费标签仅 0.9%</a:t>
+              <a:t>SkillHub 生态画像：全站付费 10%、API Key 19%，分类比头部更均衡</a:t>
             </a:r>
           </a:p>
         </p:txBody>
@@ -37234,7 +37234,7 @@
                 <a:ea typeface="微软雅黑"/>
                 <a:cs typeface="微软雅黑"/>
               </a:rPr>
-              <a:t>生态画像：Top1000 下载头部</a:t>
+              <a:t>生态画像：来源/消费看 Top1000，分类/付费看全站</a:t>
             </a:r>
           </a:p>
         </p:txBody>
@@ -37921,7 +37921,7 @@
                 <a:ea typeface="微软雅黑"/>
                 <a:cs typeface="微软雅黑"/>
               </a:rPr>
-              <a:t>分类：开发类少而重，AI Agent 多而散</a:t>
+              <a:t>分类：全站结构更均衡，商业/专业/AI/开发居前</a:t>
             </a:r>
           </a:p>
         </p:txBody>
@@ -37962,7 +37962,7 @@
                 <a:ea typeface="微软雅黑"/>
                 <a:cs typeface="微软雅黑"/>
               </a:rPr>
-              <a:t>数量占比 / 下载占比</a:t>
+              <a:t>全站 200,403 条 · 条数占比</a:t>
             </a:r>
           </a:p>
         </p:txBody>
@@ -38003,7 +38003,7 @@
                 <a:ea typeface="微软雅黑"/>
                 <a:cs typeface="微软雅黑"/>
               </a:rPr>
-              <a:t>开发编程</a:t>
+              <a:t>商业运营</a:t>
             </a:r>
           </a:p>
         </p:txBody>
@@ -38063,7 +38063,7 @@
         <p:spPr>
           <a:xfrm>
             <a:off x="7376160" y="1481328"/>
-            <a:ext cx="638922" cy="68580"/>
+            <a:ext cx="1402080" cy="68580"/>
           </a:xfrm>
           <a:prstGeom prst="roundRect">
             <a:avLst>
@@ -38109,7 +38109,7 @@
         <p:spPr>
           <a:xfrm>
             <a:off x="8900160" y="1453896"/>
-            <a:ext cx="1341120" cy="137160"/>
+            <a:ext cx="731520" cy="137160"/>
           </a:xfrm>
           <a:prstGeom prst="rect">
             <a:avLst/>
@@ -38136,7 +38136,7 @@
                 <a:ea typeface="微软雅黑"/>
                 <a:cs typeface="微软雅黑"/>
               </a:rPr>
-              <a:t>7.2% / 21.8%</a:t>
+              <a:t>15.2%</a:t>
             </a:r>
           </a:p>
         </p:txBody>
@@ -38177,7 +38177,7 @@
                 <a:ea typeface="微软雅黑"/>
                 <a:cs typeface="微软雅黑"/>
               </a:rPr>
-              <a:t>AI Agent</a:t>
+              <a:t>专业服务</a:t>
             </a:r>
           </a:p>
         </p:txBody>
@@ -38237,7 +38237,7 @@
         <p:spPr>
           <a:xfrm>
             <a:off x="7376160" y="1687068"/>
-            <a:ext cx="1402080" cy="68580"/>
+            <a:ext cx="1070008" cy="68580"/>
           </a:xfrm>
           <a:prstGeom prst="roundRect">
             <a:avLst>
@@ -38283,7 +38283,7 @@
         <p:spPr>
           <a:xfrm>
             <a:off x="8900160" y="1659636"/>
-            <a:ext cx="1341120" cy="137160"/>
+            <a:ext cx="731520" cy="137160"/>
           </a:xfrm>
           <a:prstGeom prst="rect">
             <a:avLst/>
@@ -38310,7 +38310,7 @@
                 <a:ea typeface="微软雅黑"/>
                 <a:cs typeface="微软雅黑"/>
               </a:rPr>
-              <a:t>15.8% / 15.4%</a:t>
+              <a:t>11.6%</a:t>
             </a:r>
           </a:p>
         </p:txBody>
@@ -38351,7 +38351,7 @@
                 <a:ea typeface="微软雅黑"/>
                 <a:cs typeface="微软雅黑"/>
               </a:rPr>
-              <a:t>办公效率</a:t>
+              <a:t>AI Agent</a:t>
             </a:r>
           </a:p>
         </p:txBody>
@@ -38411,7 +38411,7 @@
         <p:spPr>
           <a:xfrm>
             <a:off x="7376160" y="1892808"/>
-            <a:ext cx="1126988" cy="68580"/>
+            <a:ext cx="1033111" cy="68580"/>
           </a:xfrm>
           <a:prstGeom prst="roundRect">
             <a:avLst>
@@ -38457,7 +38457,7 @@
         <p:spPr>
           <a:xfrm>
             <a:off x="8900160" y="1865376"/>
-            <a:ext cx="1341120" cy="137160"/>
+            <a:ext cx="731520" cy="137160"/>
           </a:xfrm>
           <a:prstGeom prst="rect">
             <a:avLst/>
@@ -38484,7 +38484,7 @@
                 <a:ea typeface="微软雅黑"/>
                 <a:cs typeface="微软雅黑"/>
               </a:rPr>
-              <a:t>12.7% / 10.4%</a:t>
+              <a:t>11.2%</a:t>
             </a:r>
           </a:p>
         </p:txBody>
@@ -38525,7 +38525,7 @@
                 <a:ea typeface="微软雅黑"/>
                 <a:cs typeface="微软雅黑"/>
               </a:rPr>
-              <a:t>知识管理</a:t>
+              <a:t>开发编程</a:t>
             </a:r>
           </a:p>
         </p:txBody>
@@ -38585,7 +38585,7 @@
         <p:spPr>
           <a:xfrm>
             <a:off x="7376160" y="2098548"/>
-            <a:ext cx="603426" cy="68580"/>
+            <a:ext cx="977766" cy="68580"/>
           </a:xfrm>
           <a:prstGeom prst="roundRect">
             <a:avLst>
@@ -38631,7 +38631,7 @@
         <p:spPr>
           <a:xfrm>
             <a:off x="8900160" y="2071116"/>
-            <a:ext cx="1341120" cy="137160"/>
+            <a:ext cx="731520" cy="137160"/>
           </a:xfrm>
           <a:prstGeom prst="rect">
             <a:avLst/>
@@ -38658,7 +38658,7 @@
                 <a:ea typeface="微软雅黑"/>
                 <a:cs typeface="微软雅黑"/>
               </a:rPr>
-              <a:t>6.8% / 9.5%</a:t>
+              <a:t>10.6%</a:t>
             </a:r>
           </a:p>
         </p:txBody>
@@ -38759,7 +38759,7 @@
         <p:spPr>
           <a:xfrm>
             <a:off x="7376160" y="2304288"/>
-            <a:ext cx="1047123" cy="68580"/>
+            <a:ext cx="867075" cy="68580"/>
           </a:xfrm>
           <a:prstGeom prst="roundRect">
             <a:avLst>
@@ -38805,7 +38805,7 @@
         <p:spPr>
           <a:xfrm>
             <a:off x="8900160" y="2276856"/>
-            <a:ext cx="1341120" cy="137160"/>
+            <a:ext cx="731520" cy="137160"/>
           </a:xfrm>
           <a:prstGeom prst="rect">
             <a:avLst/>
@@ -38832,7 +38832,7 @@
                 <a:ea typeface="微软雅黑"/>
                 <a:cs typeface="微软雅黑"/>
               </a:rPr>
-              <a:t>11.8% / 9.2%</a:t>
+              <a:t>9.4%</a:t>
             </a:r>
           </a:p>
         </p:txBody>
@@ -38933,7 +38933,7 @@
         <p:spPr>
           <a:xfrm>
             <a:off x="7376160" y="2510028"/>
-            <a:ext cx="1091492" cy="68580"/>
+            <a:ext cx="682591" cy="68580"/>
           </a:xfrm>
           <a:prstGeom prst="roundRect">
             <a:avLst>
@@ -38979,7 +38979,7 @@
         <p:spPr>
           <a:xfrm>
             <a:off x="8900160" y="2482596"/>
-            <a:ext cx="1341120" cy="137160"/>
+            <a:ext cx="731520" cy="137160"/>
           </a:xfrm>
           <a:prstGeom prst="rect">
             <a:avLst/>
@@ -39006,7 +39006,7 @@
                 <a:ea typeface="微软雅黑"/>
                 <a:cs typeface="微软雅黑"/>
               </a:rPr>
-              <a:t>12.3% / 8.1%</a:t>
+              <a:t>7.4%</a:t>
             </a:r>
           </a:p>
         </p:txBody>
@@ -39047,7 +39047,7 @@
                 <a:ea typeface="微软雅黑"/>
                 <a:cs typeface="微软雅黑"/>
               </a:rPr>
-              <a:t>开发类只占 7.2% 供给，却拿走 21.8% 下载；AI Agent 供给最多，下载占比略低。</a:t>
+              <a:t>其余 6 类合计 34.7%；12 个内容分类基本覆盖全站（10 条未挂类目）。</a:t>
             </a:r>
           </a:p>
         </p:txBody>
@@ -39088,7 +39088,7 @@
                 <a:ea typeface="微软雅黑"/>
                 <a:cs typeface="微软雅黑"/>
               </a:rPr>
-              <a:t>其余 6 类合计：33.4% 供给 / 25.6% 下载。</a:t>
+              <a:t>对比 Top1000：AI Agent 15.8%、开发 7.2%，头部结构与全站不同。</a:t>
             </a:r>
           </a:p>
         </p:txBody>
@@ -39129,7 +39129,7 @@
                 <a:ea typeface="微软雅黑"/>
                 <a:cs typeface="微软雅黑"/>
               </a:rPr>
-              <a:t>付费与 API Key：API Key 已三成，付费仍在边缘</a:t>
+              <a:t>付费与 API Key：全站 10.0% / 19.3%，头部结构相反</a:t>
             </a:r>
           </a:p>
         </p:txBody>
@@ -39170,7 +39170,7 @@
                 <a:ea typeface="微软雅黑"/>
                 <a:cs typeface="微软雅黑"/>
               </a:rPr>
-              <a:t>Top1000 条 · 条数占比 / 下载占比</a:t>
+              <a:t>全站 200,403 条 · 条数占比</a:t>
             </a:r>
           </a:p>
         </p:txBody>
@@ -39211,7 +39211,7 @@
                 <a:ea typeface="微软雅黑"/>
                 <a:cs typeface="微软雅黑"/>
               </a:rPr>
-              <a:t>0.9%</a:t>
+              <a:t>10.0%</a:t>
             </a:r>
           </a:p>
         </p:txBody>
@@ -39252,7 +39252,7 @@
                 <a:ea typeface="微软雅黑"/>
                 <a:cs typeface="微软雅黑"/>
               </a:rPr>
-              <a:t>PaySkill（9 条）</a:t>
+              <a:t>Pay Skill（20,125 条）</a:t>
             </a:r>
           </a:p>
         </p:txBody>
@@ -39293,7 +39293,7 @@
                 <a:ea typeface="微软雅黑"/>
                 <a:cs typeface="微软雅黑"/>
               </a:rPr>
-              <a:t>30.7%</a:t>
+              <a:t>19.3%</a:t>
             </a:r>
           </a:p>
         </p:txBody>
@@ -39334,7 +39334,7 @@
                 <a:ea typeface="微软雅黑"/>
                 <a:cs typeface="微软雅黑"/>
               </a:rPr>
-              <a:t>API Key（307 条）</a:t>
+              <a:t>API Key（38,646 条）</a:t>
             </a:r>
           </a:p>
         </p:txBody>
@@ -39348,7 +39348,7 @@
         <p:spPr>
           <a:xfrm>
             <a:off x="426720" y="4491990"/>
-            <a:ext cx="5364480" cy="514350"/>
+            <a:ext cx="5364480" cy="582930"/>
           </a:xfrm>
           <a:prstGeom prst="rect">
             <a:avLst/>
@@ -39375,8 +39375,8 @@
                 <a:ea typeface="微软雅黑"/>
                 <a:cs typeface="微软雅黑"/>
               </a:rPr>
-              <a:t>付费下载占比 0.8%；API Key 下载占比 21.6%；付费且 API Key 仅 1 条；
-Pay Skill 分类在 Top1000 为 0 条。付费标签按 pricing_type=paid/alipay 统计。</a:t>
+              <a:t>付费标签 17,123（8.5%）、支付宝 2,901（1.4%）；Pay Skill 且 API Key 331 条。
+Top1000：付费 0.9%、API Key 30.7%；Pay Skill 是多标签分类，不计入左侧 12 类。</a:t>
             </a:r>
           </a:p>
         </p:txBody>
@@ -39786,7 +39786,7 @@
                 <a:ea typeface="微软雅黑"/>
                 <a:cs typeface="微软雅黑"/>
               </a:rPr>
-              <a:t>读法：ClawHub 撑数量，社区撑下载，开发类最重；付费仍在边缘，API Key 已是三成供给。</a:t>
+              <a:t>读法：全站付费 10%、API Key 19%，但头部下载集中在编程；Top1000 付费标签只有 0.9%。</a:t>
             </a:r>
           </a:p>
         </p:txBody>

</xml_diff>

<commit_message>
Refine SkillHub ecosystem portrait
</commit_message>
<xml_diff>
--- a/skill-final-v1.pptx
+++ b/skill-final-v1.pptx
@@ -37193,7 +37193,7 @@
                 <a:ea typeface="微软雅黑"/>
                 <a:cs typeface="微软雅黑"/>
               </a:rPr>
-              <a:t>SkillHub 生态画像：全站付费 10%、API Key 19%，分类比头部更均衡</a:t>
+              <a:t>SkillHub 生态画像：Top5000 里，个人 24.9%、企业 12.7%、镜像 62.4%</a:t>
             </a:r>
           </a:p>
         </p:txBody>
@@ -37206,8 +37206,8 @@
         </p:nvSpPr>
         <p:spPr>
           <a:xfrm>
-            <a:off x="426720" y="754380"/>
-            <a:ext cx="4876800" cy="178308"/>
+            <a:off x="426720" y="740664"/>
+            <a:ext cx="10972800" cy="164592"/>
           </a:xfrm>
           <a:prstGeom prst="rect">
             <a:avLst/>
@@ -37226,15 +37226,15 @@
               </a:lnSpc>
             </a:pPr>
             <a:r>
-              <a:rPr sz="1200" b="1">
-                <a:solidFill>
-                  <a:srgbClr val="1A1A1C"/>
-                </a:solidFill>
-                <a:latin typeface="微软雅黑"/>
-                <a:ea typeface="微软雅黑"/>
-                <a:cs typeface="微软雅黑"/>
-              </a:rPr>
-              <a:t>生态画像：来源/消费看 Top1000，分类/付费看全站</a:t>
+              <a:rPr sz="1000" b="0">
+                <a:solidFill>
+                  <a:srgbClr val="5B616B"/>
+                </a:solidFill>
+                <a:latin typeface="微软雅黑"/>
+                <a:ea typeface="微软雅黑"/>
+                <a:cs typeface="微软雅黑"/>
+              </a:rPr>
+              <a:t>镜像撑数量，个人下载份额最高，企业单条最强；全站付费 10%，头部只有 1%。</a:t>
             </a:r>
           </a:p>
         </p:txBody>
@@ -37247,7 +37247,7 @@
         </p:nvSpPr>
         <p:spPr>
           <a:xfrm>
-            <a:off x="426720" y="1028700"/>
+            <a:off x="426720" y="994409"/>
             <a:ext cx="5364480" cy="164592"/>
           </a:xfrm>
           <a:prstGeom prst="rect">
@@ -37275,7 +37275,7 @@
                 <a:ea typeface="微软雅黑"/>
                 <a:cs typeface="微软雅黑"/>
               </a:rPr>
-              <a:t>谁在供给：ClawHub 数量最多，社区拿走最多下载</a:t>
+              <a:t>三种上架方：镜像最多，个人最重，企业最强</a:t>
             </a:r>
           </a:p>
         </p:txBody>
@@ -37288,7 +37288,7 @@
         </p:nvSpPr>
         <p:spPr>
           <a:xfrm>
-            <a:off x="426720" y="1193292"/>
+            <a:off x="426720" y="1152144"/>
             <a:ext cx="5364480" cy="137160"/>
           </a:xfrm>
           <a:prstGeom prst="rect">
@@ -37316,7 +37316,7 @@
                 <a:ea typeface="微软雅黑"/>
                 <a:cs typeface="微软雅黑"/>
               </a:rPr>
-              <a:t>Top1000 条 · 数量占比 / 下载占比</a:t>
+              <a:t>Top5000 条 · 数量 / 下载</a:t>
             </a:r>
           </a:p>
         </p:txBody>
@@ -37329,7 +37329,7 @@
         </p:nvSpPr>
         <p:spPr>
           <a:xfrm>
-            <a:off x="426720" y="1453896"/>
+            <a:off x="426720" y="1371600"/>
             <a:ext cx="1036320" cy="137160"/>
           </a:xfrm>
           <a:prstGeom prst="rect">
@@ -37357,7 +37357,7 @@
                 <a:ea typeface="微软雅黑"/>
                 <a:cs typeface="微软雅黑"/>
               </a:rPr>
-              <a:t>ClawHub</a:t>
+              <a:t>个人 / 社区</a:t>
             </a:r>
           </a:p>
         </p:txBody>
@@ -37370,8 +37370,8 @@
         </p:nvSpPr>
         <p:spPr>
           <a:xfrm>
-            <a:off x="1524000" y="1481328"/>
-            <a:ext cx="2072640" cy="75438"/>
+            <a:off x="1524000" y="1399032"/>
+            <a:ext cx="1828800" cy="68580"/>
           </a:xfrm>
           <a:prstGeom prst="roundRect">
             <a:avLst>
@@ -37416,8 +37416,8 @@
         </p:nvSpPr>
         <p:spPr>
           <a:xfrm>
-            <a:off x="1524000" y="1481328"/>
-            <a:ext cx="2072640" cy="75438"/>
+            <a:off x="1524000" y="1399032"/>
+            <a:ext cx="729761" cy="68580"/>
           </a:xfrm>
           <a:prstGeom prst="roundRect">
             <a:avLst>
@@ -37425,7 +37425,7 @@
             </a:avLst>
           </a:prstGeom>
           <a:solidFill>
-            <a:srgbClr val="9AA1AA"/>
+            <a:srgbClr val="B5333B"/>
           </a:solidFill>
           <a:ln>
             <a:noFill/>
@@ -37462,8 +37462,8 @@
         </p:nvSpPr>
         <p:spPr>
           <a:xfrm>
-            <a:off x="3779520" y="1453896"/>
-            <a:ext cx="2011680" cy="137160"/>
+            <a:off x="3560064" y="1371600"/>
+            <a:ext cx="1950720" cy="137160"/>
           </a:xfrm>
           <a:prstGeom prst="rect">
             <a:avLst/>
@@ -37482,7 +37482,7 @@
               </a:lnSpc>
             </a:pPr>
             <a:r>
-              <a:rPr sz="900" b="0">
+              <a:rPr sz="850" b="0">
                 <a:solidFill>
                   <a:srgbClr val="1A1A1C"/>
                 </a:solidFill>
@@ -37490,7 +37490,7 @@
                 <a:ea typeface="微软雅黑"/>
                 <a:cs typeface="微软雅黑"/>
               </a:rPr>
-              <a:t>44.7% / 27.0%</a:t>
+              <a:t>24.9% / 39.8%</a:t>
             </a:r>
           </a:p>
         </p:txBody>
@@ -37503,7 +37503,7 @@
         </p:nvSpPr>
         <p:spPr>
           <a:xfrm>
-            <a:off x="426720" y="1728216"/>
+            <a:off x="426720" y="1577340"/>
             <a:ext cx="1036320" cy="137160"/>
           </a:xfrm>
           <a:prstGeom prst="rect">
@@ -37531,7 +37531,7 @@
                 <a:ea typeface="微软雅黑"/>
                 <a:cs typeface="微软雅黑"/>
               </a:rPr>
-              <a:t>社区</a:t>
+              <a:t>企业</a:t>
             </a:r>
           </a:p>
         </p:txBody>
@@ -37544,8 +37544,8 @@
         </p:nvSpPr>
         <p:spPr>
           <a:xfrm>
-            <a:off x="1524000" y="1755648"/>
-            <a:ext cx="2072640" cy="75438"/>
+            <a:off x="1524000" y="1604772"/>
+            <a:ext cx="1828800" cy="68580"/>
           </a:xfrm>
           <a:prstGeom prst="roundRect">
             <a:avLst>
@@ -37590,8 +37590,8 @@
         </p:nvSpPr>
         <p:spPr>
           <a:xfrm>
-            <a:off x="1524000" y="1755648"/>
-            <a:ext cx="1414217" cy="75438"/>
+            <a:off x="1524000" y="1604772"/>
+            <a:ext cx="372207" cy="68580"/>
           </a:xfrm>
           <a:prstGeom prst="roundRect">
             <a:avLst>
@@ -37599,7 +37599,7 @@
             </a:avLst>
           </a:prstGeom>
           <a:solidFill>
-            <a:srgbClr val="B5333B"/>
+            <a:srgbClr val="566472"/>
           </a:solidFill>
           <a:ln>
             <a:noFill/>
@@ -37636,8 +37636,8 @@
         </p:nvSpPr>
         <p:spPr>
           <a:xfrm>
-            <a:off x="3779520" y="1728216"/>
-            <a:ext cx="2011680" cy="137160"/>
+            <a:off x="3560064" y="1577340"/>
+            <a:ext cx="1950720" cy="137160"/>
           </a:xfrm>
           <a:prstGeom prst="rect">
             <a:avLst/>
@@ -37656,7 +37656,7 @@
               </a:lnSpc>
             </a:pPr>
             <a:r>
-              <a:rPr sz="900" b="0">
+              <a:rPr sz="850" b="0">
                 <a:solidFill>
                   <a:srgbClr val="1A1A1C"/>
                 </a:solidFill>
@@ -37664,7 +37664,7 @@
                 <a:ea typeface="微软雅黑"/>
                 <a:cs typeface="微软雅黑"/>
               </a:rPr>
-              <a:t>30.5% / 44.2%</a:t>
+              <a:t>12.7% / 24.7%</a:t>
             </a:r>
           </a:p>
         </p:txBody>
@@ -37677,7 +37677,7 @@
         </p:nvSpPr>
         <p:spPr>
           <a:xfrm>
-            <a:off x="426720" y="2002536"/>
+            <a:off x="426720" y="1783080"/>
             <a:ext cx="1036320" cy="137160"/>
           </a:xfrm>
           <a:prstGeom prst="rect">
@@ -37705,7 +37705,7 @@
                 <a:ea typeface="微软雅黑"/>
                 <a:cs typeface="微软雅黑"/>
               </a:rPr>
-              <a:t>企业</a:t>
+              <a:t>镜像 ClawHub</a:t>
             </a:r>
           </a:p>
         </p:txBody>
@@ -37718,8 +37718,8 @@
         </p:nvSpPr>
         <p:spPr>
           <a:xfrm>
-            <a:off x="1524000" y="2029968"/>
-            <a:ext cx="2072640" cy="75438"/>
+            <a:off x="1524000" y="1810512"/>
+            <a:ext cx="1828800" cy="68580"/>
           </a:xfrm>
           <a:prstGeom prst="roundRect">
             <a:avLst>
@@ -37764,8 +37764,8 @@
         </p:nvSpPr>
         <p:spPr>
           <a:xfrm>
-            <a:off x="1524000" y="2029968"/>
-            <a:ext cx="1149921" cy="75438"/>
+            <a:off x="1524000" y="1810512"/>
+            <a:ext cx="1828800" cy="68580"/>
           </a:xfrm>
           <a:prstGeom prst="roundRect">
             <a:avLst>
@@ -37773,7 +37773,7 @@
             </a:avLst>
           </a:prstGeom>
           <a:solidFill>
-            <a:srgbClr val="9AA1AA"/>
+            <a:srgbClr val="CFD4DA"/>
           </a:solidFill>
           <a:ln>
             <a:noFill/>
@@ -37810,8 +37810,8 @@
         </p:nvSpPr>
         <p:spPr>
           <a:xfrm>
-            <a:off x="3779520" y="2002536"/>
-            <a:ext cx="2011680" cy="137160"/>
+            <a:off x="3560064" y="1783080"/>
+            <a:ext cx="1950720" cy="137160"/>
           </a:xfrm>
           <a:prstGeom prst="rect">
             <a:avLst/>
@@ -37830,7 +37830,7 @@
               </a:lnSpc>
             </a:pPr>
             <a:r>
-              <a:rPr sz="900" b="0">
+              <a:rPr sz="850" b="0">
                 <a:solidFill>
                   <a:srgbClr val="1A1A1C"/>
                 </a:solidFill>
@@ -37838,7 +37838,7 @@
                 <a:ea typeface="微软雅黑"/>
                 <a:cs typeface="微软雅黑"/>
               </a:rPr>
-              <a:t>24.8% / 28.8%</a:t>
+              <a:t>62.4% / 35.5%</a:t>
             </a:r>
           </a:p>
         </p:txBody>
@@ -37851,8 +37851,8 @@
         </p:nvSpPr>
         <p:spPr>
           <a:xfrm>
-            <a:off x="426720" y="2331720"/>
-            <a:ext cx="5364480" cy="342900"/>
+            <a:off x="426720" y="2023110"/>
+            <a:ext cx="5364480" cy="329184"/>
           </a:xfrm>
           <a:prstGeom prst="rect">
             <a:avLst/>
@@ -37867,7 +37867,7 @@
           <a:p>
             <a:pPr algn="l">
               <a:lnSpc>
-                <a:spcPct val="115000"/>
+                <a:spcPct val="110000"/>
               </a:lnSpc>
             </a:pPr>
             <a:r>
@@ -37879,8 +37879,8 @@
                 <a:ea typeface="微软雅黑"/>
                 <a:cs typeface="微软雅黑"/>
               </a:rPr>
-              <a:t>社区 = 个人/社区作者；ClawHub = 外部同步；企业 = 认证企业。
-Top1000 里 ClawHub 条数最多，但下载份额低于社区。</a:t>
+              <a:t>个人条数少、下载高；镜像条数最多；企业单条最强见右图。
+个人 1,245 条 / 企业 633 条 / 镜像 3,122 条。</a:t>
             </a:r>
           </a:p>
         </p:txBody>
@@ -37893,7 +37893,7 @@
         </p:nvSpPr>
         <p:spPr>
           <a:xfrm>
-            <a:off x="6217920" y="1028700"/>
+            <a:off x="6217920" y="994409"/>
             <a:ext cx="5364480" cy="164592"/>
           </a:xfrm>
           <a:prstGeom prst="rect">
@@ -37921,7 +37921,7 @@
                 <a:ea typeface="微软雅黑"/>
                 <a:cs typeface="微软雅黑"/>
               </a:rPr>
-              <a:t>分类：全站结构更均衡，商业/专业/AI/开发居前</a:t>
+              <a:t>分类：全站商业 / 专业 / AI / 开发居前</a:t>
             </a:r>
           </a:p>
         </p:txBody>
@@ -37934,7 +37934,7 @@
         </p:nvSpPr>
         <p:spPr>
           <a:xfrm>
-            <a:off x="6217920" y="1193292"/>
+            <a:off x="6217920" y="1152144"/>
             <a:ext cx="5364480" cy="137160"/>
           </a:xfrm>
           <a:prstGeom prst="rect">
@@ -37975,8 +37975,8 @@
         </p:nvSpPr>
         <p:spPr>
           <a:xfrm>
-            <a:off x="6217920" y="1453896"/>
-            <a:ext cx="1097280" cy="137160"/>
+            <a:off x="6217920" y="1357884"/>
+            <a:ext cx="1036320" cy="137160"/>
           </a:xfrm>
           <a:prstGeom prst="rect">
             <a:avLst/>
@@ -38016,8 +38016,8 @@
         </p:nvSpPr>
         <p:spPr>
           <a:xfrm>
-            <a:off x="7376160" y="1481328"/>
-            <a:ext cx="1402080" cy="68580"/>
+            <a:off x="7315200" y="1385316"/>
+            <a:ext cx="1341120" cy="61721"/>
           </a:xfrm>
           <a:prstGeom prst="roundRect">
             <a:avLst>
@@ -38062,8 +38062,8 @@
         </p:nvSpPr>
         <p:spPr>
           <a:xfrm>
-            <a:off x="7376160" y="1481328"/>
-            <a:ext cx="1402080" cy="68580"/>
+            <a:off x="7315200" y="1385316"/>
+            <a:ext cx="1341120" cy="61721"/>
           </a:xfrm>
           <a:prstGeom prst="roundRect">
             <a:avLst>
@@ -38108,7 +38108,7 @@
         </p:nvSpPr>
         <p:spPr>
           <a:xfrm>
-            <a:off x="8900160" y="1453896"/>
+            <a:off x="8778240" y="1357884"/>
             <a:ext cx="731520" cy="137160"/>
           </a:xfrm>
           <a:prstGeom prst="rect">
@@ -38149,8 +38149,8 @@
         </p:nvSpPr>
         <p:spPr>
           <a:xfrm>
-            <a:off x="6217920" y="1659636"/>
-            <a:ext cx="1097280" cy="137160"/>
+            <a:off x="6217920" y="1508760"/>
+            <a:ext cx="1036320" cy="137160"/>
           </a:xfrm>
           <a:prstGeom prst="rect">
             <a:avLst/>
@@ -38190,8 +38190,8 @@
         </p:nvSpPr>
         <p:spPr>
           <a:xfrm>
-            <a:off x="7376160" y="1687068"/>
-            <a:ext cx="1402080" cy="68580"/>
+            <a:off x="7315200" y="1536192"/>
+            <a:ext cx="1341120" cy="61721"/>
           </a:xfrm>
           <a:prstGeom prst="roundRect">
             <a:avLst>
@@ -38236,8 +38236,8 @@
         </p:nvSpPr>
         <p:spPr>
           <a:xfrm>
-            <a:off x="7376160" y="1687068"/>
-            <a:ext cx="1070008" cy="68580"/>
+            <a:off x="7315200" y="1536192"/>
+            <a:ext cx="1023486" cy="61721"/>
           </a:xfrm>
           <a:prstGeom prst="roundRect">
             <a:avLst>
@@ -38282,7 +38282,7 @@
         </p:nvSpPr>
         <p:spPr>
           <a:xfrm>
-            <a:off x="8900160" y="1659636"/>
+            <a:off x="8778240" y="1508760"/>
             <a:ext cx="731520" cy="137160"/>
           </a:xfrm>
           <a:prstGeom prst="rect">
@@ -38323,8 +38323,8 @@
         </p:nvSpPr>
         <p:spPr>
           <a:xfrm>
-            <a:off x="6217920" y="1865376"/>
-            <a:ext cx="1097280" cy="137160"/>
+            <a:off x="6217920" y="1659636"/>
+            <a:ext cx="1036320" cy="137160"/>
           </a:xfrm>
           <a:prstGeom prst="rect">
             <a:avLst/>
@@ -38364,8 +38364,8 @@
         </p:nvSpPr>
         <p:spPr>
           <a:xfrm>
-            <a:off x="7376160" y="1892808"/>
-            <a:ext cx="1402080" cy="68580"/>
+            <a:off x="7315200" y="1687068"/>
+            <a:ext cx="1341120" cy="61721"/>
           </a:xfrm>
           <a:prstGeom prst="roundRect">
             <a:avLst>
@@ -38410,8 +38410,8 @@
         </p:nvSpPr>
         <p:spPr>
           <a:xfrm>
-            <a:off x="7376160" y="1892808"/>
-            <a:ext cx="1033111" cy="68580"/>
+            <a:off x="7315200" y="1687068"/>
+            <a:ext cx="988193" cy="61721"/>
           </a:xfrm>
           <a:prstGeom prst="roundRect">
             <a:avLst>
@@ -38456,7 +38456,7 @@
         </p:nvSpPr>
         <p:spPr>
           <a:xfrm>
-            <a:off x="8900160" y="1865376"/>
+            <a:off x="8778240" y="1659636"/>
             <a:ext cx="731520" cy="137160"/>
           </a:xfrm>
           <a:prstGeom prst="rect">
@@ -38497,8 +38497,8 @@
         </p:nvSpPr>
         <p:spPr>
           <a:xfrm>
-            <a:off x="6217920" y="2071116"/>
-            <a:ext cx="1097280" cy="137160"/>
+            <a:off x="6217920" y="1810512"/>
+            <a:ext cx="1036320" cy="137160"/>
           </a:xfrm>
           <a:prstGeom prst="rect">
             <a:avLst/>
@@ -38538,8 +38538,8 @@
         </p:nvSpPr>
         <p:spPr>
           <a:xfrm>
-            <a:off x="7376160" y="2098548"/>
-            <a:ext cx="1402080" cy="68580"/>
+            <a:off x="7315200" y="1837944"/>
+            <a:ext cx="1341120" cy="61721"/>
           </a:xfrm>
           <a:prstGeom prst="roundRect">
             <a:avLst>
@@ -38584,8 +38584,8 @@
         </p:nvSpPr>
         <p:spPr>
           <a:xfrm>
-            <a:off x="7376160" y="2098548"/>
-            <a:ext cx="977766" cy="68580"/>
+            <a:off x="7315200" y="1837944"/>
+            <a:ext cx="935254" cy="61721"/>
           </a:xfrm>
           <a:prstGeom prst="roundRect">
             <a:avLst>
@@ -38630,7 +38630,7 @@
         </p:nvSpPr>
         <p:spPr>
           <a:xfrm>
-            <a:off x="8900160" y="2071116"/>
+            <a:off x="8778240" y="1810512"/>
             <a:ext cx="731520" cy="137160"/>
           </a:xfrm>
           <a:prstGeom prst="rect">
@@ -38671,8 +38671,8 @@
         </p:nvSpPr>
         <p:spPr>
           <a:xfrm>
-            <a:off x="6217920" y="2276856"/>
-            <a:ext cx="1097280" cy="137160"/>
+            <a:off x="6217920" y="1961388"/>
+            <a:ext cx="1036320" cy="137160"/>
           </a:xfrm>
           <a:prstGeom prst="rect">
             <a:avLst/>
@@ -38712,8 +38712,8 @@
         </p:nvSpPr>
         <p:spPr>
           <a:xfrm>
-            <a:off x="7376160" y="2304288"/>
-            <a:ext cx="1402080" cy="68580"/>
+            <a:off x="7315200" y="1988820"/>
+            <a:ext cx="1341120" cy="61721"/>
           </a:xfrm>
           <a:prstGeom prst="roundRect">
             <a:avLst>
@@ -38758,8 +38758,8 @@
         </p:nvSpPr>
         <p:spPr>
           <a:xfrm>
-            <a:off x="7376160" y="2304288"/>
-            <a:ext cx="867075" cy="68580"/>
+            <a:off x="7315200" y="1988820"/>
+            <a:ext cx="829376" cy="61721"/>
           </a:xfrm>
           <a:prstGeom prst="roundRect">
             <a:avLst>
@@ -38804,7 +38804,7 @@
         </p:nvSpPr>
         <p:spPr>
           <a:xfrm>
-            <a:off x="8900160" y="2276856"/>
+            <a:off x="8778240" y="1961388"/>
             <a:ext cx="731520" cy="137160"/>
           </a:xfrm>
           <a:prstGeom prst="rect">
@@ -38845,8 +38845,8 @@
         </p:nvSpPr>
         <p:spPr>
           <a:xfrm>
-            <a:off x="6217920" y="2482596"/>
-            <a:ext cx="1097280" cy="137160"/>
+            <a:off x="6217920" y="2112264"/>
+            <a:ext cx="1036320" cy="137160"/>
           </a:xfrm>
           <a:prstGeom prst="rect">
             <a:avLst/>
@@ -38886,8 +38886,8 @@
         </p:nvSpPr>
         <p:spPr>
           <a:xfrm>
-            <a:off x="7376160" y="2510028"/>
-            <a:ext cx="1402080" cy="68580"/>
+            <a:off x="7315200" y="2139696"/>
+            <a:ext cx="1341120" cy="61721"/>
           </a:xfrm>
           <a:prstGeom prst="roundRect">
             <a:avLst>
@@ -38932,8 +38932,8 @@
         </p:nvSpPr>
         <p:spPr>
           <a:xfrm>
-            <a:off x="7376160" y="2510028"/>
-            <a:ext cx="682591" cy="68580"/>
+            <a:off x="7315200" y="2139696"/>
+            <a:ext cx="652913" cy="61721"/>
           </a:xfrm>
           <a:prstGeom prst="roundRect">
             <a:avLst>
@@ -38978,7 +38978,7 @@
         </p:nvSpPr>
         <p:spPr>
           <a:xfrm>
-            <a:off x="8900160" y="2482596"/>
+            <a:off x="8778240" y="2112264"/>
             <a:ext cx="731520" cy="137160"/>
           </a:xfrm>
           <a:prstGeom prst="rect">
@@ -39019,8 +39019,8 @@
         </p:nvSpPr>
         <p:spPr>
           <a:xfrm>
-            <a:off x="6217920" y="2777490"/>
-            <a:ext cx="5364480" cy="150876"/>
+            <a:off x="6217920" y="2276856"/>
+            <a:ext cx="5364480" cy="240030"/>
           </a:xfrm>
           <a:prstGeom prst="rect">
             <a:avLst/>
@@ -39047,7 +39047,7 @@
                 <a:ea typeface="微软雅黑"/>
                 <a:cs typeface="微软雅黑"/>
               </a:rPr>
-              <a:t>其余 6 类合计 34.7%；12 个内容分类基本覆盖全站（10 条未挂类目）。</a:t>
+              <a:t>其余 6 类 34.7%；12 个内容分类覆盖全站；Pay Skill 10.0% 为多标签，另计。</a:t>
             </a:r>
           </a:p>
         </p:txBody>
@@ -39060,8 +39060,8 @@
         </p:nvSpPr>
         <p:spPr>
           <a:xfrm>
-            <a:off x="6217920" y="2962656"/>
-            <a:ext cx="5364480" cy="137160"/>
+            <a:off x="426720" y="2640330"/>
+            <a:ext cx="5364480" cy="164592"/>
           </a:xfrm>
           <a:prstGeom prst="rect">
             <a:avLst/>
@@ -39080,15 +39080,15 @@
               </a:lnSpc>
             </a:pPr>
             <a:r>
-              <a:rPr sz="850" b="0">
-                <a:solidFill>
-                  <a:srgbClr val="8B8E94"/>
-                </a:solidFill>
-                <a:latin typeface="微软雅黑"/>
-                <a:ea typeface="微软雅黑"/>
-                <a:cs typeface="微软雅黑"/>
-              </a:rPr>
-              <a:t>对比 Top1000：AI Agent 15.8%、开发 7.2%，头部结构与全站不同。</a:t>
+              <a:rPr sz="1050" b="1">
+                <a:solidFill>
+                  <a:srgbClr val="1A1A1C"/>
+                </a:solidFill>
+                <a:latin typeface="微软雅黑"/>
+                <a:ea typeface="微软雅黑"/>
+                <a:cs typeface="微软雅黑"/>
+              </a:rPr>
+              <a:t>消费集中度：Top10 24.2%，Top100 48.9%</a:t>
             </a:r>
           </a:p>
         </p:txBody>
@@ -39101,8 +39101,8 @@
         </p:nvSpPr>
         <p:spPr>
           <a:xfrm>
-            <a:off x="426720" y="3566160"/>
-            <a:ext cx="5364480" cy="164592"/>
+            <a:off x="426720" y="2798064"/>
+            <a:ext cx="5364480" cy="137160"/>
           </a:xfrm>
           <a:prstGeom prst="rect">
             <a:avLst/>
@@ -39121,15 +39121,15 @@
               </a:lnSpc>
             </a:pPr>
             <a:r>
-              <a:rPr sz="1050" b="1">
-                <a:solidFill>
-                  <a:srgbClr val="1A1A1C"/>
-                </a:solidFill>
-                <a:latin typeface="微软雅黑"/>
-                <a:ea typeface="微软雅黑"/>
-                <a:cs typeface="微软雅黑"/>
-              </a:rPr>
-              <a:t>付费与 API Key：全站 10.0% / 19.3%，头部结构相反</a:t>
+              <a:rPr sz="850" b="0">
+                <a:solidFill>
+                  <a:srgbClr val="8B8E94"/>
+                </a:solidFill>
+                <a:latin typeface="微软雅黑"/>
+                <a:ea typeface="微软雅黑"/>
+                <a:cs typeface="微软雅黑"/>
+              </a:rPr>
+              <a:t>Top5000 总下载 1.35 亿 · 中位 7,521</a:t>
             </a:r>
           </a:p>
         </p:txBody>
@@ -39142,8 +39142,8 @@
         </p:nvSpPr>
         <p:spPr>
           <a:xfrm>
-            <a:off x="426720" y="3730752"/>
-            <a:ext cx="5364480" cy="137160"/>
+            <a:off x="426720" y="3017520"/>
+            <a:ext cx="1463040" cy="233172"/>
           </a:xfrm>
           <a:prstGeom prst="rect">
             <a:avLst/>
@@ -39162,15 +39162,15 @@
               </a:lnSpc>
             </a:pPr>
             <a:r>
-              <a:rPr sz="850" b="0">
-                <a:solidFill>
-                  <a:srgbClr val="8B8E94"/>
-                </a:solidFill>
-                <a:latin typeface="微软雅黑"/>
-                <a:ea typeface="微软雅黑"/>
-                <a:cs typeface="微软雅黑"/>
-              </a:rPr>
-              <a:t>全站 200,403 条 · 条数占比</a:t>
+              <a:rPr sz="1600" b="1">
+                <a:solidFill>
+                  <a:srgbClr val="B5333B"/>
+                </a:solidFill>
+                <a:latin typeface="微软雅黑"/>
+                <a:ea typeface="微软雅黑"/>
+                <a:cs typeface="微软雅黑"/>
+              </a:rPr>
+              <a:t>3.9%</a:t>
             </a:r>
           </a:p>
         </p:txBody>
@@ -39183,8 +39183,8 @@
         </p:nvSpPr>
         <p:spPr>
           <a:xfrm>
-            <a:off x="426720" y="3963923"/>
-            <a:ext cx="1402080" cy="274320"/>
+            <a:off x="426720" y="3223260"/>
+            <a:ext cx="1828800" cy="137160"/>
           </a:xfrm>
           <a:prstGeom prst="rect">
             <a:avLst/>
@@ -39203,15 +39203,15 @@
               </a:lnSpc>
             </a:pPr>
             <a:r>
-              <a:rPr sz="1800" b="1">
-                <a:solidFill>
-                  <a:srgbClr val="B5333B"/>
-                </a:solidFill>
-                <a:latin typeface="微软雅黑"/>
-                <a:ea typeface="微软雅黑"/>
-                <a:cs typeface="微软雅黑"/>
-              </a:rPr>
-              <a:t>10.0%</a:t>
+              <a:rPr sz="850" b="0">
+                <a:solidFill>
+                  <a:srgbClr val="5B616B"/>
+                </a:solidFill>
+                <a:latin typeface="微软雅黑"/>
+                <a:ea typeface="微软雅黑"/>
+                <a:cs typeface="微软雅黑"/>
+              </a:rPr>
+              <a:t>Top1 占比</a:t>
             </a:r>
           </a:p>
         </p:txBody>
@@ -39224,8 +39224,8 @@
         </p:nvSpPr>
         <p:spPr>
           <a:xfrm>
-            <a:off x="426720" y="4217670"/>
-            <a:ext cx="1828800" cy="137160"/>
+            <a:off x="3108960" y="3017520"/>
+            <a:ext cx="1463040" cy="233172"/>
           </a:xfrm>
           <a:prstGeom prst="rect">
             <a:avLst/>
@@ -39244,15 +39244,15 @@
               </a:lnSpc>
             </a:pPr>
             <a:r>
-              <a:rPr sz="850" b="0">
-                <a:solidFill>
-                  <a:srgbClr val="5B616B"/>
-                </a:solidFill>
-                <a:latin typeface="微软雅黑"/>
-                <a:ea typeface="微软雅黑"/>
-                <a:cs typeface="微软雅黑"/>
-              </a:rPr>
-              <a:t>Pay Skill（20,125 条）</a:t>
+              <a:rPr sz="1600" b="1">
+                <a:solidFill>
+                  <a:srgbClr val="B5333B"/>
+                </a:solidFill>
+                <a:latin typeface="微软雅黑"/>
+                <a:ea typeface="微软雅黑"/>
+                <a:cs typeface="微软雅黑"/>
+              </a:rPr>
+              <a:t>24.2%</a:t>
             </a:r>
           </a:p>
         </p:txBody>
@@ -39265,8 +39265,8 @@
         </p:nvSpPr>
         <p:spPr>
           <a:xfrm>
-            <a:off x="2926080" y="3963923"/>
-            <a:ext cx="1402080" cy="274320"/>
+            <a:off x="3108960" y="3223260"/>
+            <a:ext cx="1828800" cy="137160"/>
           </a:xfrm>
           <a:prstGeom prst="rect">
             <a:avLst/>
@@ -39285,15 +39285,15 @@
               </a:lnSpc>
             </a:pPr>
             <a:r>
-              <a:rPr sz="1800" b="1">
-                <a:solidFill>
-                  <a:srgbClr val="B5333B"/>
-                </a:solidFill>
-                <a:latin typeface="微软雅黑"/>
-                <a:ea typeface="微软雅黑"/>
-                <a:cs typeface="微软雅黑"/>
-              </a:rPr>
-              <a:t>19.3%</a:t>
+              <a:rPr sz="850" b="0">
+                <a:solidFill>
+                  <a:srgbClr val="5B616B"/>
+                </a:solidFill>
+                <a:latin typeface="微软雅黑"/>
+                <a:ea typeface="微软雅黑"/>
+                <a:cs typeface="微软雅黑"/>
+              </a:rPr>
+              <a:t>Top10 占比</a:t>
             </a:r>
           </a:p>
         </p:txBody>
@@ -39306,8 +39306,8 @@
         </p:nvSpPr>
         <p:spPr>
           <a:xfrm>
-            <a:off x="2926080" y="4217670"/>
-            <a:ext cx="1828800" cy="137160"/>
+            <a:off x="426720" y="3429000"/>
+            <a:ext cx="1463040" cy="233172"/>
           </a:xfrm>
           <a:prstGeom prst="rect">
             <a:avLst/>
@@ -39326,15 +39326,15 @@
               </a:lnSpc>
             </a:pPr>
             <a:r>
-              <a:rPr sz="850" b="0">
-                <a:solidFill>
-                  <a:srgbClr val="5B616B"/>
-                </a:solidFill>
-                <a:latin typeface="微软雅黑"/>
-                <a:ea typeface="微软雅黑"/>
-                <a:cs typeface="微软雅黑"/>
-              </a:rPr>
-              <a:t>API Key（38,646 条）</a:t>
+              <a:rPr sz="1600" b="1">
+                <a:solidFill>
+                  <a:srgbClr val="B5333B"/>
+                </a:solidFill>
+                <a:latin typeface="微软雅黑"/>
+                <a:ea typeface="微软雅黑"/>
+                <a:cs typeface="微软雅黑"/>
+              </a:rPr>
+              <a:t>48.9%</a:t>
             </a:r>
           </a:p>
         </p:txBody>
@@ -39347,50 +39347,8 @@
         </p:nvSpPr>
         <p:spPr>
           <a:xfrm>
-            <a:off x="426720" y="4491990"/>
-            <a:ext cx="5364480" cy="582930"/>
-          </a:xfrm>
-          <a:prstGeom prst="rect">
-            <a:avLst/>
-          </a:prstGeom>
-          <a:noFill/>
-        </p:spPr>
-        <p:txBody>
-          <a:bodyPr wrap="square" lIns="0" rIns="0" tIns="0" bIns="0" anchor="t">
-            <a:spAutoFit/>
-          </a:bodyPr>
-          <a:lstStyle/>
-          <a:p>
-            <a:pPr algn="l">
-              <a:lnSpc>
-                <a:spcPct val="115000"/>
-              </a:lnSpc>
-            </a:pPr>
-            <a:r>
-              <a:rPr sz="850" b="0">
-                <a:solidFill>
-                  <a:srgbClr val="8B8E94"/>
-                </a:solidFill>
-                <a:latin typeface="微软雅黑"/>
-                <a:ea typeface="微软雅黑"/>
-                <a:cs typeface="微软雅黑"/>
-              </a:rPr>
-              <a:t>付费标签 17,123（8.5%）、支付宝 2,901（1.4%）；Pay Skill 且 API Key 331 条。
-Top1000：付费 0.9%、API Key 30.7%；Pay Skill 是多标签分类，不计入左侧 12 类。</a:t>
-            </a:r>
-          </a:p>
-        </p:txBody>
-      </p:sp>
-      <p:sp>
-        <p:nvSpPr>
-          <p:cNvPr id="54" name="TextBox 53"/>
-          <p:cNvSpPr txBox="1"/>
-          <p:nvPr/>
-        </p:nvSpPr>
-        <p:spPr>
-          <a:xfrm>
-            <a:off x="6217920" y="3566160"/>
-            <a:ext cx="5364480" cy="164592"/>
+            <a:off x="426720" y="3634740"/>
+            <a:ext cx="1828800" cy="137160"/>
           </a:xfrm>
           <a:prstGeom prst="rect">
             <a:avLst/>
@@ -39409,29 +39367,29 @@
               </a:lnSpc>
             </a:pPr>
             <a:r>
-              <a:rPr sz="1050" b="1">
-                <a:solidFill>
-                  <a:srgbClr val="1A1A1C"/>
-                </a:solidFill>
-                <a:latin typeface="微软雅黑"/>
-                <a:ea typeface="微软雅黑"/>
-                <a:cs typeface="微软雅黑"/>
-              </a:rPr>
-              <a:t>消费集中度：Top10 拿走 31.3%，Top100 拿走 63.3%</a:t>
-            </a:r>
-          </a:p>
-        </p:txBody>
-      </p:sp>
-      <p:sp>
-        <p:nvSpPr>
-          <p:cNvPr id="55" name="TextBox 54"/>
-          <p:cNvSpPr txBox="1"/>
-          <p:nvPr/>
-        </p:nvSpPr>
-        <p:spPr>
-          <a:xfrm>
-            <a:off x="6217920" y="3730752"/>
-            <a:ext cx="5364480" cy="137160"/>
+              <a:rPr sz="850" b="0">
+                <a:solidFill>
+                  <a:srgbClr val="5B616B"/>
+                </a:solidFill>
+                <a:latin typeface="微软雅黑"/>
+                <a:ea typeface="微软雅黑"/>
+                <a:cs typeface="微软雅黑"/>
+              </a:rPr>
+              <a:t>Top100 占比</a:t>
+            </a:r>
+          </a:p>
+        </p:txBody>
+      </p:sp>
+      <p:sp>
+        <p:nvSpPr>
+          <p:cNvPr id="54" name="TextBox 53"/>
+          <p:cNvSpPr txBox="1"/>
+          <p:nvPr/>
+        </p:nvSpPr>
+        <p:spPr>
+          <a:xfrm>
+            <a:off x="3108960" y="3429000"/>
+            <a:ext cx="1463040" cy="233172"/>
           </a:xfrm>
           <a:prstGeom prst="rect">
             <a:avLst/>
@@ -39450,29 +39408,29 @@
               </a:lnSpc>
             </a:pPr>
             <a:r>
-              <a:rPr sz="850" b="0">
-                <a:solidFill>
-                  <a:srgbClr val="8B8E94"/>
-                </a:solidFill>
-                <a:latin typeface="微软雅黑"/>
-                <a:ea typeface="微软雅黑"/>
-                <a:cs typeface="微软雅黑"/>
-              </a:rPr>
-              <a:t>Top1000 总下载约 1.04 亿；中位 32,907</a:t>
-            </a:r>
-          </a:p>
-        </p:txBody>
-      </p:sp>
-      <p:sp>
-        <p:nvSpPr>
-          <p:cNvPr id="56" name="TextBox 55"/>
-          <p:cNvSpPr txBox="1"/>
-          <p:nvPr/>
-        </p:nvSpPr>
-        <p:spPr>
-          <a:xfrm>
-            <a:off x="6217920" y="3963923"/>
-            <a:ext cx="1584960" cy="274320"/>
+              <a:rPr sz="1600" b="1">
+                <a:solidFill>
+                  <a:srgbClr val="B5333B"/>
+                </a:solidFill>
+                <a:latin typeface="微软雅黑"/>
+                <a:ea typeface="微软雅黑"/>
+                <a:cs typeface="微软雅黑"/>
+              </a:rPr>
+              <a:t>77.3%</a:t>
+            </a:r>
+          </a:p>
+        </p:txBody>
+      </p:sp>
+      <p:sp>
+        <p:nvSpPr>
+          <p:cNvPr id="55" name="TextBox 54"/>
+          <p:cNvSpPr txBox="1"/>
+          <p:nvPr/>
+        </p:nvSpPr>
+        <p:spPr>
+          <a:xfrm>
+            <a:off x="3108960" y="3634740"/>
+            <a:ext cx="1828800" cy="137160"/>
           </a:xfrm>
           <a:prstGeom prst="rect">
             <a:avLst/>
@@ -39491,29 +39449,29 @@
               </a:lnSpc>
             </a:pPr>
             <a:r>
-              <a:rPr sz="1800" b="1">
-                <a:solidFill>
-                  <a:srgbClr val="B5333B"/>
-                </a:solidFill>
-                <a:latin typeface="微软雅黑"/>
-                <a:ea typeface="微软雅黑"/>
-                <a:cs typeface="微软雅黑"/>
-              </a:rPr>
-              <a:t>31.3%</a:t>
-            </a:r>
-          </a:p>
-        </p:txBody>
-      </p:sp>
-      <p:sp>
-        <p:nvSpPr>
-          <p:cNvPr id="57" name="TextBox 56"/>
-          <p:cNvSpPr txBox="1"/>
-          <p:nvPr/>
-        </p:nvSpPr>
-        <p:spPr>
-          <a:xfrm>
-            <a:off x="6217920" y="4217670"/>
-            <a:ext cx="1584960" cy="233172"/>
+              <a:rPr sz="850" b="0">
+                <a:solidFill>
+                  <a:srgbClr val="5B616B"/>
+                </a:solidFill>
+                <a:latin typeface="微软雅黑"/>
+                <a:ea typeface="微软雅黑"/>
+                <a:cs typeface="微软雅黑"/>
+              </a:rPr>
+              <a:t>Top1000 占比</a:t>
+            </a:r>
+          </a:p>
+        </p:txBody>
+      </p:sp>
+      <p:sp>
+        <p:nvSpPr>
+          <p:cNvPr id="56" name="TextBox 55"/>
+          <p:cNvSpPr txBox="1"/>
+          <p:nvPr/>
+        </p:nvSpPr>
+        <p:spPr>
+          <a:xfrm>
+            <a:off x="426720" y="3874769"/>
+            <a:ext cx="5364480" cy="274320"/>
           </a:xfrm>
           <a:prstGeom prst="rect">
             <a:avLst/>
@@ -39534,27 +39492,27 @@
             <a:r>
               <a:rPr sz="850" b="0">
                 <a:solidFill>
-                  <a:srgbClr val="5B616B"/>
-                </a:solidFill>
-                <a:latin typeface="微软雅黑"/>
-                <a:ea typeface="微软雅黑"/>
-                <a:cs typeface="微软雅黑"/>
-              </a:rPr>
-              <a:t>Top10 下载占比</a:t>
-            </a:r>
-          </a:p>
-        </p:txBody>
-      </p:sp>
-      <p:sp>
-        <p:nvSpPr>
-          <p:cNvPr id="58" name="TextBox 57"/>
-          <p:cNvSpPr txBox="1"/>
-          <p:nvPr/>
-        </p:nvSpPr>
-        <p:spPr>
-          <a:xfrm>
-            <a:off x="7985760" y="3963923"/>
-            <a:ext cx="1584960" cy="274320"/>
+                  <a:srgbClr val="8B8E94"/>
+                </a:solidFill>
+                <a:latin typeface="微软雅黑"/>
+                <a:ea typeface="微软雅黑"/>
+                <a:cs typeface="微软雅黑"/>
+              </a:rPr>
+              <a:t>Top5000 中 1,519 条 installs=0；下载含 CLI / 镜像，不等于使用。</a:t>
+            </a:r>
+          </a:p>
+        </p:txBody>
+      </p:sp>
+      <p:sp>
+        <p:nvSpPr>
+          <p:cNvPr id="57" name="TextBox 56"/>
+          <p:cNvSpPr txBox="1"/>
+          <p:nvPr/>
+        </p:nvSpPr>
+        <p:spPr>
+          <a:xfrm>
+            <a:off x="6217920" y="2640330"/>
+            <a:ext cx="5364480" cy="164592"/>
           </a:xfrm>
           <a:prstGeom prst="rect">
             <a:avLst/>
@@ -39573,15 +39531,56 @@
               </a:lnSpc>
             </a:pPr>
             <a:r>
-              <a:rPr sz="1800" b="1">
-                <a:solidFill>
-                  <a:srgbClr val="B5333B"/>
-                </a:solidFill>
-                <a:latin typeface="微软雅黑"/>
-                <a:ea typeface="微软雅黑"/>
-                <a:cs typeface="微软雅黑"/>
-              </a:rPr>
-              <a:t>63.3%</a:t>
+              <a:rPr sz="1050" b="1">
+                <a:solidFill>
+                  <a:srgbClr val="1A1A1C"/>
+                </a:solidFill>
+                <a:latin typeface="微软雅黑"/>
+                <a:ea typeface="微软雅黑"/>
+                <a:cs typeface="微软雅黑"/>
+              </a:rPr>
+              <a:t>谁被下载：企业 &gt; 个人 &gt; 镜像</a:t>
+            </a:r>
+          </a:p>
+        </p:txBody>
+      </p:sp>
+      <p:sp>
+        <p:nvSpPr>
+          <p:cNvPr id="58" name="TextBox 57"/>
+          <p:cNvSpPr txBox="1"/>
+          <p:nvPr/>
+        </p:nvSpPr>
+        <p:spPr>
+          <a:xfrm>
+            <a:off x="6217920" y="2798064"/>
+            <a:ext cx="5364480" cy="137160"/>
+          </a:xfrm>
+          <a:prstGeom prst="rect">
+            <a:avLst/>
+          </a:prstGeom>
+          <a:noFill/>
+        </p:spPr>
+        <p:txBody>
+          <a:bodyPr wrap="square" lIns="0" rIns="0" tIns="0" bIns="0" anchor="t">
+            <a:spAutoFit/>
+          </a:bodyPr>
+          <a:lstStyle/>
+          <a:p>
+            <a:pPr algn="l">
+              <a:lnSpc>
+                <a:spcPct val="100000"/>
+              </a:lnSpc>
+            </a:pPr>
+            <a:r>
+              <a:rPr sz="850" b="0">
+                <a:solidFill>
+                  <a:srgbClr val="8B8E94"/>
+                </a:solidFill>
+                <a:latin typeface="微软雅黑"/>
+                <a:ea typeface="微软雅黑"/>
+                <a:cs typeface="微软雅黑"/>
+              </a:rPr>
+              <a:t>Top5000 · 单条中位下载</a:t>
             </a:r>
           </a:p>
         </p:txBody>
@@ -39594,8 +39593,530 @@
         </p:nvSpPr>
         <p:spPr>
           <a:xfrm>
-            <a:off x="7985760" y="4217670"/>
-            <a:ext cx="1584960" cy="233172"/>
+            <a:off x="6217920" y="3051810"/>
+            <a:ext cx="1158240" cy="137160"/>
+          </a:xfrm>
+          <a:prstGeom prst="rect">
+            <a:avLst/>
+          </a:prstGeom>
+          <a:noFill/>
+        </p:spPr>
+        <p:txBody>
+          <a:bodyPr wrap="square" lIns="0" rIns="0" tIns="0" bIns="0" anchor="t">
+            <a:spAutoFit/>
+          </a:bodyPr>
+          <a:lstStyle/>
+          <a:p>
+            <a:pPr algn="l">
+              <a:lnSpc>
+                <a:spcPct val="100000"/>
+              </a:lnSpc>
+            </a:pPr>
+            <a:r>
+              <a:rPr sz="950" b="0">
+                <a:solidFill>
+                  <a:srgbClr val="5B616B"/>
+                </a:solidFill>
+                <a:latin typeface="微软雅黑"/>
+                <a:ea typeface="微软雅黑"/>
+                <a:cs typeface="微软雅黑"/>
+              </a:rPr>
+              <a:t>企业</a:t>
+            </a:r>
+          </a:p>
+        </p:txBody>
+      </p:sp>
+      <p:sp>
+        <p:nvSpPr>
+          <p:cNvPr id="60" name="Rounded Rectangle 59"/>
+          <p:cNvSpPr/>
+          <p:nvPr/>
+        </p:nvSpPr>
+        <p:spPr>
+          <a:xfrm>
+            <a:off x="7498080" y="3079242"/>
+            <a:ext cx="1463040" cy="75438"/>
+          </a:xfrm>
+          <a:prstGeom prst="roundRect">
+            <a:avLst>
+              <a:gd name="adj" fmla="val 40000"/>
+            </a:avLst>
+          </a:prstGeom>
+          <a:solidFill>
+            <a:srgbClr val="EDEFF2"/>
+          </a:solidFill>
+          <a:ln>
+            <a:noFill/>
+          </a:ln>
+          <a:effectLst/>
+        </p:spPr>
+        <p:style>
+          <a:lnRef idx="1">
+            <a:schemeClr val="accent1"/>
+          </a:lnRef>
+          <a:fillRef idx="3">
+            <a:schemeClr val="accent1"/>
+          </a:fillRef>
+          <a:effectRef idx="2">
+            <a:schemeClr val="accent1"/>
+          </a:effectRef>
+          <a:fontRef idx="minor">
+            <a:schemeClr val="lt1"/>
+          </a:fontRef>
+        </p:style>
+        <p:txBody>
+          <a:bodyPr rtlCol="0" anchor="ctr"/>
+          <a:lstStyle/>
+          <a:p>
+            <a:pPr algn="ctr"/>
+          </a:p>
+        </p:txBody>
+      </p:sp>
+      <p:sp>
+        <p:nvSpPr>
+          <p:cNvPr id="61" name="Rounded Rectangle 60"/>
+          <p:cNvSpPr/>
+          <p:nvPr/>
+        </p:nvSpPr>
+        <p:spPr>
+          <a:xfrm>
+            <a:off x="7498080" y="3079242"/>
+            <a:ext cx="1463040" cy="75438"/>
+          </a:xfrm>
+          <a:prstGeom prst="roundRect">
+            <a:avLst>
+              <a:gd name="adj" fmla="val 40000"/>
+            </a:avLst>
+          </a:prstGeom>
+          <a:solidFill>
+            <a:srgbClr val="B5333B"/>
+          </a:solidFill>
+          <a:ln>
+            <a:noFill/>
+          </a:ln>
+          <a:effectLst/>
+        </p:spPr>
+        <p:style>
+          <a:lnRef idx="1">
+            <a:schemeClr val="accent1"/>
+          </a:lnRef>
+          <a:fillRef idx="3">
+            <a:schemeClr val="accent1"/>
+          </a:fillRef>
+          <a:effectRef idx="2">
+            <a:schemeClr val="accent1"/>
+          </a:effectRef>
+          <a:fontRef idx="minor">
+            <a:schemeClr val="lt1"/>
+          </a:fontRef>
+        </p:style>
+        <p:txBody>
+          <a:bodyPr rtlCol="0" anchor="ctr"/>
+          <a:lstStyle/>
+          <a:p>
+            <a:pPr algn="ctr"/>
+          </a:p>
+        </p:txBody>
+      </p:sp>
+      <p:sp>
+        <p:nvSpPr>
+          <p:cNvPr id="62" name="TextBox 61"/>
+          <p:cNvSpPr txBox="1"/>
+          <p:nvPr/>
+        </p:nvSpPr>
+        <p:spPr>
+          <a:xfrm>
+            <a:off x="9083040" y="3051810"/>
+            <a:ext cx="2255520" cy="137160"/>
+          </a:xfrm>
+          <a:prstGeom prst="rect">
+            <a:avLst/>
+          </a:prstGeom>
+          <a:noFill/>
+        </p:spPr>
+        <p:txBody>
+          <a:bodyPr wrap="square" lIns="0" rIns="0" tIns="0" bIns="0" anchor="t">
+            <a:spAutoFit/>
+          </a:bodyPr>
+          <a:lstStyle/>
+          <a:p>
+            <a:pPr algn="l">
+              <a:lnSpc>
+                <a:spcPct val="100000"/>
+              </a:lnSpc>
+            </a:pPr>
+            <a:r>
+              <a:rPr sz="850" b="0">
+                <a:solidFill>
+                  <a:srgbClr val="1A1A1C"/>
+                </a:solidFill>
+                <a:latin typeface="微软雅黑"/>
+                <a:ea typeface="微软雅黑"/>
+                <a:cs typeface="微软雅黑"/>
+              </a:rPr>
+              <a:t>12,725 / 633 条</a:t>
+            </a:r>
+          </a:p>
+        </p:txBody>
+      </p:sp>
+      <p:sp>
+        <p:nvSpPr>
+          <p:cNvPr id="63" name="TextBox 62"/>
+          <p:cNvSpPr txBox="1"/>
+          <p:nvPr/>
+        </p:nvSpPr>
+        <p:spPr>
+          <a:xfrm>
+            <a:off x="6217920" y="3429000"/>
+            <a:ext cx="1158240" cy="137160"/>
+          </a:xfrm>
+          <a:prstGeom prst="rect">
+            <a:avLst/>
+          </a:prstGeom>
+          <a:noFill/>
+        </p:spPr>
+        <p:txBody>
+          <a:bodyPr wrap="square" lIns="0" rIns="0" tIns="0" bIns="0" anchor="t">
+            <a:spAutoFit/>
+          </a:bodyPr>
+          <a:lstStyle/>
+          <a:p>
+            <a:pPr algn="l">
+              <a:lnSpc>
+                <a:spcPct val="100000"/>
+              </a:lnSpc>
+            </a:pPr>
+            <a:r>
+              <a:rPr sz="950" b="0">
+                <a:solidFill>
+                  <a:srgbClr val="5B616B"/>
+                </a:solidFill>
+                <a:latin typeface="微软雅黑"/>
+                <a:ea typeface="微软雅黑"/>
+                <a:cs typeface="微软雅黑"/>
+              </a:rPr>
+              <a:t>个人 / 社区</a:t>
+            </a:r>
+          </a:p>
+        </p:txBody>
+      </p:sp>
+      <p:sp>
+        <p:nvSpPr>
+          <p:cNvPr id="64" name="Rounded Rectangle 63"/>
+          <p:cNvSpPr/>
+          <p:nvPr/>
+        </p:nvSpPr>
+        <p:spPr>
+          <a:xfrm>
+            <a:off x="7498080" y="3456432"/>
+            <a:ext cx="1463040" cy="75438"/>
+          </a:xfrm>
+          <a:prstGeom prst="roundRect">
+            <a:avLst>
+              <a:gd name="adj" fmla="val 40000"/>
+            </a:avLst>
+          </a:prstGeom>
+          <a:solidFill>
+            <a:srgbClr val="EDEFF2"/>
+          </a:solidFill>
+          <a:ln>
+            <a:noFill/>
+          </a:ln>
+          <a:effectLst/>
+        </p:spPr>
+        <p:style>
+          <a:lnRef idx="1">
+            <a:schemeClr val="accent1"/>
+          </a:lnRef>
+          <a:fillRef idx="3">
+            <a:schemeClr val="accent1"/>
+          </a:fillRef>
+          <a:effectRef idx="2">
+            <a:schemeClr val="accent1"/>
+          </a:effectRef>
+          <a:fontRef idx="minor">
+            <a:schemeClr val="lt1"/>
+          </a:fontRef>
+        </p:style>
+        <p:txBody>
+          <a:bodyPr rtlCol="0" anchor="ctr"/>
+          <a:lstStyle/>
+          <a:p>
+            <a:pPr algn="ctr"/>
+          </a:p>
+        </p:txBody>
+      </p:sp>
+      <p:sp>
+        <p:nvSpPr>
+          <p:cNvPr id="65" name="Rounded Rectangle 64"/>
+          <p:cNvSpPr/>
+          <p:nvPr/>
+        </p:nvSpPr>
+        <p:spPr>
+          <a:xfrm>
+            <a:off x="7498080" y="3456432"/>
+            <a:ext cx="1003720" cy="75438"/>
+          </a:xfrm>
+          <a:prstGeom prst="roundRect">
+            <a:avLst>
+              <a:gd name="adj" fmla="val 40000"/>
+            </a:avLst>
+          </a:prstGeom>
+          <a:solidFill>
+            <a:srgbClr val="566472"/>
+          </a:solidFill>
+          <a:ln>
+            <a:noFill/>
+          </a:ln>
+          <a:effectLst/>
+        </p:spPr>
+        <p:style>
+          <a:lnRef idx="1">
+            <a:schemeClr val="accent1"/>
+          </a:lnRef>
+          <a:fillRef idx="3">
+            <a:schemeClr val="accent1"/>
+          </a:fillRef>
+          <a:effectRef idx="2">
+            <a:schemeClr val="accent1"/>
+          </a:effectRef>
+          <a:fontRef idx="minor">
+            <a:schemeClr val="lt1"/>
+          </a:fontRef>
+        </p:style>
+        <p:txBody>
+          <a:bodyPr rtlCol="0" anchor="ctr"/>
+          <a:lstStyle/>
+          <a:p>
+            <a:pPr algn="ctr"/>
+          </a:p>
+        </p:txBody>
+      </p:sp>
+      <p:sp>
+        <p:nvSpPr>
+          <p:cNvPr id="66" name="TextBox 65"/>
+          <p:cNvSpPr txBox="1"/>
+          <p:nvPr/>
+        </p:nvSpPr>
+        <p:spPr>
+          <a:xfrm>
+            <a:off x="9083040" y="3429000"/>
+            <a:ext cx="2255520" cy="137160"/>
+          </a:xfrm>
+          <a:prstGeom prst="rect">
+            <a:avLst/>
+          </a:prstGeom>
+          <a:noFill/>
+        </p:spPr>
+        <p:txBody>
+          <a:bodyPr wrap="square" lIns="0" rIns="0" tIns="0" bIns="0" anchor="t">
+            <a:spAutoFit/>
+          </a:bodyPr>
+          <a:lstStyle/>
+          <a:p>
+            <a:pPr algn="l">
+              <a:lnSpc>
+                <a:spcPct val="100000"/>
+              </a:lnSpc>
+            </a:pPr>
+            <a:r>
+              <a:rPr sz="850" b="0">
+                <a:solidFill>
+                  <a:srgbClr val="1A1A1C"/>
+                </a:solidFill>
+                <a:latin typeface="微软雅黑"/>
+                <a:ea typeface="微软雅黑"/>
+                <a:cs typeface="微软雅黑"/>
+              </a:rPr>
+              <a:t>8,730 / 1245 条</a:t>
+            </a:r>
+          </a:p>
+        </p:txBody>
+      </p:sp>
+      <p:sp>
+        <p:nvSpPr>
+          <p:cNvPr id="67" name="TextBox 66"/>
+          <p:cNvSpPr txBox="1"/>
+          <p:nvPr/>
+        </p:nvSpPr>
+        <p:spPr>
+          <a:xfrm>
+            <a:off x="6217920" y="3806190"/>
+            <a:ext cx="1158240" cy="137160"/>
+          </a:xfrm>
+          <a:prstGeom prst="rect">
+            <a:avLst/>
+          </a:prstGeom>
+          <a:noFill/>
+        </p:spPr>
+        <p:txBody>
+          <a:bodyPr wrap="square" lIns="0" rIns="0" tIns="0" bIns="0" anchor="t">
+            <a:spAutoFit/>
+          </a:bodyPr>
+          <a:lstStyle/>
+          <a:p>
+            <a:pPr algn="l">
+              <a:lnSpc>
+                <a:spcPct val="100000"/>
+              </a:lnSpc>
+            </a:pPr>
+            <a:r>
+              <a:rPr sz="950" b="0">
+                <a:solidFill>
+                  <a:srgbClr val="5B616B"/>
+                </a:solidFill>
+                <a:latin typeface="微软雅黑"/>
+                <a:ea typeface="微软雅黑"/>
+                <a:cs typeface="微软雅黑"/>
+              </a:rPr>
+              <a:t>镜像 ClawHub</a:t>
+            </a:r>
+          </a:p>
+        </p:txBody>
+      </p:sp>
+      <p:sp>
+        <p:nvSpPr>
+          <p:cNvPr id="68" name="Rounded Rectangle 67"/>
+          <p:cNvSpPr/>
+          <p:nvPr/>
+        </p:nvSpPr>
+        <p:spPr>
+          <a:xfrm>
+            <a:off x="7498080" y="3833622"/>
+            <a:ext cx="1463040" cy="75438"/>
+          </a:xfrm>
+          <a:prstGeom prst="roundRect">
+            <a:avLst>
+              <a:gd name="adj" fmla="val 40000"/>
+            </a:avLst>
+          </a:prstGeom>
+          <a:solidFill>
+            <a:srgbClr val="EDEFF2"/>
+          </a:solidFill>
+          <a:ln>
+            <a:noFill/>
+          </a:ln>
+          <a:effectLst/>
+        </p:spPr>
+        <p:style>
+          <a:lnRef idx="1">
+            <a:schemeClr val="accent1"/>
+          </a:lnRef>
+          <a:fillRef idx="3">
+            <a:schemeClr val="accent1"/>
+          </a:fillRef>
+          <a:effectRef idx="2">
+            <a:schemeClr val="accent1"/>
+          </a:effectRef>
+          <a:fontRef idx="minor">
+            <a:schemeClr val="lt1"/>
+          </a:fontRef>
+        </p:style>
+        <p:txBody>
+          <a:bodyPr rtlCol="0" anchor="ctr"/>
+          <a:lstStyle/>
+          <a:p>
+            <a:pPr algn="ctr"/>
+          </a:p>
+        </p:txBody>
+      </p:sp>
+      <p:sp>
+        <p:nvSpPr>
+          <p:cNvPr id="69" name="Rounded Rectangle 68"/>
+          <p:cNvSpPr/>
+          <p:nvPr/>
+        </p:nvSpPr>
+        <p:spPr>
+          <a:xfrm>
+            <a:off x="7498080" y="3833622"/>
+            <a:ext cx="776762" cy="75438"/>
+          </a:xfrm>
+          <a:prstGeom prst="roundRect">
+            <a:avLst>
+              <a:gd name="adj" fmla="val 40000"/>
+            </a:avLst>
+          </a:prstGeom>
+          <a:solidFill>
+            <a:srgbClr val="CFD4DA"/>
+          </a:solidFill>
+          <a:ln>
+            <a:noFill/>
+          </a:ln>
+          <a:effectLst/>
+        </p:spPr>
+        <p:style>
+          <a:lnRef idx="1">
+            <a:schemeClr val="accent1"/>
+          </a:lnRef>
+          <a:fillRef idx="3">
+            <a:schemeClr val="accent1"/>
+          </a:fillRef>
+          <a:effectRef idx="2">
+            <a:schemeClr val="accent1"/>
+          </a:effectRef>
+          <a:fontRef idx="minor">
+            <a:schemeClr val="lt1"/>
+          </a:fontRef>
+        </p:style>
+        <p:txBody>
+          <a:bodyPr rtlCol="0" anchor="ctr"/>
+          <a:lstStyle/>
+          <a:p>
+            <a:pPr algn="ctr"/>
+          </a:p>
+        </p:txBody>
+      </p:sp>
+      <p:sp>
+        <p:nvSpPr>
+          <p:cNvPr id="70" name="TextBox 69"/>
+          <p:cNvSpPr txBox="1"/>
+          <p:nvPr/>
+        </p:nvSpPr>
+        <p:spPr>
+          <a:xfrm>
+            <a:off x="9083040" y="3806190"/>
+            <a:ext cx="2255520" cy="137160"/>
+          </a:xfrm>
+          <a:prstGeom prst="rect">
+            <a:avLst/>
+          </a:prstGeom>
+          <a:noFill/>
+        </p:spPr>
+        <p:txBody>
+          <a:bodyPr wrap="square" lIns="0" rIns="0" tIns="0" bIns="0" anchor="t">
+            <a:spAutoFit/>
+          </a:bodyPr>
+          <a:lstStyle/>
+          <a:p>
+            <a:pPr algn="l">
+              <a:lnSpc>
+                <a:spcPct val="100000"/>
+              </a:lnSpc>
+            </a:pPr>
+            <a:r>
+              <a:rPr sz="850" b="0">
+                <a:solidFill>
+                  <a:srgbClr val="1A1A1C"/>
+                </a:solidFill>
+                <a:latin typeface="微软雅黑"/>
+                <a:ea typeface="微软雅黑"/>
+                <a:cs typeface="微软雅黑"/>
+              </a:rPr>
+              <a:t>6,756 / 3122 条</a:t>
+            </a:r>
+          </a:p>
+        </p:txBody>
+      </p:sp>
+      <p:sp>
+        <p:nvSpPr>
+          <p:cNvPr id="71" name="TextBox 70"/>
+          <p:cNvSpPr txBox="1"/>
+          <p:nvPr/>
+        </p:nvSpPr>
+        <p:spPr>
+          <a:xfrm>
+            <a:off x="6217920" y="4046220"/>
+            <a:ext cx="5364480" cy="219456"/>
           </a:xfrm>
           <a:prstGeom prst="rect">
             <a:avLst/>
@@ -39616,27 +40137,27 @@
             <a:r>
               <a:rPr sz="850" b="0">
                 <a:solidFill>
-                  <a:srgbClr val="5B616B"/>
-                </a:solidFill>
-                <a:latin typeface="微软雅黑"/>
-                <a:ea typeface="微软雅黑"/>
-                <a:cs typeface="微软雅黑"/>
-              </a:rPr>
-              <a:t>Top100 下载占比</a:t>
-            </a:r>
-          </a:p>
-        </p:txBody>
-      </p:sp>
-      <p:sp>
-        <p:nvSpPr>
-          <p:cNvPr id="60" name="TextBox 59"/>
-          <p:cNvSpPr txBox="1"/>
-          <p:nvPr/>
-        </p:nvSpPr>
-        <p:spPr>
-          <a:xfrm>
-            <a:off x="9753600" y="3963923"/>
-            <a:ext cx="1584960" cy="274320"/>
+                  <a:srgbClr val="8B8E94"/>
+                </a:solidFill>
+                <a:latin typeface="微软雅黑"/>
+                <a:ea typeface="微软雅黑"/>
+                <a:cs typeface="微软雅黑"/>
+              </a:rPr>
+              <a:t>Top5000 整体中位 7,521；企业单条最高，个人高于镜像。2,883 个上架方，Top10 占 37.9% 下载。</a:t>
+            </a:r>
+          </a:p>
+        </p:txBody>
+      </p:sp>
+      <p:sp>
+        <p:nvSpPr>
+          <p:cNvPr id="72" name="TextBox 71"/>
+          <p:cNvSpPr txBox="1"/>
+          <p:nvPr/>
+        </p:nvSpPr>
+        <p:spPr>
+          <a:xfrm>
+            <a:off x="426720" y="4354830"/>
+            <a:ext cx="10972800" cy="164592"/>
           </a:xfrm>
           <a:prstGeom prst="rect">
             <a:avLst/>
@@ -39655,29 +40176,29 @@
               </a:lnSpc>
             </a:pPr>
             <a:r>
-              <a:rPr sz="1800" b="1">
-                <a:solidFill>
-                  <a:srgbClr val="B5333B"/>
-                </a:solidFill>
-                <a:latin typeface="微软雅黑"/>
-                <a:ea typeface="微软雅黑"/>
-                <a:cs typeface="微软雅黑"/>
-              </a:rPr>
-              <a:t>443</a:t>
-            </a:r>
-          </a:p>
-        </p:txBody>
-      </p:sp>
-      <p:sp>
-        <p:nvSpPr>
-          <p:cNvPr id="61" name="TextBox 60"/>
-          <p:cNvSpPr txBox="1"/>
-          <p:nvPr/>
-        </p:nvSpPr>
-        <p:spPr>
-          <a:xfrm>
-            <a:off x="9753600" y="4217670"/>
-            <a:ext cx="1584960" cy="233172"/>
+              <a:rPr sz="1050" b="1">
+                <a:solidFill>
+                  <a:srgbClr val="1A1A1C"/>
+                </a:solidFill>
+                <a:latin typeface="微软雅黑"/>
+                <a:ea typeface="微软雅黑"/>
+                <a:cs typeface="微软雅黑"/>
+              </a:rPr>
+              <a:t>付费与 API Key：全站 10.0% / 19.3%，Top5000 付费仅 1.0%</a:t>
+            </a:r>
+          </a:p>
+        </p:txBody>
+      </p:sp>
+      <p:sp>
+        <p:nvSpPr>
+          <p:cNvPr id="73" name="TextBox 72"/>
+          <p:cNvSpPr txBox="1"/>
+          <p:nvPr/>
+        </p:nvSpPr>
+        <p:spPr>
+          <a:xfrm>
+            <a:off x="426720" y="4512564"/>
+            <a:ext cx="10972800" cy="137160"/>
           </a:xfrm>
           <a:prstGeom prst="rect">
             <a:avLst/>
@@ -39692,33 +40213,197 @@
           <a:p>
             <a:pPr algn="l">
               <a:lnSpc>
-                <a:spcPct val="105000"/>
+                <a:spcPct val="100000"/>
               </a:lnSpc>
             </a:pPr>
             <a:r>
               <a:rPr sz="850" b="0">
                 <a:solidFill>
+                  <a:srgbClr val="8B8E94"/>
+                </a:solidFill>
+                <a:latin typeface="微软雅黑"/>
+                <a:ea typeface="微软雅黑"/>
+                <a:cs typeface="微软雅黑"/>
+              </a:rPr>
+              <a:t>全站 200,403 条；Pay Skill 20,125、API Key 38,646</a:t>
+            </a:r>
+          </a:p>
+        </p:txBody>
+      </p:sp>
+      <p:sp>
+        <p:nvSpPr>
+          <p:cNvPr id="74" name="TextBox 73"/>
+          <p:cNvSpPr txBox="1"/>
+          <p:nvPr/>
+        </p:nvSpPr>
+        <p:spPr>
+          <a:xfrm>
+            <a:off x="426720" y="4677156"/>
+            <a:ext cx="1097280" cy="246887"/>
+          </a:xfrm>
+          <a:prstGeom prst="rect">
+            <a:avLst/>
+          </a:prstGeom>
+          <a:noFill/>
+        </p:spPr>
+        <p:txBody>
+          <a:bodyPr wrap="square" lIns="0" rIns="0" tIns="0" bIns="0" anchor="t">
+            <a:spAutoFit/>
+          </a:bodyPr>
+          <a:lstStyle/>
+          <a:p>
+            <a:pPr algn="l">
+              <a:lnSpc>
+                <a:spcPct val="100000"/>
+              </a:lnSpc>
+            </a:pPr>
+            <a:r>
+              <a:rPr sz="1600" b="1">
+                <a:solidFill>
+                  <a:srgbClr val="B5333B"/>
+                </a:solidFill>
+                <a:latin typeface="微软雅黑"/>
+                <a:ea typeface="微软雅黑"/>
+                <a:cs typeface="微软雅黑"/>
+              </a:rPr>
+              <a:t>10.0%</a:t>
+            </a:r>
+          </a:p>
+        </p:txBody>
+      </p:sp>
+      <p:sp>
+        <p:nvSpPr>
+          <p:cNvPr id="75" name="TextBox 74"/>
+          <p:cNvSpPr txBox="1"/>
+          <p:nvPr/>
+        </p:nvSpPr>
+        <p:spPr>
+          <a:xfrm>
+            <a:off x="426720" y="4910328"/>
+            <a:ext cx="1584960" cy="137160"/>
+          </a:xfrm>
+          <a:prstGeom prst="rect">
+            <a:avLst/>
+          </a:prstGeom>
+          <a:noFill/>
+        </p:spPr>
+        <p:txBody>
+          <a:bodyPr wrap="square" lIns="0" rIns="0" tIns="0" bIns="0" anchor="t">
+            <a:spAutoFit/>
+          </a:bodyPr>
+          <a:lstStyle/>
+          <a:p>
+            <a:pPr algn="l">
+              <a:lnSpc>
+                <a:spcPct val="100000"/>
+              </a:lnSpc>
+            </a:pPr>
+            <a:r>
+              <a:rPr sz="850" b="0">
+                <a:solidFill>
                   <a:srgbClr val="5B616B"/>
                 </a:solidFill>
                 <a:latin typeface="微软雅黑"/>
                 <a:ea typeface="微软雅黑"/>
                 <a:cs typeface="微软雅黑"/>
               </a:rPr>
-              <a:t>installs=0 的条数</a:t>
-            </a:r>
-          </a:p>
-        </p:txBody>
-      </p:sp>
-      <p:sp>
-        <p:nvSpPr>
-          <p:cNvPr id="62" name="TextBox 61"/>
-          <p:cNvSpPr txBox="1"/>
-          <p:nvPr/>
-        </p:nvSpPr>
-        <p:spPr>
-          <a:xfrm>
-            <a:off x="6217920" y="4560570"/>
-            <a:ext cx="5364480" cy="411480"/>
+              <a:t>Pay Skill</a:t>
+            </a:r>
+          </a:p>
+        </p:txBody>
+      </p:sp>
+      <p:sp>
+        <p:nvSpPr>
+          <p:cNvPr id="76" name="TextBox 75"/>
+          <p:cNvSpPr txBox="1"/>
+          <p:nvPr/>
+        </p:nvSpPr>
+        <p:spPr>
+          <a:xfrm>
+            <a:off x="2194560" y="4677156"/>
+            <a:ext cx="1097280" cy="246887"/>
+          </a:xfrm>
+          <a:prstGeom prst="rect">
+            <a:avLst/>
+          </a:prstGeom>
+          <a:noFill/>
+        </p:spPr>
+        <p:txBody>
+          <a:bodyPr wrap="square" lIns="0" rIns="0" tIns="0" bIns="0" anchor="t">
+            <a:spAutoFit/>
+          </a:bodyPr>
+          <a:lstStyle/>
+          <a:p>
+            <a:pPr algn="l">
+              <a:lnSpc>
+                <a:spcPct val="100000"/>
+              </a:lnSpc>
+            </a:pPr>
+            <a:r>
+              <a:rPr sz="1600" b="1">
+                <a:solidFill>
+                  <a:srgbClr val="B5333B"/>
+                </a:solidFill>
+                <a:latin typeface="微软雅黑"/>
+                <a:ea typeface="微软雅黑"/>
+                <a:cs typeface="微软雅黑"/>
+              </a:rPr>
+              <a:t>19.3%</a:t>
+            </a:r>
+          </a:p>
+        </p:txBody>
+      </p:sp>
+      <p:sp>
+        <p:nvSpPr>
+          <p:cNvPr id="77" name="TextBox 76"/>
+          <p:cNvSpPr txBox="1"/>
+          <p:nvPr/>
+        </p:nvSpPr>
+        <p:spPr>
+          <a:xfrm>
+            <a:off x="2194560" y="4910328"/>
+            <a:ext cx="1584960" cy="137160"/>
+          </a:xfrm>
+          <a:prstGeom prst="rect">
+            <a:avLst/>
+          </a:prstGeom>
+          <a:noFill/>
+        </p:spPr>
+        <p:txBody>
+          <a:bodyPr wrap="square" lIns="0" rIns="0" tIns="0" bIns="0" anchor="t">
+            <a:spAutoFit/>
+          </a:bodyPr>
+          <a:lstStyle/>
+          <a:p>
+            <a:pPr algn="l">
+              <a:lnSpc>
+                <a:spcPct val="100000"/>
+              </a:lnSpc>
+            </a:pPr>
+            <a:r>
+              <a:rPr sz="850" b="0">
+                <a:solidFill>
+                  <a:srgbClr val="5B616B"/>
+                </a:solidFill>
+                <a:latin typeface="微软雅黑"/>
+                <a:ea typeface="微软雅黑"/>
+                <a:cs typeface="微软雅黑"/>
+              </a:rPr>
+              <a:t>API Key</a:t>
+            </a:r>
+          </a:p>
+        </p:txBody>
+      </p:sp>
+      <p:sp>
+        <p:nvSpPr>
+          <p:cNvPr id="78" name="TextBox 77"/>
+          <p:cNvSpPr txBox="1"/>
+          <p:nvPr/>
+        </p:nvSpPr>
+        <p:spPr>
+          <a:xfrm>
+            <a:off x="4267200" y="4677156"/>
+            <a:ext cx="7315200" cy="411480"/>
           </a:xfrm>
           <a:prstGeom prst="rect">
             <a:avLst/>
@@ -39745,20 +40430,21 @@
                 <a:ea typeface="微软雅黑"/>
                 <a:cs typeface="微软雅黑"/>
               </a:rPr>
-              <a:t>Top1 占 5.0%，Top3 占 14.7%；下载含 CLI/镜像拉取，不等于安装或使用。</a:t>
-            </a:r>
-          </a:p>
-        </p:txBody>
-      </p:sp>
-      <p:sp>
-        <p:nvSpPr>
-          <p:cNvPr id="63" name="TextBox 62"/>
-          <p:cNvSpPr txBox="1"/>
-          <p:nvPr/>
-        </p:nvSpPr>
-        <p:spPr>
-          <a:xfrm>
-            <a:off x="426720" y="5863590"/>
+              <a:t>付费标签 17,123（8.5%）、支付宝 2,901（1.4%）；Pay Skill 且 API Key 331 条。
+Top5000：付费 1.0%（50 条）、API Key 28.8%；Pay Skill 分类 0 条。</a:t>
+            </a:r>
+          </a:p>
+        </p:txBody>
+      </p:sp>
+      <p:sp>
+        <p:nvSpPr>
+          <p:cNvPr id="79" name="TextBox 78"/>
+          <p:cNvSpPr txBox="1"/>
+          <p:nvPr/>
+        </p:nvSpPr>
+        <p:spPr>
+          <a:xfrm>
+            <a:off x="426720" y="5795010"/>
             <a:ext cx="11338560" cy="192024"/>
           </a:xfrm>
           <a:prstGeom prst="rect">
@@ -39786,7 +40472,7 @@
                 <a:ea typeface="微软雅黑"/>
                 <a:cs typeface="微软雅黑"/>
               </a:rPr>
-              <a:t>读法：全站付费 10%、API Key 19%，但头部下载集中在编程；Top1000 付费标签只有 0.9%。</a:t>
+              <a:t>读法：Top5000 由 2,883 个上架方供给，Top10 拿走 37.9% 下载；全站付费 10%，但头部只有 1%。</a:t>
             </a:r>
           </a:p>
         </p:txBody>

</xml_diff>

<commit_message>
Use full-site supply counts for SkillHub ecosystem
</commit_message>
<xml_diff>
--- a/skill-final-v1.pptx
+++ b/skill-final-v1.pptx
@@ -37193,7 +37193,7 @@
                 <a:ea typeface="微软雅黑"/>
                 <a:cs typeface="微软雅黑"/>
               </a:rPr>
-              <a:t>SkillHub 生态画像：Top5000 里，个人 24.9%、企业 12.7%、镜像 62.4%</a:t>
+              <a:t>SkillHub 生态画像：全站社区 68.4%、ClawHub 31.6%，企业是交叉标签</a:t>
             </a:r>
           </a:p>
         </p:txBody>
@@ -37234,7 +37234,7 @@
                 <a:ea typeface="微软雅黑"/>
                 <a:cs typeface="微软雅黑"/>
               </a:rPr>
-              <a:t>镜像撑数量，个人下载份额最高，企业单条最强；全站付费 10%，头部只有 1%。</a:t>
+              <a:t>全站社区 + ClawHub 覆盖全站，企业 34.9% 叠加；Top5000 里个人下载份额最高，企业单条最强。</a:t>
             </a:r>
           </a:p>
         </p:txBody>
@@ -37275,7 +37275,7 @@
                 <a:ea typeface="微软雅黑"/>
                 <a:cs typeface="微软雅黑"/>
               </a:rPr>
-              <a:t>三种上架方：镜像最多，个人最重，企业最强</a:t>
+              <a:t>谁在供给：社区 13.7 万，ClawHub 6.3 万，企业 7.0 万</a:t>
             </a:r>
           </a:p>
         </p:txBody>
@@ -37316,7 +37316,7 @@
                 <a:ea typeface="微软雅黑"/>
                 <a:cs typeface="微软雅黑"/>
               </a:rPr>
-              <a:t>Top5000 条 · 数量 / 下载</a:t>
+              <a:t>全站 200,419 条 · 来源计数（可重叠）</a:t>
             </a:r>
           </a:p>
         </p:txBody>
@@ -37330,7 +37330,7 @@
         <p:spPr>
           <a:xfrm>
             <a:off x="426720" y="1371600"/>
-            <a:ext cx="1036320" cy="137160"/>
+            <a:ext cx="1158240" cy="137160"/>
           </a:xfrm>
           <a:prstGeom prst="rect">
             <a:avLst/>
@@ -37357,7 +37357,7 @@
                 <a:ea typeface="微软雅黑"/>
                 <a:cs typeface="微软雅黑"/>
               </a:rPr>
-              <a:t>个人 / 社区</a:t>
+              <a:t>社区</a:t>
             </a:r>
           </a:p>
         </p:txBody>
@@ -37370,8 +37370,8 @@
         </p:nvSpPr>
         <p:spPr>
           <a:xfrm>
-            <a:off x="1524000" y="1399032"/>
-            <a:ext cx="1828800" cy="68580"/>
+            <a:off x="1609344" y="1399032"/>
+            <a:ext cx="1767839" cy="68580"/>
           </a:xfrm>
           <a:prstGeom prst="roundRect">
             <a:avLst>
@@ -37416,8 +37416,8 @@
         </p:nvSpPr>
         <p:spPr>
           <a:xfrm>
-            <a:off x="1524000" y="1399032"/>
-            <a:ext cx="729761" cy="68580"/>
+            <a:off x="1609344" y="1399032"/>
+            <a:ext cx="1767839" cy="68580"/>
           </a:xfrm>
           <a:prstGeom prst="roundRect">
             <a:avLst>
@@ -37462,8 +37462,8 @@
         </p:nvSpPr>
         <p:spPr>
           <a:xfrm>
-            <a:off x="3560064" y="1371600"/>
-            <a:ext cx="1950720" cy="137160"/>
+            <a:off x="3511295" y="1371600"/>
+            <a:ext cx="2011680" cy="137160"/>
           </a:xfrm>
           <a:prstGeom prst="rect">
             <a:avLst/>
@@ -37490,7 +37490,7 @@
                 <a:ea typeface="微软雅黑"/>
                 <a:cs typeface="微软雅黑"/>
               </a:rPr>
-              <a:t>24.9% / 39.8%</a:t>
+              <a:t>137,017 / 68.4%</a:t>
             </a:r>
           </a:p>
         </p:txBody>
@@ -37504,7 +37504,7 @@
         <p:spPr>
           <a:xfrm>
             <a:off x="426720" y="1577340"/>
-            <a:ext cx="1036320" cy="137160"/>
+            <a:ext cx="1158240" cy="137160"/>
           </a:xfrm>
           <a:prstGeom prst="rect">
             <a:avLst/>
@@ -37531,7 +37531,7 @@
                 <a:ea typeface="微软雅黑"/>
                 <a:cs typeface="微软雅黑"/>
               </a:rPr>
-              <a:t>企业</a:t>
+              <a:t>ClawHub</a:t>
             </a:r>
           </a:p>
         </p:txBody>
@@ -37544,8 +37544,8 @@
         </p:nvSpPr>
         <p:spPr>
           <a:xfrm>
-            <a:off x="1524000" y="1604772"/>
-            <a:ext cx="1828800" cy="68580"/>
+            <a:off x="1609344" y="1604772"/>
+            <a:ext cx="1767839" cy="68580"/>
           </a:xfrm>
           <a:prstGeom prst="roundRect">
             <a:avLst>
@@ -37590,8 +37590,8 @@
         </p:nvSpPr>
         <p:spPr>
           <a:xfrm>
-            <a:off x="1524000" y="1604772"/>
-            <a:ext cx="372207" cy="68580"/>
+            <a:off x="1609344" y="1604772"/>
+            <a:ext cx="816721" cy="68580"/>
           </a:xfrm>
           <a:prstGeom prst="roundRect">
             <a:avLst>
@@ -37636,8 +37636,8 @@
         </p:nvSpPr>
         <p:spPr>
           <a:xfrm>
-            <a:off x="3560064" y="1577340"/>
-            <a:ext cx="1950720" cy="137160"/>
+            <a:off x="3511295" y="1577340"/>
+            <a:ext cx="2011680" cy="137160"/>
           </a:xfrm>
           <a:prstGeom prst="rect">
             <a:avLst/>
@@ -37664,7 +37664,7 @@
                 <a:ea typeface="微软雅黑"/>
                 <a:cs typeface="微软雅黑"/>
               </a:rPr>
-              <a:t>12.7% / 24.7%</a:t>
+              <a:t>63,402 / 31.6%</a:t>
             </a:r>
           </a:p>
         </p:txBody>
@@ -37678,7 +37678,7 @@
         <p:spPr>
           <a:xfrm>
             <a:off x="426720" y="1783080"/>
-            <a:ext cx="1036320" cy="137160"/>
+            <a:ext cx="1158240" cy="137160"/>
           </a:xfrm>
           <a:prstGeom prst="rect">
             <a:avLst/>
@@ -37705,7 +37705,7 @@
                 <a:ea typeface="微软雅黑"/>
                 <a:cs typeface="微软雅黑"/>
               </a:rPr>
-              <a:t>镜像 ClawHub</a:t>
+              <a:t>企业（交叉）</a:t>
             </a:r>
           </a:p>
         </p:txBody>
@@ -37718,8 +37718,8 @@
         </p:nvSpPr>
         <p:spPr>
           <a:xfrm>
-            <a:off x="1524000" y="1810512"/>
-            <a:ext cx="1828800" cy="68580"/>
+            <a:off x="1609344" y="1810512"/>
+            <a:ext cx="1767839" cy="68580"/>
           </a:xfrm>
           <a:prstGeom prst="roundRect">
             <a:avLst>
@@ -37764,8 +37764,8 @@
         </p:nvSpPr>
         <p:spPr>
           <a:xfrm>
-            <a:off x="1524000" y="1810512"/>
-            <a:ext cx="1828800" cy="68580"/>
+            <a:off x="1609344" y="1810512"/>
+            <a:ext cx="902011" cy="68580"/>
           </a:xfrm>
           <a:prstGeom prst="roundRect">
             <a:avLst>
@@ -37810,8 +37810,8 @@
         </p:nvSpPr>
         <p:spPr>
           <a:xfrm>
-            <a:off x="3560064" y="1783080"/>
-            <a:ext cx="1950720" cy="137160"/>
+            <a:off x="3511295" y="1783080"/>
+            <a:ext cx="2011680" cy="137160"/>
           </a:xfrm>
           <a:prstGeom prst="rect">
             <a:avLst/>
@@ -37838,7 +37838,7 @@
                 <a:ea typeface="微软雅黑"/>
                 <a:cs typeface="微软雅黑"/>
               </a:rPr>
-              <a:t>62.4% / 35.5%</a:t>
+              <a:t>69,938 / 34.9%</a:t>
             </a:r>
           </a:p>
         </p:txBody>
@@ -37879,8 +37879,8 @@
                 <a:ea typeface="微软雅黑"/>
                 <a:cs typeface="微软雅黑"/>
               </a:rPr>
-              <a:t>个人条数少、下载高；镜像条数最多；企业单条最强见右图。
-个人 1,245 条 / 企业 633 条 / 镜像 3,122 条。</a:t>
+              <a:t>社区 + ClawHub = 200,419，正好覆盖全站；
+企业是叠加在两者上的交叉标签，三者不能相加。</a:t>
             </a:r>
           </a:p>
         </p:txBody>
@@ -40472,7 +40472,7 @@
                 <a:ea typeface="微软雅黑"/>
                 <a:cs typeface="微软雅黑"/>
               </a:rPr>
-              <a:t>读法：Top5000 由 2,883 个上架方供给，Top10 拿走 37.9% 下载；全站付费 10%，但头部只有 1%。</a:t>
+              <a:t>读法：全站社区 + ClawHub 覆盖全站，企业 34.9% 是叠加；Top5000 里企业单条最强，付费只有 1%。</a:t>
             </a:r>
           </a:p>
         </p:txBody>

</xml_diff>

<commit_message>
Add free, Payskill, and API Key top six to SkillHub page
</commit_message>
<xml_diff>
--- a/skill-final-v1.pptx
+++ b/skill-final-v1.pptx
@@ -44131,8 +44131,8 @@
         </p:nvSpPr>
         <p:spPr>
           <a:xfrm>
-            <a:off x="426720" y="4354830"/>
-            <a:ext cx="10972800" cy="164592"/>
+            <a:off x="426720" y="4320540"/>
+            <a:ext cx="11338560" cy="137160"/>
           </a:xfrm>
           <a:prstGeom prst="rect">
             <a:avLst/>
@@ -44159,7 +44159,7 @@
                 <a:ea typeface="微软雅黑"/>
                 <a:cs typeface="微软雅黑"/>
               </a:rPr>
-              <a:t>付费与 API Key：全站 10.0% / 19.3%，Top10000 付费仅 0.7%</a:t>
+              <a:t>Top6 下载：免费 / Payskill / API Key</a:t>
             </a:r>
           </a:p>
         </p:txBody>
@@ -44172,8 +44172,8 @@
         </p:nvSpPr>
         <p:spPr>
           <a:xfrm>
-            <a:off x="426720" y="4512564"/>
-            <a:ext cx="10972800" cy="137160"/>
+            <a:off x="426720" y="4485132"/>
+            <a:ext cx="11338560" cy="89154"/>
           </a:xfrm>
           <a:prstGeom prst="rect">
             <a:avLst/>
@@ -44192,7 +44192,7 @@
               </a:lnSpc>
             </a:pPr>
             <a:r>
-              <a:rPr sz="850" b="0">
+              <a:rPr sz="720" b="0">
                 <a:solidFill>
                   <a:srgbClr val="8B8E94"/>
                 </a:solidFill>
@@ -44200,7 +44200,7 @@
                 <a:ea typeface="微软雅黑"/>
                 <a:cs typeface="微软雅黑"/>
               </a:rPr>
-              <a:t>全站 200,403 条；Pay Skill 20,125、API Key 38,646</a:t>
+              <a:t>Top10000 内：免费 6,908 / Payskill 68 / API Key 3,030；Payskill 与 API Key 可重叠</a:t>
             </a:r>
           </a:p>
         </p:txBody>
@@ -44213,8 +44213,8 @@
         </p:nvSpPr>
         <p:spPr>
           <a:xfrm>
-            <a:off x="426720" y="4677156"/>
-            <a:ext cx="1097280" cy="246887"/>
+            <a:off x="426720" y="4594860"/>
+            <a:ext cx="3535679" cy="96012"/>
           </a:xfrm>
           <a:prstGeom prst="rect">
             <a:avLst/>
@@ -44233,7 +44233,7 @@
               </a:lnSpc>
             </a:pPr>
             <a:r>
-              <a:rPr sz="1600" b="1">
+              <a:rPr sz="860" b="1">
                 <a:solidFill>
                   <a:srgbClr val="B5333B"/>
                 </a:solidFill>
@@ -44241,21 +44241,65 @@
                 <a:ea typeface="微软雅黑"/>
                 <a:cs typeface="微软雅黑"/>
               </a:rPr>
-              <a:t>10.0%</a:t>
-            </a:r>
-          </a:p>
-        </p:txBody>
-      </p:sp>
-      <p:sp>
-        <p:nvSpPr>
-          <p:cNvPr id="75" name="TextBox 74"/>
-          <p:cNvSpPr txBox="1"/>
-          <p:nvPr/>
-        </p:nvSpPr>
-        <p:spPr>
-          <a:xfrm>
-            <a:off x="426720" y="4910328"/>
-            <a:ext cx="1584960" cy="137160"/>
+              <a:t>免费 Top6</a:t>
+            </a:r>
+          </a:p>
+        </p:txBody>
+      </p:sp>
+      <p:sp>
+        <p:nvSpPr>
+          <p:cNvPr id="75" name="Rectangle 74"/>
+          <p:cNvSpPr/>
+          <p:nvPr/>
+        </p:nvSpPr>
+        <p:spPr>
+          <a:xfrm>
+            <a:off x="426720" y="4690872"/>
+            <a:ext cx="3535679" cy="5486"/>
+          </a:xfrm>
+          <a:prstGeom prst="rect">
+            <a:avLst/>
+          </a:prstGeom>
+          <a:solidFill>
+            <a:srgbClr val="E2E4E7"/>
+          </a:solidFill>
+          <a:ln>
+            <a:noFill/>
+          </a:ln>
+          <a:effectLst/>
+        </p:spPr>
+        <p:style>
+          <a:lnRef idx="1">
+            <a:schemeClr val="accent1"/>
+          </a:lnRef>
+          <a:fillRef idx="3">
+            <a:schemeClr val="accent1"/>
+          </a:fillRef>
+          <a:effectRef idx="2">
+            <a:schemeClr val="accent1"/>
+          </a:effectRef>
+          <a:fontRef idx="minor">
+            <a:schemeClr val="lt1"/>
+          </a:fontRef>
+        </p:style>
+        <p:txBody>
+          <a:bodyPr rtlCol="0" anchor="ctr"/>
+          <a:lstStyle/>
+          <a:p>
+            <a:pPr algn="ctr"/>
+          </a:p>
+        </p:txBody>
+      </p:sp>
+      <p:sp>
+        <p:nvSpPr>
+          <p:cNvPr id="76" name="TextBox 75"/>
+          <p:cNvSpPr txBox="1"/>
+          <p:nvPr/>
+        </p:nvSpPr>
+        <p:spPr>
+          <a:xfrm>
+            <a:off x="426720" y="4718304"/>
+            <a:ext cx="170688" cy="75438"/>
           </a:xfrm>
           <a:prstGeom prst="rect">
             <a:avLst/>
@@ -44274,29 +44318,29 @@
               </a:lnSpc>
             </a:pPr>
             <a:r>
-              <a:rPr sz="850" b="0">
-                <a:solidFill>
-                  <a:srgbClr val="5B616B"/>
-                </a:solidFill>
-                <a:latin typeface="微软雅黑"/>
-                <a:ea typeface="微软雅黑"/>
-                <a:cs typeface="微软雅黑"/>
-              </a:rPr>
-              <a:t>Pay Skill</a:t>
-            </a:r>
-          </a:p>
-        </p:txBody>
-      </p:sp>
-      <p:sp>
-        <p:nvSpPr>
-          <p:cNvPr id="76" name="TextBox 75"/>
-          <p:cNvSpPr txBox="1"/>
-          <p:nvPr/>
-        </p:nvSpPr>
-        <p:spPr>
-          <a:xfrm>
-            <a:off x="2194560" y="4677156"/>
-            <a:ext cx="1097280" cy="246887"/>
+              <a:rPr sz="740" b="1">
+                <a:solidFill>
+                  <a:srgbClr val="B5333B"/>
+                </a:solidFill>
+                <a:latin typeface="微软雅黑"/>
+                <a:ea typeface="微软雅黑"/>
+                <a:cs typeface="微软雅黑"/>
+              </a:rPr>
+              <a:t>1</a:t>
+            </a:r>
+          </a:p>
+        </p:txBody>
+      </p:sp>
+      <p:sp>
+        <p:nvSpPr>
+          <p:cNvPr id="77" name="TextBox 76"/>
+          <p:cNvSpPr txBox="1"/>
+          <p:nvPr/>
+        </p:nvSpPr>
+        <p:spPr>
+          <a:xfrm>
+            <a:off x="621792" y="4718304"/>
+            <a:ext cx="2621280" cy="75438"/>
           </a:xfrm>
           <a:prstGeom prst="rect">
             <a:avLst/>
@@ -44315,29 +44359,70 @@
               </a:lnSpc>
             </a:pPr>
             <a:r>
-              <a:rPr sz="1600" b="1">
-                <a:solidFill>
-                  <a:srgbClr val="B5333B"/>
-                </a:solidFill>
-                <a:latin typeface="微软雅黑"/>
-                <a:ea typeface="微软雅黑"/>
-                <a:cs typeface="微软雅黑"/>
-              </a:rPr>
-              <a:t>19.3%</a:t>
-            </a:r>
-          </a:p>
-        </p:txBody>
-      </p:sp>
-      <p:sp>
-        <p:nvSpPr>
-          <p:cNvPr id="77" name="TextBox 76"/>
-          <p:cNvSpPr txBox="1"/>
-          <p:nvPr/>
-        </p:nvSpPr>
-        <p:spPr>
-          <a:xfrm>
-            <a:off x="2194560" y="4910328"/>
-            <a:ext cx="1584960" cy="137160"/>
+              <a:rPr sz="720" b="1">
+                <a:solidFill>
+                  <a:srgbClr val="1A1A1C"/>
+                </a:solidFill>
+                <a:latin typeface="微软雅黑"/>
+                <a:ea typeface="微软雅黑"/>
+                <a:cs typeface="微软雅黑"/>
+              </a:rPr>
+              <a:t>编程大神.Skill</a:t>
+            </a:r>
+          </a:p>
+        </p:txBody>
+      </p:sp>
+      <p:sp>
+        <p:nvSpPr>
+          <p:cNvPr id="78" name="TextBox 77"/>
+          <p:cNvSpPr txBox="1"/>
+          <p:nvPr/>
+        </p:nvSpPr>
+        <p:spPr>
+          <a:xfrm>
+            <a:off x="3328416" y="4718304"/>
+            <a:ext cx="609600" cy="75438"/>
+          </a:xfrm>
+          <a:prstGeom prst="rect">
+            <a:avLst/>
+          </a:prstGeom>
+          <a:noFill/>
+        </p:spPr>
+        <p:txBody>
+          <a:bodyPr wrap="square" lIns="0" rIns="0" tIns="0" bIns="0" anchor="t">
+            <a:spAutoFit/>
+          </a:bodyPr>
+          <a:lstStyle/>
+          <a:p>
+            <a:pPr algn="r">
+              <a:lnSpc>
+                <a:spcPct val="100000"/>
+              </a:lnSpc>
+            </a:pPr>
+            <a:r>
+              <a:rPr sz="720" b="0">
+                <a:solidFill>
+                  <a:srgbClr val="5B616B"/>
+                </a:solidFill>
+                <a:latin typeface="微软雅黑"/>
+                <a:ea typeface="微软雅黑"/>
+                <a:cs typeface="微软雅黑"/>
+              </a:rPr>
+              <a:t>5,213,811</a:t>
+            </a:r>
+          </a:p>
+        </p:txBody>
+      </p:sp>
+      <p:sp>
+        <p:nvSpPr>
+          <p:cNvPr id="79" name="TextBox 78"/>
+          <p:cNvSpPr txBox="1"/>
+          <p:nvPr/>
+        </p:nvSpPr>
+        <p:spPr>
+          <a:xfrm>
+            <a:off x="621792" y="4821174"/>
+            <a:ext cx="3291840" cy="61721"/>
           </a:xfrm>
           <a:prstGeom prst="rect">
             <a:avLst/>
@@ -44356,7 +44441,7 @@
               </a:lnSpc>
             </a:pPr>
             <a:r>
-              <a:rPr sz="850" b="0">
+              <a:rPr sz="620" b="0">
                 <a:solidFill>
                   <a:srgbClr val="5B616B"/>
                 </a:solidFill>
@@ -44364,63 +44449,21 @@
                 <a:ea typeface="微软雅黑"/>
                 <a:cs typeface="微软雅黑"/>
               </a:rPr>
-              <a:t>API Key</a:t>
-            </a:r>
-          </a:p>
-        </p:txBody>
-      </p:sp>
-      <p:sp>
-        <p:nvSpPr>
-          <p:cNvPr id="78" name="TextBox 77"/>
-          <p:cNvSpPr txBox="1"/>
-          <p:nvPr/>
-        </p:nvSpPr>
-        <p:spPr>
-          <a:xfrm>
-            <a:off x="4267200" y="4677156"/>
-            <a:ext cx="7315200" cy="411480"/>
-          </a:xfrm>
-          <a:prstGeom prst="rect">
-            <a:avLst/>
-          </a:prstGeom>
-          <a:noFill/>
-        </p:spPr>
-        <p:txBody>
-          <a:bodyPr wrap="square" lIns="0" rIns="0" tIns="0" bIns="0" anchor="t">
-            <a:spAutoFit/>
-          </a:bodyPr>
-          <a:lstStyle/>
-          <a:p>
-            <a:pPr algn="l">
-              <a:lnSpc>
-                <a:spcPct val="110000"/>
-              </a:lnSpc>
-            </a:pPr>
-            <a:r>
-              <a:rPr sz="850" b="0">
-                <a:solidFill>
-                  <a:srgbClr val="8B8E94"/>
-                </a:solidFill>
-                <a:latin typeface="微软雅黑"/>
-                <a:ea typeface="微软雅黑"/>
-                <a:cs typeface="微软雅黑"/>
-              </a:rPr>
-              <a:t>付费标签 17,123（8.5%）、支付宝 2,901（1.4%）；Pay Skill 且 API Key 331 条。
-Top10000：付费 0.7%（68 条）、API Key 30.3%；Pay Skill 分类 0 条。</a:t>
-            </a:r>
-          </a:p>
-        </p:txBody>
-      </p:sp>
-      <p:sp>
-        <p:nvSpPr>
-          <p:cNvPr id="79" name="TextBox 78"/>
-          <p:cNvSpPr txBox="1"/>
-          <p:nvPr/>
-        </p:nvSpPr>
-        <p:spPr>
-          <a:xfrm>
-            <a:off x="426720" y="5795010"/>
-            <a:ext cx="11338560" cy="192024"/>
+              <a:t>阿客实验室</a:t>
+            </a:r>
+          </a:p>
+        </p:txBody>
+      </p:sp>
+      <p:sp>
+        <p:nvSpPr>
+          <p:cNvPr id="80" name="TextBox 79"/>
+          <p:cNvSpPr txBox="1"/>
+          <p:nvPr/>
+        </p:nvSpPr>
+        <p:spPr>
+          <a:xfrm>
+            <a:off x="426720" y="4889754"/>
+            <a:ext cx="170688" cy="75438"/>
           </a:xfrm>
           <a:prstGeom prst="rect">
             <a:avLst/>
@@ -44439,7 +44482,48 @@
               </a:lnSpc>
             </a:pPr>
             <a:r>
-              <a:rPr sz="1000" b="0">
+              <a:rPr sz="740" b="1">
+                <a:solidFill>
+                  <a:srgbClr val="B5333B"/>
+                </a:solidFill>
+                <a:latin typeface="微软雅黑"/>
+                <a:ea typeface="微软雅黑"/>
+                <a:cs typeface="微软雅黑"/>
+              </a:rPr>
+              <a:t>2</a:t>
+            </a:r>
+          </a:p>
+        </p:txBody>
+      </p:sp>
+      <p:sp>
+        <p:nvSpPr>
+          <p:cNvPr id="81" name="TextBox 80"/>
+          <p:cNvSpPr txBox="1"/>
+          <p:nvPr/>
+        </p:nvSpPr>
+        <p:spPr>
+          <a:xfrm>
+            <a:off x="621792" y="4889754"/>
+            <a:ext cx="2621280" cy="75438"/>
+          </a:xfrm>
+          <a:prstGeom prst="rect">
+            <a:avLst/>
+          </a:prstGeom>
+          <a:noFill/>
+        </p:spPr>
+        <p:txBody>
+          <a:bodyPr wrap="square" lIns="0" rIns="0" tIns="0" bIns="0" anchor="t">
+            <a:spAutoFit/>
+          </a:bodyPr>
+          <a:lstStyle/>
+          <a:p>
+            <a:pPr algn="l">
+              <a:lnSpc>
+                <a:spcPct val="100000"/>
+              </a:lnSpc>
+            </a:pPr>
+            <a:r>
+              <a:rPr sz="720" b="1">
                 <a:solidFill>
                   <a:srgbClr val="1A1A1C"/>
                 </a:solidFill>
@@ -44447,7 +44531,2924 @@
                 <a:ea typeface="微软雅黑"/>
                 <a:cs typeface="微软雅黑"/>
               </a:rPr>
-              <a:t>读法：镜像撑数量也撑总下载，企业撑单条；付费沉在长尾，API 在头部。</a:t>
+              <a:t>编程专家Pro.Skill</a:t>
+            </a:r>
+          </a:p>
+        </p:txBody>
+      </p:sp>
+      <p:sp>
+        <p:nvSpPr>
+          <p:cNvPr id="82" name="TextBox 81"/>
+          <p:cNvSpPr txBox="1"/>
+          <p:nvPr/>
+        </p:nvSpPr>
+        <p:spPr>
+          <a:xfrm>
+            <a:off x="3328416" y="4889754"/>
+            <a:ext cx="609600" cy="75438"/>
+          </a:xfrm>
+          <a:prstGeom prst="rect">
+            <a:avLst/>
+          </a:prstGeom>
+          <a:noFill/>
+        </p:spPr>
+        <p:txBody>
+          <a:bodyPr wrap="square" lIns="0" rIns="0" tIns="0" bIns="0" anchor="t">
+            <a:spAutoFit/>
+          </a:bodyPr>
+          <a:lstStyle/>
+          <a:p>
+            <a:pPr algn="r">
+              <a:lnSpc>
+                <a:spcPct val="100000"/>
+              </a:lnSpc>
+            </a:pPr>
+            <a:r>
+              <a:rPr sz="720" b="0">
+                <a:solidFill>
+                  <a:srgbClr val="5B616B"/>
+                </a:solidFill>
+                <a:latin typeface="微软雅黑"/>
+                <a:ea typeface="微软雅黑"/>
+                <a:cs typeface="微软雅黑"/>
+              </a:rPr>
+              <a:t>5,192,102</a:t>
+            </a:r>
+          </a:p>
+        </p:txBody>
+      </p:sp>
+      <p:sp>
+        <p:nvSpPr>
+          <p:cNvPr id="83" name="TextBox 82"/>
+          <p:cNvSpPr txBox="1"/>
+          <p:nvPr/>
+        </p:nvSpPr>
+        <p:spPr>
+          <a:xfrm>
+            <a:off x="621792" y="4992624"/>
+            <a:ext cx="3291840" cy="61721"/>
+          </a:xfrm>
+          <a:prstGeom prst="rect">
+            <a:avLst/>
+          </a:prstGeom>
+          <a:noFill/>
+        </p:spPr>
+        <p:txBody>
+          <a:bodyPr wrap="square" lIns="0" rIns="0" tIns="0" bIns="0" anchor="t">
+            <a:spAutoFit/>
+          </a:bodyPr>
+          <a:lstStyle/>
+          <a:p>
+            <a:pPr algn="l">
+              <a:lnSpc>
+                <a:spcPct val="100000"/>
+              </a:lnSpc>
+            </a:pPr>
+            <a:r>
+              <a:rPr sz="620" b="0">
+                <a:solidFill>
+                  <a:srgbClr val="5B616B"/>
+                </a:solidFill>
+                <a:latin typeface="微软雅黑"/>
+                <a:ea typeface="微软雅黑"/>
+                <a:cs typeface="微软雅黑"/>
+              </a:rPr>
+              <a:t>user_47d655f0</a:t>
+            </a:r>
+          </a:p>
+        </p:txBody>
+      </p:sp>
+      <p:sp>
+        <p:nvSpPr>
+          <p:cNvPr id="84" name="TextBox 83"/>
+          <p:cNvSpPr txBox="1"/>
+          <p:nvPr/>
+        </p:nvSpPr>
+        <p:spPr>
+          <a:xfrm>
+            <a:off x="426720" y="5061204"/>
+            <a:ext cx="170688" cy="75438"/>
+          </a:xfrm>
+          <a:prstGeom prst="rect">
+            <a:avLst/>
+          </a:prstGeom>
+          <a:noFill/>
+        </p:spPr>
+        <p:txBody>
+          <a:bodyPr wrap="square" lIns="0" rIns="0" tIns="0" bIns="0" anchor="t">
+            <a:spAutoFit/>
+          </a:bodyPr>
+          <a:lstStyle/>
+          <a:p>
+            <a:pPr algn="l">
+              <a:lnSpc>
+                <a:spcPct val="100000"/>
+              </a:lnSpc>
+            </a:pPr>
+            <a:r>
+              <a:rPr sz="740" b="1">
+                <a:solidFill>
+                  <a:srgbClr val="B5333B"/>
+                </a:solidFill>
+                <a:latin typeface="微软雅黑"/>
+                <a:ea typeface="微软雅黑"/>
+                <a:cs typeface="微软雅黑"/>
+              </a:rPr>
+              <a:t>3</a:t>
+            </a:r>
+          </a:p>
+        </p:txBody>
+      </p:sp>
+      <p:sp>
+        <p:nvSpPr>
+          <p:cNvPr id="85" name="TextBox 84"/>
+          <p:cNvSpPr txBox="1"/>
+          <p:nvPr/>
+        </p:nvSpPr>
+        <p:spPr>
+          <a:xfrm>
+            <a:off x="621792" y="5061204"/>
+            <a:ext cx="2621280" cy="75438"/>
+          </a:xfrm>
+          <a:prstGeom prst="rect">
+            <a:avLst/>
+          </a:prstGeom>
+          <a:noFill/>
+        </p:spPr>
+        <p:txBody>
+          <a:bodyPr wrap="square" lIns="0" rIns="0" tIns="0" bIns="0" anchor="t">
+            <a:spAutoFit/>
+          </a:bodyPr>
+          <a:lstStyle/>
+          <a:p>
+            <a:pPr algn="l">
+              <a:lnSpc>
+                <a:spcPct val="100000"/>
+              </a:lnSpc>
+            </a:pPr>
+            <a:r>
+              <a:rPr sz="720" b="1">
+                <a:solidFill>
+                  <a:srgbClr val="1A1A1C"/>
+                </a:solidFill>
+                <a:latin typeface="微软雅黑"/>
+                <a:ea typeface="微软雅黑"/>
+                <a:cs typeface="微软雅黑"/>
+              </a:rPr>
+              <a:t>编程专家.Skill</a:t>
+            </a:r>
+          </a:p>
+        </p:txBody>
+      </p:sp>
+      <p:sp>
+        <p:nvSpPr>
+          <p:cNvPr id="86" name="TextBox 85"/>
+          <p:cNvSpPr txBox="1"/>
+          <p:nvPr/>
+        </p:nvSpPr>
+        <p:spPr>
+          <a:xfrm>
+            <a:off x="3328416" y="5061204"/>
+            <a:ext cx="609600" cy="75438"/>
+          </a:xfrm>
+          <a:prstGeom prst="rect">
+            <a:avLst/>
+          </a:prstGeom>
+          <a:noFill/>
+        </p:spPr>
+        <p:txBody>
+          <a:bodyPr wrap="square" lIns="0" rIns="0" tIns="0" bIns="0" anchor="t">
+            <a:spAutoFit/>
+          </a:bodyPr>
+          <a:lstStyle/>
+          <a:p>
+            <a:pPr algn="r">
+              <a:lnSpc>
+                <a:spcPct val="100000"/>
+              </a:lnSpc>
+            </a:pPr>
+            <a:r>
+              <a:rPr sz="720" b="0">
+                <a:solidFill>
+                  <a:srgbClr val="5B616B"/>
+                </a:solidFill>
+                <a:latin typeface="微软雅黑"/>
+                <a:ea typeface="微软雅黑"/>
+                <a:cs typeface="微软雅黑"/>
+              </a:rPr>
+              <a:t>4,877,322</a:t>
+            </a:r>
+          </a:p>
+        </p:txBody>
+      </p:sp>
+      <p:sp>
+        <p:nvSpPr>
+          <p:cNvPr id="87" name="TextBox 86"/>
+          <p:cNvSpPr txBox="1"/>
+          <p:nvPr/>
+        </p:nvSpPr>
+        <p:spPr>
+          <a:xfrm>
+            <a:off x="621792" y="5164074"/>
+            <a:ext cx="3291840" cy="61721"/>
+          </a:xfrm>
+          <a:prstGeom prst="rect">
+            <a:avLst/>
+          </a:prstGeom>
+          <a:noFill/>
+        </p:spPr>
+        <p:txBody>
+          <a:bodyPr wrap="square" lIns="0" rIns="0" tIns="0" bIns="0" anchor="t">
+            <a:spAutoFit/>
+          </a:bodyPr>
+          <a:lstStyle/>
+          <a:p>
+            <a:pPr algn="l">
+              <a:lnSpc>
+                <a:spcPct val="100000"/>
+              </a:lnSpc>
+            </a:pPr>
+            <a:r>
+              <a:rPr sz="620" b="0">
+                <a:solidFill>
+                  <a:srgbClr val="5B616B"/>
+                </a:solidFill>
+                <a:latin typeface="微软雅黑"/>
+                <a:ea typeface="微软雅黑"/>
+                <a:cs typeface="微软雅黑"/>
+              </a:rPr>
+              <a:t>user_741dc82b</a:t>
+            </a:r>
+          </a:p>
+        </p:txBody>
+      </p:sp>
+      <p:sp>
+        <p:nvSpPr>
+          <p:cNvPr id="88" name="TextBox 87"/>
+          <p:cNvSpPr txBox="1"/>
+          <p:nvPr/>
+        </p:nvSpPr>
+        <p:spPr>
+          <a:xfrm>
+            <a:off x="426720" y="5232653"/>
+            <a:ext cx="170688" cy="75438"/>
+          </a:xfrm>
+          <a:prstGeom prst="rect">
+            <a:avLst/>
+          </a:prstGeom>
+          <a:noFill/>
+        </p:spPr>
+        <p:txBody>
+          <a:bodyPr wrap="square" lIns="0" rIns="0" tIns="0" bIns="0" anchor="t">
+            <a:spAutoFit/>
+          </a:bodyPr>
+          <a:lstStyle/>
+          <a:p>
+            <a:pPr algn="l">
+              <a:lnSpc>
+                <a:spcPct val="100000"/>
+              </a:lnSpc>
+            </a:pPr>
+            <a:r>
+              <a:rPr sz="740" b="1">
+                <a:solidFill>
+                  <a:srgbClr val="B5333B"/>
+                </a:solidFill>
+                <a:latin typeface="微软雅黑"/>
+                <a:ea typeface="微软雅黑"/>
+                <a:cs typeface="微软雅黑"/>
+              </a:rPr>
+              <a:t>4</a:t>
+            </a:r>
+          </a:p>
+        </p:txBody>
+      </p:sp>
+      <p:sp>
+        <p:nvSpPr>
+          <p:cNvPr id="89" name="TextBox 88"/>
+          <p:cNvSpPr txBox="1"/>
+          <p:nvPr/>
+        </p:nvSpPr>
+        <p:spPr>
+          <a:xfrm>
+            <a:off x="621792" y="5232653"/>
+            <a:ext cx="2621280" cy="75438"/>
+          </a:xfrm>
+          <a:prstGeom prst="rect">
+            <a:avLst/>
+          </a:prstGeom>
+          <a:noFill/>
+        </p:spPr>
+        <p:txBody>
+          <a:bodyPr wrap="square" lIns="0" rIns="0" tIns="0" bIns="0" anchor="t">
+            <a:spAutoFit/>
+          </a:bodyPr>
+          <a:lstStyle/>
+          <a:p>
+            <a:pPr algn="l">
+              <a:lnSpc>
+                <a:spcPct val="100000"/>
+              </a:lnSpc>
+            </a:pPr>
+            <a:r>
+              <a:rPr sz="720" b="1">
+                <a:solidFill>
+                  <a:srgbClr val="1A1A1C"/>
+                </a:solidFill>
+                <a:latin typeface="微软雅黑"/>
+                <a:ea typeface="微软雅黑"/>
+                <a:cs typeface="微软雅黑"/>
+              </a:rPr>
+              <a:t>搜索引擎</a:t>
+            </a:r>
+          </a:p>
+        </p:txBody>
+      </p:sp>
+      <p:sp>
+        <p:nvSpPr>
+          <p:cNvPr id="90" name="TextBox 89"/>
+          <p:cNvSpPr txBox="1"/>
+          <p:nvPr/>
+        </p:nvSpPr>
+        <p:spPr>
+          <a:xfrm>
+            <a:off x="3328416" y="5232653"/>
+            <a:ext cx="609600" cy="75438"/>
+          </a:xfrm>
+          <a:prstGeom prst="rect">
+            <a:avLst/>
+          </a:prstGeom>
+          <a:noFill/>
+        </p:spPr>
+        <p:txBody>
+          <a:bodyPr wrap="square" lIns="0" rIns="0" tIns="0" bIns="0" anchor="t">
+            <a:spAutoFit/>
+          </a:bodyPr>
+          <a:lstStyle/>
+          <a:p>
+            <a:pPr algn="r">
+              <a:lnSpc>
+                <a:spcPct val="100000"/>
+              </a:lnSpc>
+            </a:pPr>
+            <a:r>
+              <a:rPr sz="720" b="0">
+                <a:solidFill>
+                  <a:srgbClr val="5B616B"/>
+                </a:solidFill>
+                <a:latin typeface="微软雅黑"/>
+                <a:ea typeface="微软雅黑"/>
+                <a:cs typeface="微软雅黑"/>
+              </a:rPr>
+              <a:t>4,712,038</a:t>
+            </a:r>
+          </a:p>
+        </p:txBody>
+      </p:sp>
+      <p:sp>
+        <p:nvSpPr>
+          <p:cNvPr id="91" name="TextBox 90"/>
+          <p:cNvSpPr txBox="1"/>
+          <p:nvPr/>
+        </p:nvSpPr>
+        <p:spPr>
+          <a:xfrm>
+            <a:off x="621792" y="5335523"/>
+            <a:ext cx="3291840" cy="61721"/>
+          </a:xfrm>
+          <a:prstGeom prst="rect">
+            <a:avLst/>
+          </a:prstGeom>
+          <a:noFill/>
+        </p:spPr>
+        <p:txBody>
+          <a:bodyPr wrap="square" lIns="0" rIns="0" tIns="0" bIns="0" anchor="t">
+            <a:spAutoFit/>
+          </a:bodyPr>
+          <a:lstStyle/>
+          <a:p>
+            <a:pPr algn="l">
+              <a:lnSpc>
+                <a:spcPct val="100000"/>
+              </a:lnSpc>
+            </a:pPr>
+            <a:r>
+              <a:rPr sz="620" b="0">
+                <a:solidFill>
+                  <a:srgbClr val="5B616B"/>
+                </a:solidFill>
+                <a:latin typeface="微软雅黑"/>
+                <a:ea typeface="微软雅黑"/>
+                <a:cs typeface="微软雅黑"/>
+              </a:rPr>
+              <a:t>智创未来</a:t>
+            </a:r>
+          </a:p>
+        </p:txBody>
+      </p:sp>
+      <p:sp>
+        <p:nvSpPr>
+          <p:cNvPr id="92" name="TextBox 91"/>
+          <p:cNvSpPr txBox="1"/>
+          <p:nvPr/>
+        </p:nvSpPr>
+        <p:spPr>
+          <a:xfrm>
+            <a:off x="426720" y="5404103"/>
+            <a:ext cx="170688" cy="75438"/>
+          </a:xfrm>
+          <a:prstGeom prst="rect">
+            <a:avLst/>
+          </a:prstGeom>
+          <a:noFill/>
+        </p:spPr>
+        <p:txBody>
+          <a:bodyPr wrap="square" lIns="0" rIns="0" tIns="0" bIns="0" anchor="t">
+            <a:spAutoFit/>
+          </a:bodyPr>
+          <a:lstStyle/>
+          <a:p>
+            <a:pPr algn="l">
+              <a:lnSpc>
+                <a:spcPct val="100000"/>
+              </a:lnSpc>
+            </a:pPr>
+            <a:r>
+              <a:rPr sz="740" b="1">
+                <a:solidFill>
+                  <a:srgbClr val="B5333B"/>
+                </a:solidFill>
+                <a:latin typeface="微软雅黑"/>
+                <a:ea typeface="微软雅黑"/>
+                <a:cs typeface="微软雅黑"/>
+              </a:rPr>
+              <a:t>5</a:t>
+            </a:r>
+          </a:p>
+        </p:txBody>
+      </p:sp>
+      <p:sp>
+        <p:nvSpPr>
+          <p:cNvPr id="93" name="TextBox 92"/>
+          <p:cNvSpPr txBox="1"/>
+          <p:nvPr/>
+        </p:nvSpPr>
+        <p:spPr>
+          <a:xfrm>
+            <a:off x="621792" y="5404103"/>
+            <a:ext cx="2621280" cy="75438"/>
+          </a:xfrm>
+          <a:prstGeom prst="rect">
+            <a:avLst/>
+          </a:prstGeom>
+          <a:noFill/>
+        </p:spPr>
+        <p:txBody>
+          <a:bodyPr wrap="square" lIns="0" rIns="0" tIns="0" bIns="0" anchor="t">
+            <a:spAutoFit/>
+          </a:bodyPr>
+          <a:lstStyle/>
+          <a:p>
+            <a:pPr algn="l">
+              <a:lnSpc>
+                <a:spcPct val="100000"/>
+              </a:lnSpc>
+            </a:pPr>
+            <a:r>
+              <a:rPr sz="720" b="1">
+                <a:solidFill>
+                  <a:srgbClr val="1A1A1C"/>
+                </a:solidFill>
+                <a:latin typeface="微软雅黑"/>
+                <a:ea typeface="微软雅黑"/>
+                <a:cs typeface="微软雅黑"/>
+              </a:rPr>
+              <a:t>dev-expert</a:t>
+            </a:r>
+          </a:p>
+        </p:txBody>
+      </p:sp>
+      <p:sp>
+        <p:nvSpPr>
+          <p:cNvPr id="94" name="TextBox 93"/>
+          <p:cNvSpPr txBox="1"/>
+          <p:nvPr/>
+        </p:nvSpPr>
+        <p:spPr>
+          <a:xfrm>
+            <a:off x="3328416" y="5404103"/>
+            <a:ext cx="609600" cy="75438"/>
+          </a:xfrm>
+          <a:prstGeom prst="rect">
+            <a:avLst/>
+          </a:prstGeom>
+          <a:noFill/>
+        </p:spPr>
+        <p:txBody>
+          <a:bodyPr wrap="square" lIns="0" rIns="0" tIns="0" bIns="0" anchor="t">
+            <a:spAutoFit/>
+          </a:bodyPr>
+          <a:lstStyle/>
+          <a:p>
+            <a:pPr algn="r">
+              <a:lnSpc>
+                <a:spcPct val="100000"/>
+              </a:lnSpc>
+            </a:pPr>
+            <a:r>
+              <a:rPr sz="720" b="0">
+                <a:solidFill>
+                  <a:srgbClr val="5B616B"/>
+                </a:solidFill>
+                <a:latin typeface="微软雅黑"/>
+                <a:ea typeface="微软雅黑"/>
+                <a:cs typeface="微软雅黑"/>
+              </a:rPr>
+              <a:t>4,173,129</a:t>
+            </a:r>
+          </a:p>
+        </p:txBody>
+      </p:sp>
+      <p:sp>
+        <p:nvSpPr>
+          <p:cNvPr id="95" name="TextBox 94"/>
+          <p:cNvSpPr txBox="1"/>
+          <p:nvPr/>
+        </p:nvSpPr>
+        <p:spPr>
+          <a:xfrm>
+            <a:off x="621792" y="5506974"/>
+            <a:ext cx="3291840" cy="61721"/>
+          </a:xfrm>
+          <a:prstGeom prst="rect">
+            <a:avLst/>
+          </a:prstGeom>
+          <a:noFill/>
+        </p:spPr>
+        <p:txBody>
+          <a:bodyPr wrap="square" lIns="0" rIns="0" tIns="0" bIns="0" anchor="t">
+            <a:spAutoFit/>
+          </a:bodyPr>
+          <a:lstStyle/>
+          <a:p>
+            <a:pPr algn="l">
+              <a:lnSpc>
+                <a:spcPct val="100000"/>
+              </a:lnSpc>
+            </a:pPr>
+            <a:r>
+              <a:rPr sz="620" b="0">
+                <a:solidFill>
+                  <a:srgbClr val="5B616B"/>
+                </a:solidFill>
+                <a:latin typeface="微软雅黑"/>
+                <a:ea typeface="微软雅黑"/>
+                <a:cs typeface="微软雅黑"/>
+              </a:rPr>
+              <a:t>user_814dbe54</a:t>
+            </a:r>
+          </a:p>
+        </p:txBody>
+      </p:sp>
+      <p:sp>
+        <p:nvSpPr>
+          <p:cNvPr id="96" name="TextBox 95"/>
+          <p:cNvSpPr txBox="1"/>
+          <p:nvPr/>
+        </p:nvSpPr>
+        <p:spPr>
+          <a:xfrm>
+            <a:off x="426720" y="5575554"/>
+            <a:ext cx="170688" cy="75438"/>
+          </a:xfrm>
+          <a:prstGeom prst="rect">
+            <a:avLst/>
+          </a:prstGeom>
+          <a:noFill/>
+        </p:spPr>
+        <p:txBody>
+          <a:bodyPr wrap="square" lIns="0" rIns="0" tIns="0" bIns="0" anchor="t">
+            <a:spAutoFit/>
+          </a:bodyPr>
+          <a:lstStyle/>
+          <a:p>
+            <a:pPr algn="l">
+              <a:lnSpc>
+                <a:spcPct val="100000"/>
+              </a:lnSpc>
+            </a:pPr>
+            <a:r>
+              <a:rPr sz="740" b="1">
+                <a:solidFill>
+                  <a:srgbClr val="B5333B"/>
+                </a:solidFill>
+                <a:latin typeface="微软雅黑"/>
+                <a:ea typeface="微软雅黑"/>
+                <a:cs typeface="微软雅黑"/>
+              </a:rPr>
+              <a:t>6</a:t>
+            </a:r>
+          </a:p>
+        </p:txBody>
+      </p:sp>
+      <p:sp>
+        <p:nvSpPr>
+          <p:cNvPr id="97" name="TextBox 96"/>
+          <p:cNvSpPr txBox="1"/>
+          <p:nvPr/>
+        </p:nvSpPr>
+        <p:spPr>
+          <a:xfrm>
+            <a:off x="621792" y="5575554"/>
+            <a:ext cx="2621280" cy="75438"/>
+          </a:xfrm>
+          <a:prstGeom prst="rect">
+            <a:avLst/>
+          </a:prstGeom>
+          <a:noFill/>
+        </p:spPr>
+        <p:txBody>
+          <a:bodyPr wrap="square" lIns="0" rIns="0" tIns="0" bIns="0" anchor="t">
+            <a:spAutoFit/>
+          </a:bodyPr>
+          <a:lstStyle/>
+          <a:p>
+            <a:pPr algn="l">
+              <a:lnSpc>
+                <a:spcPct val="100000"/>
+              </a:lnSpc>
+            </a:pPr>
+            <a:r>
+              <a:rPr sz="720" b="1">
+                <a:solidFill>
+                  <a:srgbClr val="1A1A1C"/>
+                </a:solidFill>
+                <a:latin typeface="微软雅黑"/>
+                <a:ea typeface="微软雅黑"/>
+                <a:cs typeface="微软雅黑"/>
+              </a:rPr>
+              <a:t>育儿大师.Skill</a:t>
+            </a:r>
+          </a:p>
+        </p:txBody>
+      </p:sp>
+      <p:sp>
+        <p:nvSpPr>
+          <p:cNvPr id="98" name="TextBox 97"/>
+          <p:cNvSpPr txBox="1"/>
+          <p:nvPr/>
+        </p:nvSpPr>
+        <p:spPr>
+          <a:xfrm>
+            <a:off x="3328416" y="5575554"/>
+            <a:ext cx="609600" cy="75438"/>
+          </a:xfrm>
+          <a:prstGeom prst="rect">
+            <a:avLst/>
+          </a:prstGeom>
+          <a:noFill/>
+        </p:spPr>
+        <p:txBody>
+          <a:bodyPr wrap="square" lIns="0" rIns="0" tIns="0" bIns="0" anchor="t">
+            <a:spAutoFit/>
+          </a:bodyPr>
+          <a:lstStyle/>
+          <a:p>
+            <a:pPr algn="r">
+              <a:lnSpc>
+                <a:spcPct val="100000"/>
+              </a:lnSpc>
+            </a:pPr>
+            <a:r>
+              <a:rPr sz="720" b="0">
+                <a:solidFill>
+                  <a:srgbClr val="5B616B"/>
+                </a:solidFill>
+                <a:latin typeface="微软雅黑"/>
+                <a:ea typeface="微软雅黑"/>
+                <a:cs typeface="微软雅黑"/>
+              </a:rPr>
+              <a:t>2,508,248</a:t>
+            </a:r>
+          </a:p>
+        </p:txBody>
+      </p:sp>
+      <p:sp>
+        <p:nvSpPr>
+          <p:cNvPr id="99" name="TextBox 98"/>
+          <p:cNvSpPr txBox="1"/>
+          <p:nvPr/>
+        </p:nvSpPr>
+        <p:spPr>
+          <a:xfrm>
+            <a:off x="621792" y="5678424"/>
+            <a:ext cx="3291840" cy="61721"/>
+          </a:xfrm>
+          <a:prstGeom prst="rect">
+            <a:avLst/>
+          </a:prstGeom>
+          <a:noFill/>
+        </p:spPr>
+        <p:txBody>
+          <a:bodyPr wrap="square" lIns="0" rIns="0" tIns="0" bIns="0" anchor="t">
+            <a:spAutoFit/>
+          </a:bodyPr>
+          <a:lstStyle/>
+          <a:p>
+            <a:pPr algn="l">
+              <a:lnSpc>
+                <a:spcPct val="100000"/>
+              </a:lnSpc>
+            </a:pPr>
+            <a:r>
+              <a:rPr sz="620" b="0">
+                <a:solidFill>
+                  <a:srgbClr val="5B616B"/>
+                </a:solidFill>
+                <a:latin typeface="微软雅黑"/>
+                <a:ea typeface="微软雅黑"/>
+                <a:cs typeface="微软雅黑"/>
+              </a:rPr>
+              <a:t>user_741dc82b</a:t>
+            </a:r>
+          </a:p>
+        </p:txBody>
+      </p:sp>
+      <p:sp>
+        <p:nvSpPr>
+          <p:cNvPr id="100" name="TextBox 99"/>
+          <p:cNvSpPr txBox="1"/>
+          <p:nvPr/>
+        </p:nvSpPr>
+        <p:spPr>
+          <a:xfrm>
+            <a:off x="4328160" y="4594860"/>
+            <a:ext cx="3535679" cy="96012"/>
+          </a:xfrm>
+          <a:prstGeom prst="rect">
+            <a:avLst/>
+          </a:prstGeom>
+          <a:noFill/>
+        </p:spPr>
+        <p:txBody>
+          <a:bodyPr wrap="square" lIns="0" rIns="0" tIns="0" bIns="0" anchor="t">
+            <a:spAutoFit/>
+          </a:bodyPr>
+          <a:lstStyle/>
+          <a:p>
+            <a:pPr algn="l">
+              <a:lnSpc>
+                <a:spcPct val="100000"/>
+              </a:lnSpc>
+            </a:pPr>
+            <a:r>
+              <a:rPr sz="860" b="1">
+                <a:solidFill>
+                  <a:srgbClr val="D98A8F"/>
+                </a:solidFill>
+                <a:latin typeface="微软雅黑"/>
+                <a:ea typeface="微软雅黑"/>
+                <a:cs typeface="微软雅黑"/>
+              </a:rPr>
+              <a:t>Payskill Top6</a:t>
+            </a:r>
+          </a:p>
+        </p:txBody>
+      </p:sp>
+      <p:sp>
+        <p:nvSpPr>
+          <p:cNvPr id="101" name="Rectangle 100"/>
+          <p:cNvSpPr/>
+          <p:nvPr/>
+        </p:nvSpPr>
+        <p:spPr>
+          <a:xfrm>
+            <a:off x="4328160" y="4690872"/>
+            <a:ext cx="3535679" cy="5486"/>
+          </a:xfrm>
+          <a:prstGeom prst="rect">
+            <a:avLst/>
+          </a:prstGeom>
+          <a:solidFill>
+            <a:srgbClr val="E2E4E7"/>
+          </a:solidFill>
+          <a:ln>
+            <a:noFill/>
+          </a:ln>
+          <a:effectLst/>
+        </p:spPr>
+        <p:style>
+          <a:lnRef idx="1">
+            <a:schemeClr val="accent1"/>
+          </a:lnRef>
+          <a:fillRef idx="3">
+            <a:schemeClr val="accent1"/>
+          </a:fillRef>
+          <a:effectRef idx="2">
+            <a:schemeClr val="accent1"/>
+          </a:effectRef>
+          <a:fontRef idx="minor">
+            <a:schemeClr val="lt1"/>
+          </a:fontRef>
+        </p:style>
+        <p:txBody>
+          <a:bodyPr rtlCol="0" anchor="ctr"/>
+          <a:lstStyle/>
+          <a:p>
+            <a:pPr algn="ctr"/>
+          </a:p>
+        </p:txBody>
+      </p:sp>
+      <p:sp>
+        <p:nvSpPr>
+          <p:cNvPr id="102" name="TextBox 101"/>
+          <p:cNvSpPr txBox="1"/>
+          <p:nvPr/>
+        </p:nvSpPr>
+        <p:spPr>
+          <a:xfrm>
+            <a:off x="4328160" y="4718304"/>
+            <a:ext cx="170688" cy="75438"/>
+          </a:xfrm>
+          <a:prstGeom prst="rect">
+            <a:avLst/>
+          </a:prstGeom>
+          <a:noFill/>
+        </p:spPr>
+        <p:txBody>
+          <a:bodyPr wrap="square" lIns="0" rIns="0" tIns="0" bIns="0" anchor="t">
+            <a:spAutoFit/>
+          </a:bodyPr>
+          <a:lstStyle/>
+          <a:p>
+            <a:pPr algn="l">
+              <a:lnSpc>
+                <a:spcPct val="100000"/>
+              </a:lnSpc>
+            </a:pPr>
+            <a:r>
+              <a:rPr sz="740" b="1">
+                <a:solidFill>
+                  <a:srgbClr val="B5333B"/>
+                </a:solidFill>
+                <a:latin typeface="微软雅黑"/>
+                <a:ea typeface="微软雅黑"/>
+                <a:cs typeface="微软雅黑"/>
+              </a:rPr>
+              <a:t>1</a:t>
+            </a:r>
+          </a:p>
+        </p:txBody>
+      </p:sp>
+      <p:sp>
+        <p:nvSpPr>
+          <p:cNvPr id="103" name="TextBox 102"/>
+          <p:cNvSpPr txBox="1"/>
+          <p:nvPr/>
+        </p:nvSpPr>
+        <p:spPr>
+          <a:xfrm>
+            <a:off x="4523232" y="4718304"/>
+            <a:ext cx="2621280" cy="75438"/>
+          </a:xfrm>
+          <a:prstGeom prst="rect">
+            <a:avLst/>
+          </a:prstGeom>
+          <a:noFill/>
+        </p:spPr>
+        <p:txBody>
+          <a:bodyPr wrap="square" lIns="0" rIns="0" tIns="0" bIns="0" anchor="t">
+            <a:spAutoFit/>
+          </a:bodyPr>
+          <a:lstStyle/>
+          <a:p>
+            <a:pPr algn="l">
+              <a:lnSpc>
+                <a:spcPct val="100000"/>
+              </a:lnSpc>
+            </a:pPr>
+            <a:r>
+              <a:rPr sz="720" b="1">
+                <a:solidFill>
+                  <a:srgbClr val="1A1A1C"/>
+                </a:solidFill>
+                <a:latin typeface="微软雅黑"/>
+                <a:ea typeface="微软雅黑"/>
+                <a:cs typeface="微软雅黑"/>
+              </a:rPr>
+              <a:t>WPS全家桶·办公管家.Skill</a:t>
+            </a:r>
+          </a:p>
+        </p:txBody>
+      </p:sp>
+      <p:sp>
+        <p:nvSpPr>
+          <p:cNvPr id="104" name="TextBox 103"/>
+          <p:cNvSpPr txBox="1"/>
+          <p:nvPr/>
+        </p:nvSpPr>
+        <p:spPr>
+          <a:xfrm>
+            <a:off x="7229856" y="4718304"/>
+            <a:ext cx="609600" cy="75438"/>
+          </a:xfrm>
+          <a:prstGeom prst="rect">
+            <a:avLst/>
+          </a:prstGeom>
+          <a:noFill/>
+        </p:spPr>
+        <p:txBody>
+          <a:bodyPr wrap="square" lIns="0" rIns="0" tIns="0" bIns="0" anchor="t">
+            <a:spAutoFit/>
+          </a:bodyPr>
+          <a:lstStyle/>
+          <a:p>
+            <a:pPr algn="r">
+              <a:lnSpc>
+                <a:spcPct val="100000"/>
+              </a:lnSpc>
+            </a:pPr>
+            <a:r>
+              <a:rPr sz="720" b="0">
+                <a:solidFill>
+                  <a:srgbClr val="5B616B"/>
+                </a:solidFill>
+                <a:latin typeface="微软雅黑"/>
+                <a:ea typeface="微软雅黑"/>
+                <a:cs typeface="微软雅黑"/>
+              </a:rPr>
+              <a:t>190,264</a:t>
+            </a:r>
+          </a:p>
+        </p:txBody>
+      </p:sp>
+      <p:sp>
+        <p:nvSpPr>
+          <p:cNvPr id="105" name="TextBox 104"/>
+          <p:cNvSpPr txBox="1"/>
+          <p:nvPr/>
+        </p:nvSpPr>
+        <p:spPr>
+          <a:xfrm>
+            <a:off x="4523232" y="4821174"/>
+            <a:ext cx="3291840" cy="61721"/>
+          </a:xfrm>
+          <a:prstGeom prst="rect">
+            <a:avLst/>
+          </a:prstGeom>
+          <a:noFill/>
+        </p:spPr>
+        <p:txBody>
+          <a:bodyPr wrap="square" lIns="0" rIns="0" tIns="0" bIns="0" anchor="t">
+            <a:spAutoFit/>
+          </a:bodyPr>
+          <a:lstStyle/>
+          <a:p>
+            <a:pPr algn="l">
+              <a:lnSpc>
+                <a:spcPct val="100000"/>
+              </a:lnSpc>
+            </a:pPr>
+            <a:r>
+              <a:rPr sz="620" b="0">
+                <a:solidFill>
+                  <a:srgbClr val="5B616B"/>
+                </a:solidFill>
+                <a:latin typeface="微软雅黑"/>
+                <a:ea typeface="微软雅黑"/>
+                <a:cs typeface="微软雅黑"/>
+              </a:rPr>
+              <a:t>user_185644ed</a:t>
+            </a:r>
+          </a:p>
+        </p:txBody>
+      </p:sp>
+      <p:sp>
+        <p:nvSpPr>
+          <p:cNvPr id="106" name="TextBox 105"/>
+          <p:cNvSpPr txBox="1"/>
+          <p:nvPr/>
+        </p:nvSpPr>
+        <p:spPr>
+          <a:xfrm>
+            <a:off x="4328160" y="4889754"/>
+            <a:ext cx="170688" cy="75438"/>
+          </a:xfrm>
+          <a:prstGeom prst="rect">
+            <a:avLst/>
+          </a:prstGeom>
+          <a:noFill/>
+        </p:spPr>
+        <p:txBody>
+          <a:bodyPr wrap="square" lIns="0" rIns="0" tIns="0" bIns="0" anchor="t">
+            <a:spAutoFit/>
+          </a:bodyPr>
+          <a:lstStyle/>
+          <a:p>
+            <a:pPr algn="l">
+              <a:lnSpc>
+                <a:spcPct val="100000"/>
+              </a:lnSpc>
+            </a:pPr>
+            <a:r>
+              <a:rPr sz="740" b="1">
+                <a:solidFill>
+                  <a:srgbClr val="B5333B"/>
+                </a:solidFill>
+                <a:latin typeface="微软雅黑"/>
+                <a:ea typeface="微软雅黑"/>
+                <a:cs typeface="微软雅黑"/>
+              </a:rPr>
+              <a:t>2</a:t>
+            </a:r>
+          </a:p>
+        </p:txBody>
+      </p:sp>
+      <p:sp>
+        <p:nvSpPr>
+          <p:cNvPr id="107" name="TextBox 106"/>
+          <p:cNvSpPr txBox="1"/>
+          <p:nvPr/>
+        </p:nvSpPr>
+        <p:spPr>
+          <a:xfrm>
+            <a:off x="4523232" y="4889754"/>
+            <a:ext cx="2621280" cy="75438"/>
+          </a:xfrm>
+          <a:prstGeom prst="rect">
+            <a:avLst/>
+          </a:prstGeom>
+          <a:noFill/>
+        </p:spPr>
+        <p:txBody>
+          <a:bodyPr wrap="square" lIns="0" rIns="0" tIns="0" bIns="0" anchor="t">
+            <a:spAutoFit/>
+          </a:bodyPr>
+          <a:lstStyle/>
+          <a:p>
+            <a:pPr algn="l">
+              <a:lnSpc>
+                <a:spcPct val="100000"/>
+              </a:lnSpc>
+            </a:pPr>
+            <a:r>
+              <a:rPr sz="720" b="1">
+                <a:solidFill>
+                  <a:srgbClr val="1A1A1C"/>
+                </a:solidFill>
+                <a:latin typeface="微软雅黑"/>
+                <a:ea typeface="微软雅黑"/>
+                <a:cs typeface="微软雅黑"/>
+              </a:rPr>
+              <a:t>招标文件解读【喜鹊标书】</a:t>
+            </a:r>
+          </a:p>
+        </p:txBody>
+      </p:sp>
+      <p:sp>
+        <p:nvSpPr>
+          <p:cNvPr id="108" name="TextBox 107"/>
+          <p:cNvSpPr txBox="1"/>
+          <p:nvPr/>
+        </p:nvSpPr>
+        <p:spPr>
+          <a:xfrm>
+            <a:off x="7229856" y="4889754"/>
+            <a:ext cx="609600" cy="75438"/>
+          </a:xfrm>
+          <a:prstGeom prst="rect">
+            <a:avLst/>
+          </a:prstGeom>
+          <a:noFill/>
+        </p:spPr>
+        <p:txBody>
+          <a:bodyPr wrap="square" lIns="0" rIns="0" tIns="0" bIns="0" anchor="t">
+            <a:spAutoFit/>
+          </a:bodyPr>
+          <a:lstStyle/>
+          <a:p>
+            <a:pPr algn="r">
+              <a:lnSpc>
+                <a:spcPct val="100000"/>
+              </a:lnSpc>
+            </a:pPr>
+            <a:r>
+              <a:rPr sz="720" b="0">
+                <a:solidFill>
+                  <a:srgbClr val="5B616B"/>
+                </a:solidFill>
+                <a:latin typeface="微软雅黑"/>
+                <a:ea typeface="微软雅黑"/>
+                <a:cs typeface="微软雅黑"/>
+              </a:rPr>
+              <a:t>169,094</a:t>
+            </a:r>
+          </a:p>
+        </p:txBody>
+      </p:sp>
+      <p:sp>
+        <p:nvSpPr>
+          <p:cNvPr id="109" name="TextBox 108"/>
+          <p:cNvSpPr txBox="1"/>
+          <p:nvPr/>
+        </p:nvSpPr>
+        <p:spPr>
+          <a:xfrm>
+            <a:off x="4523232" y="4992624"/>
+            <a:ext cx="3291840" cy="61721"/>
+          </a:xfrm>
+          <a:prstGeom prst="rect">
+            <a:avLst/>
+          </a:prstGeom>
+          <a:noFill/>
+        </p:spPr>
+        <p:txBody>
+          <a:bodyPr wrap="square" lIns="0" rIns="0" tIns="0" bIns="0" anchor="t">
+            <a:spAutoFit/>
+          </a:bodyPr>
+          <a:lstStyle/>
+          <a:p>
+            <a:pPr algn="l">
+              <a:lnSpc>
+                <a:spcPct val="100000"/>
+              </a:lnSpc>
+            </a:pPr>
+            <a:r>
+              <a:rPr sz="620" b="0">
+                <a:solidFill>
+                  <a:srgbClr val="5B616B"/>
+                </a:solidFill>
+                <a:latin typeface="微软雅黑"/>
+                <a:ea typeface="微软雅黑"/>
+                <a:cs typeface="微软雅黑"/>
+              </a:rPr>
+              <a:t>喜鹊AI</a:t>
+            </a:r>
+          </a:p>
+        </p:txBody>
+      </p:sp>
+      <p:sp>
+        <p:nvSpPr>
+          <p:cNvPr id="110" name="TextBox 109"/>
+          <p:cNvSpPr txBox="1"/>
+          <p:nvPr/>
+        </p:nvSpPr>
+        <p:spPr>
+          <a:xfrm>
+            <a:off x="4328160" y="5061204"/>
+            <a:ext cx="170688" cy="75438"/>
+          </a:xfrm>
+          <a:prstGeom prst="rect">
+            <a:avLst/>
+          </a:prstGeom>
+          <a:noFill/>
+        </p:spPr>
+        <p:txBody>
+          <a:bodyPr wrap="square" lIns="0" rIns="0" tIns="0" bIns="0" anchor="t">
+            <a:spAutoFit/>
+          </a:bodyPr>
+          <a:lstStyle/>
+          <a:p>
+            <a:pPr algn="l">
+              <a:lnSpc>
+                <a:spcPct val="100000"/>
+              </a:lnSpc>
+            </a:pPr>
+            <a:r>
+              <a:rPr sz="740" b="1">
+                <a:solidFill>
+                  <a:srgbClr val="B5333B"/>
+                </a:solidFill>
+                <a:latin typeface="微软雅黑"/>
+                <a:ea typeface="微软雅黑"/>
+                <a:cs typeface="微软雅黑"/>
+              </a:rPr>
+              <a:t>3</a:t>
+            </a:r>
+          </a:p>
+        </p:txBody>
+      </p:sp>
+      <p:sp>
+        <p:nvSpPr>
+          <p:cNvPr id="111" name="TextBox 110"/>
+          <p:cNvSpPr txBox="1"/>
+          <p:nvPr/>
+        </p:nvSpPr>
+        <p:spPr>
+          <a:xfrm>
+            <a:off x="4523232" y="5061204"/>
+            <a:ext cx="2621280" cy="75438"/>
+          </a:xfrm>
+          <a:prstGeom prst="rect">
+            <a:avLst/>
+          </a:prstGeom>
+          <a:noFill/>
+        </p:spPr>
+        <p:txBody>
+          <a:bodyPr wrap="square" lIns="0" rIns="0" tIns="0" bIns="0" anchor="t">
+            <a:spAutoFit/>
+          </a:bodyPr>
+          <a:lstStyle/>
+          <a:p>
+            <a:pPr algn="l">
+              <a:lnSpc>
+                <a:spcPct val="100000"/>
+              </a:lnSpc>
+            </a:pPr>
+            <a:r>
+              <a:rPr sz="720" b="1">
+                <a:solidFill>
+                  <a:srgbClr val="1A1A1C"/>
+                </a:solidFill>
+                <a:latin typeface="微软雅黑"/>
+                <a:ea typeface="微软雅黑"/>
+                <a:cs typeface="微软雅黑"/>
+              </a:rPr>
+              <a:t>办公文档三件套（Word/Excel/PDF）</a:t>
+            </a:r>
+          </a:p>
+        </p:txBody>
+      </p:sp>
+      <p:sp>
+        <p:nvSpPr>
+          <p:cNvPr id="112" name="TextBox 111"/>
+          <p:cNvSpPr txBox="1"/>
+          <p:nvPr/>
+        </p:nvSpPr>
+        <p:spPr>
+          <a:xfrm>
+            <a:off x="7229856" y="5061204"/>
+            <a:ext cx="609600" cy="75438"/>
+          </a:xfrm>
+          <a:prstGeom prst="rect">
+            <a:avLst/>
+          </a:prstGeom>
+          <a:noFill/>
+        </p:spPr>
+        <p:txBody>
+          <a:bodyPr wrap="square" lIns="0" rIns="0" tIns="0" bIns="0" anchor="t">
+            <a:spAutoFit/>
+          </a:bodyPr>
+          <a:lstStyle/>
+          <a:p>
+            <a:pPr algn="r">
+              <a:lnSpc>
+                <a:spcPct val="100000"/>
+              </a:lnSpc>
+            </a:pPr>
+            <a:r>
+              <a:rPr sz="720" b="0">
+                <a:solidFill>
+                  <a:srgbClr val="5B616B"/>
+                </a:solidFill>
+                <a:latin typeface="微软雅黑"/>
+                <a:ea typeface="微软雅黑"/>
+                <a:cs typeface="微软雅黑"/>
+              </a:rPr>
+              <a:t>135,227</a:t>
+            </a:r>
+          </a:p>
+        </p:txBody>
+      </p:sp>
+      <p:sp>
+        <p:nvSpPr>
+          <p:cNvPr id="113" name="TextBox 112"/>
+          <p:cNvSpPr txBox="1"/>
+          <p:nvPr/>
+        </p:nvSpPr>
+        <p:spPr>
+          <a:xfrm>
+            <a:off x="4523232" y="5164074"/>
+            <a:ext cx="3291840" cy="61721"/>
+          </a:xfrm>
+          <a:prstGeom prst="rect">
+            <a:avLst/>
+          </a:prstGeom>
+          <a:noFill/>
+        </p:spPr>
+        <p:txBody>
+          <a:bodyPr wrap="square" lIns="0" rIns="0" tIns="0" bIns="0" anchor="t">
+            <a:spAutoFit/>
+          </a:bodyPr>
+          <a:lstStyle/>
+          <a:p>
+            <a:pPr algn="l">
+              <a:lnSpc>
+                <a:spcPct val="100000"/>
+              </a:lnSpc>
+            </a:pPr>
+            <a:r>
+              <a:rPr sz="620" b="0">
+                <a:solidFill>
+                  <a:srgbClr val="5B616B"/>
+                </a:solidFill>
+                <a:latin typeface="微软雅黑"/>
+                <a:ea typeface="微软雅黑"/>
+                <a:cs typeface="微软雅黑"/>
+              </a:rPr>
+              <a:t>user_69794d19</a:t>
+            </a:r>
+          </a:p>
+        </p:txBody>
+      </p:sp>
+      <p:sp>
+        <p:nvSpPr>
+          <p:cNvPr id="114" name="TextBox 113"/>
+          <p:cNvSpPr txBox="1"/>
+          <p:nvPr/>
+        </p:nvSpPr>
+        <p:spPr>
+          <a:xfrm>
+            <a:off x="4328160" y="5232653"/>
+            <a:ext cx="170688" cy="75438"/>
+          </a:xfrm>
+          <a:prstGeom prst="rect">
+            <a:avLst/>
+          </a:prstGeom>
+          <a:noFill/>
+        </p:spPr>
+        <p:txBody>
+          <a:bodyPr wrap="square" lIns="0" rIns="0" tIns="0" bIns="0" anchor="t">
+            <a:spAutoFit/>
+          </a:bodyPr>
+          <a:lstStyle/>
+          <a:p>
+            <a:pPr algn="l">
+              <a:lnSpc>
+                <a:spcPct val="100000"/>
+              </a:lnSpc>
+            </a:pPr>
+            <a:r>
+              <a:rPr sz="740" b="1">
+                <a:solidFill>
+                  <a:srgbClr val="B5333B"/>
+                </a:solidFill>
+                <a:latin typeface="微软雅黑"/>
+                <a:ea typeface="微软雅黑"/>
+                <a:cs typeface="微软雅黑"/>
+              </a:rPr>
+              <a:t>4</a:t>
+            </a:r>
+          </a:p>
+        </p:txBody>
+      </p:sp>
+      <p:sp>
+        <p:nvSpPr>
+          <p:cNvPr id="115" name="TextBox 114"/>
+          <p:cNvSpPr txBox="1"/>
+          <p:nvPr/>
+        </p:nvSpPr>
+        <p:spPr>
+          <a:xfrm>
+            <a:off x="4523232" y="5232653"/>
+            <a:ext cx="2621280" cy="75438"/>
+          </a:xfrm>
+          <a:prstGeom prst="rect">
+            <a:avLst/>
+          </a:prstGeom>
+          <a:noFill/>
+        </p:spPr>
+        <p:txBody>
+          <a:bodyPr wrap="square" lIns="0" rIns="0" tIns="0" bIns="0" anchor="t">
+            <a:spAutoFit/>
+          </a:bodyPr>
+          <a:lstStyle/>
+          <a:p>
+            <a:pPr algn="l">
+              <a:lnSpc>
+                <a:spcPct val="100000"/>
+              </a:lnSpc>
+            </a:pPr>
+            <a:r>
+              <a:rPr sz="720" b="1">
+                <a:solidFill>
+                  <a:srgbClr val="1A1A1C"/>
+                </a:solidFill>
+                <a:latin typeface="微软雅黑"/>
+                <a:ea typeface="微软雅黑"/>
+                <a:cs typeface="微软雅黑"/>
+              </a:rPr>
+              <a:t>知了标讯 · 全网招中标数据查询</a:t>
+            </a:r>
+          </a:p>
+        </p:txBody>
+      </p:sp>
+      <p:sp>
+        <p:nvSpPr>
+          <p:cNvPr id="116" name="TextBox 115"/>
+          <p:cNvSpPr txBox="1"/>
+          <p:nvPr/>
+        </p:nvSpPr>
+        <p:spPr>
+          <a:xfrm>
+            <a:off x="7229856" y="5232653"/>
+            <a:ext cx="609600" cy="75438"/>
+          </a:xfrm>
+          <a:prstGeom prst="rect">
+            <a:avLst/>
+          </a:prstGeom>
+          <a:noFill/>
+        </p:spPr>
+        <p:txBody>
+          <a:bodyPr wrap="square" lIns="0" rIns="0" tIns="0" bIns="0" anchor="t">
+            <a:spAutoFit/>
+          </a:bodyPr>
+          <a:lstStyle/>
+          <a:p>
+            <a:pPr algn="r">
+              <a:lnSpc>
+                <a:spcPct val="100000"/>
+              </a:lnSpc>
+            </a:pPr>
+            <a:r>
+              <a:rPr sz="720" b="0">
+                <a:solidFill>
+                  <a:srgbClr val="5B616B"/>
+                </a:solidFill>
+                <a:latin typeface="微软雅黑"/>
+                <a:ea typeface="微软雅黑"/>
+                <a:cs typeface="微软雅黑"/>
+              </a:rPr>
+              <a:t>82,636</a:t>
+            </a:r>
+          </a:p>
+        </p:txBody>
+      </p:sp>
+      <p:sp>
+        <p:nvSpPr>
+          <p:cNvPr id="117" name="TextBox 116"/>
+          <p:cNvSpPr txBox="1"/>
+          <p:nvPr/>
+        </p:nvSpPr>
+        <p:spPr>
+          <a:xfrm>
+            <a:off x="4523232" y="5335523"/>
+            <a:ext cx="3291840" cy="61721"/>
+          </a:xfrm>
+          <a:prstGeom prst="rect">
+            <a:avLst/>
+          </a:prstGeom>
+          <a:noFill/>
+        </p:spPr>
+        <p:txBody>
+          <a:bodyPr wrap="square" lIns="0" rIns="0" tIns="0" bIns="0" anchor="t">
+            <a:spAutoFit/>
+          </a:bodyPr>
+          <a:lstStyle/>
+          <a:p>
+            <a:pPr algn="l">
+              <a:lnSpc>
+                <a:spcPct val="100000"/>
+              </a:lnSpc>
+            </a:pPr>
+            <a:r>
+              <a:rPr sz="620" b="0">
+                <a:solidFill>
+                  <a:srgbClr val="5B616B"/>
+                </a:solidFill>
+                <a:latin typeface="微软雅黑"/>
+                <a:ea typeface="微软雅黑"/>
+                <a:cs typeface="微软雅黑"/>
+              </a:rPr>
+              <a:t>知了标讯</a:t>
+            </a:r>
+          </a:p>
+        </p:txBody>
+      </p:sp>
+      <p:sp>
+        <p:nvSpPr>
+          <p:cNvPr id="118" name="TextBox 117"/>
+          <p:cNvSpPr txBox="1"/>
+          <p:nvPr/>
+        </p:nvSpPr>
+        <p:spPr>
+          <a:xfrm>
+            <a:off x="4328160" y="5404103"/>
+            <a:ext cx="170688" cy="75438"/>
+          </a:xfrm>
+          <a:prstGeom prst="rect">
+            <a:avLst/>
+          </a:prstGeom>
+          <a:noFill/>
+        </p:spPr>
+        <p:txBody>
+          <a:bodyPr wrap="square" lIns="0" rIns="0" tIns="0" bIns="0" anchor="t">
+            <a:spAutoFit/>
+          </a:bodyPr>
+          <a:lstStyle/>
+          <a:p>
+            <a:pPr algn="l">
+              <a:lnSpc>
+                <a:spcPct val="100000"/>
+              </a:lnSpc>
+            </a:pPr>
+            <a:r>
+              <a:rPr sz="740" b="1">
+                <a:solidFill>
+                  <a:srgbClr val="B5333B"/>
+                </a:solidFill>
+                <a:latin typeface="微软雅黑"/>
+                <a:ea typeface="微软雅黑"/>
+                <a:cs typeface="微软雅黑"/>
+              </a:rPr>
+              <a:t>5</a:t>
+            </a:r>
+          </a:p>
+        </p:txBody>
+      </p:sp>
+      <p:sp>
+        <p:nvSpPr>
+          <p:cNvPr id="119" name="TextBox 118"/>
+          <p:cNvSpPr txBox="1"/>
+          <p:nvPr/>
+        </p:nvSpPr>
+        <p:spPr>
+          <a:xfrm>
+            <a:off x="4523232" y="5404103"/>
+            <a:ext cx="2621280" cy="75438"/>
+          </a:xfrm>
+          <a:prstGeom prst="rect">
+            <a:avLst/>
+          </a:prstGeom>
+          <a:noFill/>
+        </p:spPr>
+        <p:txBody>
+          <a:bodyPr wrap="square" lIns="0" rIns="0" tIns="0" bIns="0" anchor="t">
+            <a:spAutoFit/>
+          </a:bodyPr>
+          <a:lstStyle/>
+          <a:p>
+            <a:pPr algn="l">
+              <a:lnSpc>
+                <a:spcPct val="100000"/>
+              </a:lnSpc>
+            </a:pPr>
+            <a:r>
+              <a:rPr sz="720" b="1">
+                <a:solidFill>
+                  <a:srgbClr val="1A1A1C"/>
+                </a:solidFill>
+                <a:latin typeface="微软雅黑"/>
+                <a:ea typeface="微软雅黑"/>
+                <a:cs typeface="微软雅黑"/>
+              </a:rPr>
+              <a:t>标书审查【喜鹊标书】</a:t>
+            </a:r>
+          </a:p>
+        </p:txBody>
+      </p:sp>
+      <p:sp>
+        <p:nvSpPr>
+          <p:cNvPr id="120" name="TextBox 119"/>
+          <p:cNvSpPr txBox="1"/>
+          <p:nvPr/>
+        </p:nvSpPr>
+        <p:spPr>
+          <a:xfrm>
+            <a:off x="7229856" y="5404103"/>
+            <a:ext cx="609600" cy="75438"/>
+          </a:xfrm>
+          <a:prstGeom prst="rect">
+            <a:avLst/>
+          </a:prstGeom>
+          <a:noFill/>
+        </p:spPr>
+        <p:txBody>
+          <a:bodyPr wrap="square" lIns="0" rIns="0" tIns="0" bIns="0" anchor="t">
+            <a:spAutoFit/>
+          </a:bodyPr>
+          <a:lstStyle/>
+          <a:p>
+            <a:pPr algn="r">
+              <a:lnSpc>
+                <a:spcPct val="100000"/>
+              </a:lnSpc>
+            </a:pPr>
+            <a:r>
+              <a:rPr sz="720" b="0">
+                <a:solidFill>
+                  <a:srgbClr val="5B616B"/>
+                </a:solidFill>
+                <a:latin typeface="微软雅黑"/>
+                <a:ea typeface="微软雅黑"/>
+                <a:cs typeface="微软雅黑"/>
+              </a:rPr>
+              <a:t>80,948</a:t>
+            </a:r>
+          </a:p>
+        </p:txBody>
+      </p:sp>
+      <p:sp>
+        <p:nvSpPr>
+          <p:cNvPr id="121" name="TextBox 120"/>
+          <p:cNvSpPr txBox="1"/>
+          <p:nvPr/>
+        </p:nvSpPr>
+        <p:spPr>
+          <a:xfrm>
+            <a:off x="4523232" y="5506974"/>
+            <a:ext cx="3291840" cy="61721"/>
+          </a:xfrm>
+          <a:prstGeom prst="rect">
+            <a:avLst/>
+          </a:prstGeom>
+          <a:noFill/>
+        </p:spPr>
+        <p:txBody>
+          <a:bodyPr wrap="square" lIns="0" rIns="0" tIns="0" bIns="0" anchor="t">
+            <a:spAutoFit/>
+          </a:bodyPr>
+          <a:lstStyle/>
+          <a:p>
+            <a:pPr algn="l">
+              <a:lnSpc>
+                <a:spcPct val="100000"/>
+              </a:lnSpc>
+            </a:pPr>
+            <a:r>
+              <a:rPr sz="620" b="0">
+                <a:solidFill>
+                  <a:srgbClr val="5B616B"/>
+                </a:solidFill>
+                <a:latin typeface="微软雅黑"/>
+                <a:ea typeface="微软雅黑"/>
+                <a:cs typeface="微软雅黑"/>
+              </a:rPr>
+              <a:t>喜鹊AI</a:t>
+            </a:r>
+          </a:p>
+        </p:txBody>
+      </p:sp>
+      <p:sp>
+        <p:nvSpPr>
+          <p:cNvPr id="122" name="TextBox 121"/>
+          <p:cNvSpPr txBox="1"/>
+          <p:nvPr/>
+        </p:nvSpPr>
+        <p:spPr>
+          <a:xfrm>
+            <a:off x="4328160" y="5575554"/>
+            <a:ext cx="170688" cy="75438"/>
+          </a:xfrm>
+          <a:prstGeom prst="rect">
+            <a:avLst/>
+          </a:prstGeom>
+          <a:noFill/>
+        </p:spPr>
+        <p:txBody>
+          <a:bodyPr wrap="square" lIns="0" rIns="0" tIns="0" bIns="0" anchor="t">
+            <a:spAutoFit/>
+          </a:bodyPr>
+          <a:lstStyle/>
+          <a:p>
+            <a:pPr algn="l">
+              <a:lnSpc>
+                <a:spcPct val="100000"/>
+              </a:lnSpc>
+            </a:pPr>
+            <a:r>
+              <a:rPr sz="740" b="1">
+                <a:solidFill>
+                  <a:srgbClr val="B5333B"/>
+                </a:solidFill>
+                <a:latin typeface="微软雅黑"/>
+                <a:ea typeface="微软雅黑"/>
+                <a:cs typeface="微软雅黑"/>
+              </a:rPr>
+              <a:t>6</a:t>
+            </a:r>
+          </a:p>
+        </p:txBody>
+      </p:sp>
+      <p:sp>
+        <p:nvSpPr>
+          <p:cNvPr id="123" name="TextBox 122"/>
+          <p:cNvSpPr txBox="1"/>
+          <p:nvPr/>
+        </p:nvSpPr>
+        <p:spPr>
+          <a:xfrm>
+            <a:off x="4523232" y="5575554"/>
+            <a:ext cx="2621280" cy="75438"/>
+          </a:xfrm>
+          <a:prstGeom prst="rect">
+            <a:avLst/>
+          </a:prstGeom>
+          <a:noFill/>
+        </p:spPr>
+        <p:txBody>
+          <a:bodyPr wrap="square" lIns="0" rIns="0" tIns="0" bIns="0" anchor="t">
+            <a:spAutoFit/>
+          </a:bodyPr>
+          <a:lstStyle/>
+          <a:p>
+            <a:pPr algn="l">
+              <a:lnSpc>
+                <a:spcPct val="100000"/>
+              </a:lnSpc>
+            </a:pPr>
+            <a:r>
+              <a:rPr sz="720" b="1">
+                <a:solidFill>
+                  <a:srgbClr val="1A1A1C"/>
+                </a:solidFill>
+                <a:latin typeface="微软雅黑"/>
+                <a:ea typeface="微软雅黑"/>
+                <a:cs typeface="微软雅黑"/>
+              </a:rPr>
+              <a:t>浏览器自动化</a:t>
+            </a:r>
+          </a:p>
+        </p:txBody>
+      </p:sp>
+      <p:sp>
+        <p:nvSpPr>
+          <p:cNvPr id="124" name="TextBox 123"/>
+          <p:cNvSpPr txBox="1"/>
+          <p:nvPr/>
+        </p:nvSpPr>
+        <p:spPr>
+          <a:xfrm>
+            <a:off x="7229856" y="5575554"/>
+            <a:ext cx="609600" cy="75438"/>
+          </a:xfrm>
+          <a:prstGeom prst="rect">
+            <a:avLst/>
+          </a:prstGeom>
+          <a:noFill/>
+        </p:spPr>
+        <p:txBody>
+          <a:bodyPr wrap="square" lIns="0" rIns="0" tIns="0" bIns="0" anchor="t">
+            <a:spAutoFit/>
+          </a:bodyPr>
+          <a:lstStyle/>
+          <a:p>
+            <a:pPr algn="r">
+              <a:lnSpc>
+                <a:spcPct val="100000"/>
+              </a:lnSpc>
+            </a:pPr>
+            <a:r>
+              <a:rPr sz="720" b="0">
+                <a:solidFill>
+                  <a:srgbClr val="5B616B"/>
+                </a:solidFill>
+                <a:latin typeface="微软雅黑"/>
+                <a:ea typeface="微软雅黑"/>
+                <a:cs typeface="微软雅黑"/>
+              </a:rPr>
+              <a:t>66,947</a:t>
+            </a:r>
+          </a:p>
+        </p:txBody>
+      </p:sp>
+      <p:sp>
+        <p:nvSpPr>
+          <p:cNvPr id="125" name="TextBox 124"/>
+          <p:cNvSpPr txBox="1"/>
+          <p:nvPr/>
+        </p:nvSpPr>
+        <p:spPr>
+          <a:xfrm>
+            <a:off x="4523232" y="5678424"/>
+            <a:ext cx="3291840" cy="61721"/>
+          </a:xfrm>
+          <a:prstGeom prst="rect">
+            <a:avLst/>
+          </a:prstGeom>
+          <a:noFill/>
+        </p:spPr>
+        <p:txBody>
+          <a:bodyPr wrap="square" lIns="0" rIns="0" tIns="0" bIns="0" anchor="t">
+            <a:spAutoFit/>
+          </a:bodyPr>
+          <a:lstStyle/>
+          <a:p>
+            <a:pPr algn="l">
+              <a:lnSpc>
+                <a:spcPct val="100000"/>
+              </a:lnSpc>
+            </a:pPr>
+            <a:r>
+              <a:rPr sz="620" b="0">
+                <a:solidFill>
+                  <a:srgbClr val="5B616B"/>
+                </a:solidFill>
+                <a:latin typeface="微软雅黑"/>
+                <a:ea typeface="微软雅黑"/>
+                <a:cs typeface="微软雅黑"/>
+              </a:rPr>
+              <a:t>菏泽九有信息科技有限公司</a:t>
+            </a:r>
+          </a:p>
+        </p:txBody>
+      </p:sp>
+      <p:sp>
+        <p:nvSpPr>
+          <p:cNvPr id="126" name="TextBox 125"/>
+          <p:cNvSpPr txBox="1"/>
+          <p:nvPr/>
+        </p:nvSpPr>
+        <p:spPr>
+          <a:xfrm>
+            <a:off x="8229600" y="4594860"/>
+            <a:ext cx="3535679" cy="96012"/>
+          </a:xfrm>
+          <a:prstGeom prst="rect">
+            <a:avLst/>
+          </a:prstGeom>
+          <a:noFill/>
+        </p:spPr>
+        <p:txBody>
+          <a:bodyPr wrap="square" lIns="0" rIns="0" tIns="0" bIns="0" anchor="t">
+            <a:spAutoFit/>
+          </a:bodyPr>
+          <a:lstStyle/>
+          <a:p>
+            <a:pPr algn="l">
+              <a:lnSpc>
+                <a:spcPct val="100000"/>
+              </a:lnSpc>
+            </a:pPr>
+            <a:r>
+              <a:rPr sz="860" b="1">
+                <a:solidFill>
+                  <a:srgbClr val="6B7785"/>
+                </a:solidFill>
+                <a:latin typeface="微软雅黑"/>
+                <a:ea typeface="微软雅黑"/>
+                <a:cs typeface="微软雅黑"/>
+              </a:rPr>
+              <a:t>API Key Top6</a:t>
+            </a:r>
+          </a:p>
+        </p:txBody>
+      </p:sp>
+      <p:sp>
+        <p:nvSpPr>
+          <p:cNvPr id="127" name="Rectangle 126"/>
+          <p:cNvSpPr/>
+          <p:nvPr/>
+        </p:nvSpPr>
+        <p:spPr>
+          <a:xfrm>
+            <a:off x="8229600" y="4690872"/>
+            <a:ext cx="3535679" cy="5486"/>
+          </a:xfrm>
+          <a:prstGeom prst="rect">
+            <a:avLst/>
+          </a:prstGeom>
+          <a:solidFill>
+            <a:srgbClr val="E2E4E7"/>
+          </a:solidFill>
+          <a:ln>
+            <a:noFill/>
+          </a:ln>
+          <a:effectLst/>
+        </p:spPr>
+        <p:style>
+          <a:lnRef idx="1">
+            <a:schemeClr val="accent1"/>
+          </a:lnRef>
+          <a:fillRef idx="3">
+            <a:schemeClr val="accent1"/>
+          </a:fillRef>
+          <a:effectRef idx="2">
+            <a:schemeClr val="accent1"/>
+          </a:effectRef>
+          <a:fontRef idx="minor">
+            <a:schemeClr val="lt1"/>
+          </a:fontRef>
+        </p:style>
+        <p:txBody>
+          <a:bodyPr rtlCol="0" anchor="ctr"/>
+          <a:lstStyle/>
+          <a:p>
+            <a:pPr algn="ctr"/>
+          </a:p>
+        </p:txBody>
+      </p:sp>
+      <p:sp>
+        <p:nvSpPr>
+          <p:cNvPr id="128" name="TextBox 127"/>
+          <p:cNvSpPr txBox="1"/>
+          <p:nvPr/>
+        </p:nvSpPr>
+        <p:spPr>
+          <a:xfrm>
+            <a:off x="8229600" y="4718304"/>
+            <a:ext cx="170688" cy="75438"/>
+          </a:xfrm>
+          <a:prstGeom prst="rect">
+            <a:avLst/>
+          </a:prstGeom>
+          <a:noFill/>
+        </p:spPr>
+        <p:txBody>
+          <a:bodyPr wrap="square" lIns="0" rIns="0" tIns="0" bIns="0" anchor="t">
+            <a:spAutoFit/>
+          </a:bodyPr>
+          <a:lstStyle/>
+          <a:p>
+            <a:pPr algn="l">
+              <a:lnSpc>
+                <a:spcPct val="100000"/>
+              </a:lnSpc>
+            </a:pPr>
+            <a:r>
+              <a:rPr sz="740" b="1">
+                <a:solidFill>
+                  <a:srgbClr val="B5333B"/>
+                </a:solidFill>
+                <a:latin typeface="微软雅黑"/>
+                <a:ea typeface="微软雅黑"/>
+                <a:cs typeface="微软雅黑"/>
+              </a:rPr>
+              <a:t>1</a:t>
+            </a:r>
+          </a:p>
+        </p:txBody>
+      </p:sp>
+      <p:sp>
+        <p:nvSpPr>
+          <p:cNvPr id="129" name="TextBox 128"/>
+          <p:cNvSpPr txBox="1"/>
+          <p:nvPr/>
+        </p:nvSpPr>
+        <p:spPr>
+          <a:xfrm>
+            <a:off x="8424672" y="4718304"/>
+            <a:ext cx="2621280" cy="75438"/>
+          </a:xfrm>
+          <a:prstGeom prst="rect">
+            <a:avLst/>
+          </a:prstGeom>
+          <a:noFill/>
+        </p:spPr>
+        <p:txBody>
+          <a:bodyPr wrap="square" lIns="0" rIns="0" tIns="0" bIns="0" anchor="t">
+            <a:spAutoFit/>
+          </a:bodyPr>
+          <a:lstStyle/>
+          <a:p>
+            <a:pPr algn="l">
+              <a:lnSpc>
+                <a:spcPct val="100000"/>
+              </a:lnSpc>
+            </a:pPr>
+            <a:r>
+              <a:rPr sz="720" b="1">
+                <a:solidFill>
+                  <a:srgbClr val="1A1A1C"/>
+                </a:solidFill>
+                <a:latin typeface="微软雅黑"/>
+                <a:ea typeface="微软雅黑"/>
+                <a:cs typeface="微软雅黑"/>
+              </a:rPr>
+              <a:t>腾讯文档 TENCENT DOCS</a:t>
+            </a:r>
+          </a:p>
+        </p:txBody>
+      </p:sp>
+      <p:sp>
+        <p:nvSpPr>
+          <p:cNvPr id="130" name="TextBox 129"/>
+          <p:cNvSpPr txBox="1"/>
+          <p:nvPr/>
+        </p:nvSpPr>
+        <p:spPr>
+          <a:xfrm>
+            <a:off x="11131296" y="4718304"/>
+            <a:ext cx="609600" cy="75438"/>
+          </a:xfrm>
+          <a:prstGeom prst="rect">
+            <a:avLst/>
+          </a:prstGeom>
+          <a:noFill/>
+        </p:spPr>
+        <p:txBody>
+          <a:bodyPr wrap="square" lIns="0" rIns="0" tIns="0" bIns="0" anchor="t">
+            <a:spAutoFit/>
+          </a:bodyPr>
+          <a:lstStyle/>
+          <a:p>
+            <a:pPr algn="r">
+              <a:lnSpc>
+                <a:spcPct val="100000"/>
+              </a:lnSpc>
+            </a:pPr>
+            <a:r>
+              <a:rPr sz="720" b="0">
+                <a:solidFill>
+                  <a:srgbClr val="5B616B"/>
+                </a:solidFill>
+                <a:latin typeface="微软雅黑"/>
+                <a:ea typeface="微软雅黑"/>
+                <a:cs typeface="微软雅黑"/>
+              </a:rPr>
+              <a:t>1,824,922</a:t>
+            </a:r>
+          </a:p>
+        </p:txBody>
+      </p:sp>
+      <p:sp>
+        <p:nvSpPr>
+          <p:cNvPr id="131" name="TextBox 130"/>
+          <p:cNvSpPr txBox="1"/>
+          <p:nvPr/>
+        </p:nvSpPr>
+        <p:spPr>
+          <a:xfrm>
+            <a:off x="8424672" y="4821174"/>
+            <a:ext cx="3291840" cy="61721"/>
+          </a:xfrm>
+          <a:prstGeom prst="rect">
+            <a:avLst/>
+          </a:prstGeom>
+          <a:noFill/>
+        </p:spPr>
+        <p:txBody>
+          <a:bodyPr wrap="square" lIns="0" rIns="0" tIns="0" bIns="0" anchor="t">
+            <a:spAutoFit/>
+          </a:bodyPr>
+          <a:lstStyle/>
+          <a:p>
+            <a:pPr algn="l">
+              <a:lnSpc>
+                <a:spcPct val="100000"/>
+              </a:lnSpc>
+            </a:pPr>
+            <a:r>
+              <a:rPr sz="620" b="0">
+                <a:solidFill>
+                  <a:srgbClr val="5B616B"/>
+                </a:solidFill>
+                <a:latin typeface="微软雅黑"/>
+                <a:ea typeface="微软雅黑"/>
+                <a:cs typeface="微软雅黑"/>
+              </a:rPr>
+              <a:t>腾讯文档团队</a:t>
+            </a:r>
+          </a:p>
+        </p:txBody>
+      </p:sp>
+      <p:sp>
+        <p:nvSpPr>
+          <p:cNvPr id="132" name="TextBox 131"/>
+          <p:cNvSpPr txBox="1"/>
+          <p:nvPr/>
+        </p:nvSpPr>
+        <p:spPr>
+          <a:xfrm>
+            <a:off x="8229600" y="4889754"/>
+            <a:ext cx="170688" cy="75438"/>
+          </a:xfrm>
+          <a:prstGeom prst="rect">
+            <a:avLst/>
+          </a:prstGeom>
+          <a:noFill/>
+        </p:spPr>
+        <p:txBody>
+          <a:bodyPr wrap="square" lIns="0" rIns="0" tIns="0" bIns="0" anchor="t">
+            <a:spAutoFit/>
+          </a:bodyPr>
+          <a:lstStyle/>
+          <a:p>
+            <a:pPr algn="l">
+              <a:lnSpc>
+                <a:spcPct val="100000"/>
+              </a:lnSpc>
+            </a:pPr>
+            <a:r>
+              <a:rPr sz="740" b="1">
+                <a:solidFill>
+                  <a:srgbClr val="B5333B"/>
+                </a:solidFill>
+                <a:latin typeface="微软雅黑"/>
+                <a:ea typeface="微软雅黑"/>
+                <a:cs typeface="微软雅黑"/>
+              </a:rPr>
+              <a:t>2</a:t>
+            </a:r>
+          </a:p>
+        </p:txBody>
+      </p:sp>
+      <p:sp>
+        <p:nvSpPr>
+          <p:cNvPr id="133" name="TextBox 132"/>
+          <p:cNvSpPr txBox="1"/>
+          <p:nvPr/>
+        </p:nvSpPr>
+        <p:spPr>
+          <a:xfrm>
+            <a:off x="8424672" y="4889754"/>
+            <a:ext cx="2621280" cy="75438"/>
+          </a:xfrm>
+          <a:prstGeom prst="rect">
+            <a:avLst/>
+          </a:prstGeom>
+          <a:noFill/>
+        </p:spPr>
+        <p:txBody>
+          <a:bodyPr wrap="square" lIns="0" rIns="0" tIns="0" bIns="0" anchor="t">
+            <a:spAutoFit/>
+          </a:bodyPr>
+          <a:lstStyle/>
+          <a:p>
+            <a:pPr algn="l">
+              <a:lnSpc>
+                <a:spcPct val="100000"/>
+              </a:lnSpc>
+            </a:pPr>
+            <a:r>
+              <a:rPr sz="720" b="1">
+                <a:solidFill>
+                  <a:srgbClr val="1A1A1C"/>
+                </a:solidFill>
+                <a:latin typeface="微软雅黑"/>
+                <a:ea typeface="微软雅黑"/>
+                <a:cs typeface="微软雅黑"/>
+              </a:rPr>
+              <a:t>全国电子印章互认平台</a:t>
+            </a:r>
+          </a:p>
+        </p:txBody>
+      </p:sp>
+      <p:sp>
+        <p:nvSpPr>
+          <p:cNvPr id="134" name="TextBox 133"/>
+          <p:cNvSpPr txBox="1"/>
+          <p:nvPr/>
+        </p:nvSpPr>
+        <p:spPr>
+          <a:xfrm>
+            <a:off x="11131296" y="4889754"/>
+            <a:ext cx="609600" cy="75438"/>
+          </a:xfrm>
+          <a:prstGeom prst="rect">
+            <a:avLst/>
+          </a:prstGeom>
+          <a:noFill/>
+        </p:spPr>
+        <p:txBody>
+          <a:bodyPr wrap="square" lIns="0" rIns="0" tIns="0" bIns="0" anchor="t">
+            <a:spAutoFit/>
+          </a:bodyPr>
+          <a:lstStyle/>
+          <a:p>
+            <a:pPr algn="r">
+              <a:lnSpc>
+                <a:spcPct val="100000"/>
+              </a:lnSpc>
+            </a:pPr>
+            <a:r>
+              <a:rPr sz="720" b="0">
+                <a:solidFill>
+                  <a:srgbClr val="5B616B"/>
+                </a:solidFill>
+                <a:latin typeface="微软雅黑"/>
+                <a:ea typeface="微软雅黑"/>
+                <a:cs typeface="微软雅黑"/>
+              </a:rPr>
+              <a:t>1,033,084</a:t>
+            </a:r>
+          </a:p>
+        </p:txBody>
+      </p:sp>
+      <p:sp>
+        <p:nvSpPr>
+          <p:cNvPr id="135" name="TextBox 134"/>
+          <p:cNvSpPr txBox="1"/>
+          <p:nvPr/>
+        </p:nvSpPr>
+        <p:spPr>
+          <a:xfrm>
+            <a:off x="8424672" y="4992624"/>
+            <a:ext cx="3291840" cy="61721"/>
+          </a:xfrm>
+          <a:prstGeom prst="rect">
+            <a:avLst/>
+          </a:prstGeom>
+          <a:noFill/>
+        </p:spPr>
+        <p:txBody>
+          <a:bodyPr wrap="square" lIns="0" rIns="0" tIns="0" bIns="0" anchor="t">
+            <a:spAutoFit/>
+          </a:bodyPr>
+          <a:lstStyle/>
+          <a:p>
+            <a:pPr algn="l">
+              <a:lnSpc>
+                <a:spcPct val="100000"/>
+              </a:lnSpc>
+            </a:pPr>
+            <a:r>
+              <a:rPr sz="620" b="0">
+                <a:solidFill>
+                  <a:srgbClr val="5B616B"/>
+                </a:solidFill>
+                <a:latin typeface="微软雅黑"/>
+                <a:ea typeface="微软雅黑"/>
+                <a:cs typeface="微软雅黑"/>
+              </a:rPr>
+              <a:t>成都国信公链科技有限公司</a:t>
+            </a:r>
+          </a:p>
+        </p:txBody>
+      </p:sp>
+      <p:sp>
+        <p:nvSpPr>
+          <p:cNvPr id="136" name="TextBox 135"/>
+          <p:cNvSpPr txBox="1"/>
+          <p:nvPr/>
+        </p:nvSpPr>
+        <p:spPr>
+          <a:xfrm>
+            <a:off x="8229600" y="5061204"/>
+            <a:ext cx="170688" cy="75438"/>
+          </a:xfrm>
+          <a:prstGeom prst="rect">
+            <a:avLst/>
+          </a:prstGeom>
+          <a:noFill/>
+        </p:spPr>
+        <p:txBody>
+          <a:bodyPr wrap="square" lIns="0" rIns="0" tIns="0" bIns="0" anchor="t">
+            <a:spAutoFit/>
+          </a:bodyPr>
+          <a:lstStyle/>
+          <a:p>
+            <a:pPr algn="l">
+              <a:lnSpc>
+                <a:spcPct val="100000"/>
+              </a:lnSpc>
+            </a:pPr>
+            <a:r>
+              <a:rPr sz="740" b="1">
+                <a:solidFill>
+                  <a:srgbClr val="B5333B"/>
+                </a:solidFill>
+                <a:latin typeface="微软雅黑"/>
+                <a:ea typeface="微软雅黑"/>
+                <a:cs typeface="微软雅黑"/>
+              </a:rPr>
+              <a:t>3</a:t>
+            </a:r>
+          </a:p>
+        </p:txBody>
+      </p:sp>
+      <p:sp>
+        <p:nvSpPr>
+          <p:cNvPr id="137" name="TextBox 136"/>
+          <p:cNvSpPr txBox="1"/>
+          <p:nvPr/>
+        </p:nvSpPr>
+        <p:spPr>
+          <a:xfrm>
+            <a:off x="8424672" y="5061204"/>
+            <a:ext cx="2621280" cy="75438"/>
+          </a:xfrm>
+          <a:prstGeom prst="rect">
+            <a:avLst/>
+          </a:prstGeom>
+          <a:noFill/>
+        </p:spPr>
+        <p:txBody>
+          <a:bodyPr wrap="square" lIns="0" rIns="0" tIns="0" bIns="0" anchor="t">
+            <a:spAutoFit/>
+          </a:bodyPr>
+          <a:lstStyle/>
+          <a:p>
+            <a:pPr algn="l">
+              <a:lnSpc>
+                <a:spcPct val="100000"/>
+              </a:lnSpc>
+            </a:pPr>
+            <a:r>
+              <a:rPr sz="720" b="1">
+                <a:solidFill>
+                  <a:srgbClr val="1A1A1C"/>
+                </a:solidFill>
+                <a:latin typeface="微软雅黑"/>
+                <a:ea typeface="微软雅黑"/>
+                <a:cs typeface="微软雅黑"/>
+              </a:rPr>
+              <a:t>Summarize</a:t>
+            </a:r>
+          </a:p>
+        </p:txBody>
+      </p:sp>
+      <p:sp>
+        <p:nvSpPr>
+          <p:cNvPr id="138" name="TextBox 137"/>
+          <p:cNvSpPr txBox="1"/>
+          <p:nvPr/>
+        </p:nvSpPr>
+        <p:spPr>
+          <a:xfrm>
+            <a:off x="11131296" y="5061204"/>
+            <a:ext cx="609600" cy="75438"/>
+          </a:xfrm>
+          <a:prstGeom prst="rect">
+            <a:avLst/>
+          </a:prstGeom>
+          <a:noFill/>
+        </p:spPr>
+        <p:txBody>
+          <a:bodyPr wrap="square" lIns="0" rIns="0" tIns="0" bIns="0" anchor="t">
+            <a:spAutoFit/>
+          </a:bodyPr>
+          <a:lstStyle/>
+          <a:p>
+            <a:pPr algn="r">
+              <a:lnSpc>
+                <a:spcPct val="100000"/>
+              </a:lnSpc>
+            </a:pPr>
+            <a:r>
+              <a:rPr sz="720" b="0">
+                <a:solidFill>
+                  <a:srgbClr val="5B616B"/>
+                </a:solidFill>
+                <a:latin typeface="微软雅黑"/>
+                <a:ea typeface="微软雅黑"/>
+                <a:cs typeface="微软雅黑"/>
+              </a:rPr>
+              <a:t>765,618</a:t>
+            </a:r>
+          </a:p>
+        </p:txBody>
+      </p:sp>
+      <p:sp>
+        <p:nvSpPr>
+          <p:cNvPr id="139" name="TextBox 138"/>
+          <p:cNvSpPr txBox="1"/>
+          <p:nvPr/>
+        </p:nvSpPr>
+        <p:spPr>
+          <a:xfrm>
+            <a:off x="8424672" y="5164074"/>
+            <a:ext cx="3291840" cy="61721"/>
+          </a:xfrm>
+          <a:prstGeom prst="rect">
+            <a:avLst/>
+          </a:prstGeom>
+          <a:noFill/>
+        </p:spPr>
+        <p:txBody>
+          <a:bodyPr wrap="square" lIns="0" rIns="0" tIns="0" bIns="0" anchor="t">
+            <a:spAutoFit/>
+          </a:bodyPr>
+          <a:lstStyle/>
+          <a:p>
+            <a:pPr algn="l">
+              <a:lnSpc>
+                <a:spcPct val="100000"/>
+              </a:lnSpc>
+            </a:pPr>
+            <a:r>
+              <a:rPr sz="620" b="0">
+                <a:solidFill>
+                  <a:srgbClr val="5B616B"/>
+                </a:solidFill>
+                <a:latin typeface="微软雅黑"/>
+                <a:ea typeface="微软雅黑"/>
+                <a:cs typeface="微软雅黑"/>
+              </a:rPr>
+              <a:t>paudyyin</a:t>
+            </a:r>
+          </a:p>
+        </p:txBody>
+      </p:sp>
+      <p:sp>
+        <p:nvSpPr>
+          <p:cNvPr id="140" name="TextBox 139"/>
+          <p:cNvSpPr txBox="1"/>
+          <p:nvPr/>
+        </p:nvSpPr>
+        <p:spPr>
+          <a:xfrm>
+            <a:off x="8229600" y="5232653"/>
+            <a:ext cx="170688" cy="75438"/>
+          </a:xfrm>
+          <a:prstGeom prst="rect">
+            <a:avLst/>
+          </a:prstGeom>
+          <a:noFill/>
+        </p:spPr>
+        <p:txBody>
+          <a:bodyPr wrap="square" lIns="0" rIns="0" tIns="0" bIns="0" anchor="t">
+            <a:spAutoFit/>
+          </a:bodyPr>
+          <a:lstStyle/>
+          <a:p>
+            <a:pPr algn="l">
+              <a:lnSpc>
+                <a:spcPct val="100000"/>
+              </a:lnSpc>
+            </a:pPr>
+            <a:r>
+              <a:rPr sz="740" b="1">
+                <a:solidFill>
+                  <a:srgbClr val="B5333B"/>
+                </a:solidFill>
+                <a:latin typeface="微软雅黑"/>
+                <a:ea typeface="微软雅黑"/>
+                <a:cs typeface="微软雅黑"/>
+              </a:rPr>
+              <a:t>4</a:t>
+            </a:r>
+          </a:p>
+        </p:txBody>
+      </p:sp>
+      <p:sp>
+        <p:nvSpPr>
+          <p:cNvPr id="141" name="TextBox 140"/>
+          <p:cNvSpPr txBox="1"/>
+          <p:nvPr/>
+        </p:nvSpPr>
+        <p:spPr>
+          <a:xfrm>
+            <a:off x="8424672" y="5232653"/>
+            <a:ext cx="2621280" cy="75438"/>
+          </a:xfrm>
+          <a:prstGeom prst="rect">
+            <a:avLst/>
+          </a:prstGeom>
+          <a:noFill/>
+        </p:spPr>
+        <p:txBody>
+          <a:bodyPr wrap="square" lIns="0" rIns="0" tIns="0" bIns="0" anchor="t">
+            <a:spAutoFit/>
+          </a:bodyPr>
+          <a:lstStyle/>
+          <a:p>
+            <a:pPr algn="l">
+              <a:lnSpc>
+                <a:spcPct val="100000"/>
+              </a:lnSpc>
+            </a:pPr>
+            <a:r>
+              <a:rPr sz="690" b="1">
+                <a:solidFill>
+                  <a:srgbClr val="1A1A1C"/>
+                </a:solidFill>
+                <a:latin typeface="微软雅黑"/>
+                <a:ea typeface="微软雅黑"/>
+                <a:cs typeface="微软雅黑"/>
+              </a:rPr>
+              <a:t>视频号爆款短视频拆解（付费版：全能）【零一数科·出品】</a:t>
+            </a:r>
+          </a:p>
+        </p:txBody>
+      </p:sp>
+      <p:sp>
+        <p:nvSpPr>
+          <p:cNvPr id="142" name="TextBox 141"/>
+          <p:cNvSpPr txBox="1"/>
+          <p:nvPr/>
+        </p:nvSpPr>
+        <p:spPr>
+          <a:xfrm>
+            <a:off x="11131296" y="5232653"/>
+            <a:ext cx="609600" cy="75438"/>
+          </a:xfrm>
+          <a:prstGeom prst="rect">
+            <a:avLst/>
+          </a:prstGeom>
+          <a:noFill/>
+        </p:spPr>
+        <p:txBody>
+          <a:bodyPr wrap="square" lIns="0" rIns="0" tIns="0" bIns="0" anchor="t">
+            <a:spAutoFit/>
+          </a:bodyPr>
+          <a:lstStyle/>
+          <a:p>
+            <a:pPr algn="r">
+              <a:lnSpc>
+                <a:spcPct val="100000"/>
+              </a:lnSpc>
+            </a:pPr>
+            <a:r>
+              <a:rPr sz="720" b="0">
+                <a:solidFill>
+                  <a:srgbClr val="5B616B"/>
+                </a:solidFill>
+                <a:latin typeface="微软雅黑"/>
+                <a:ea typeface="微软雅黑"/>
+                <a:cs typeface="微软雅黑"/>
+              </a:rPr>
+              <a:t>690,517</a:t>
+            </a:r>
+          </a:p>
+        </p:txBody>
+      </p:sp>
+      <p:sp>
+        <p:nvSpPr>
+          <p:cNvPr id="143" name="TextBox 142"/>
+          <p:cNvSpPr txBox="1"/>
+          <p:nvPr/>
+        </p:nvSpPr>
+        <p:spPr>
+          <a:xfrm>
+            <a:off x="8424672" y="5335523"/>
+            <a:ext cx="3291840" cy="61721"/>
+          </a:xfrm>
+          <a:prstGeom prst="rect">
+            <a:avLst/>
+          </a:prstGeom>
+          <a:noFill/>
+        </p:spPr>
+        <p:txBody>
+          <a:bodyPr wrap="square" lIns="0" rIns="0" tIns="0" bIns="0" anchor="t">
+            <a:spAutoFit/>
+          </a:bodyPr>
+          <a:lstStyle/>
+          <a:p>
+            <a:pPr algn="l">
+              <a:lnSpc>
+                <a:spcPct val="100000"/>
+              </a:lnSpc>
+            </a:pPr>
+            <a:r>
+              <a:rPr sz="620" b="0">
+                <a:solidFill>
+                  <a:srgbClr val="5B616B"/>
+                </a:solidFill>
+                <a:latin typeface="微软雅黑"/>
+                <a:ea typeface="微软雅黑"/>
+                <a:cs typeface="微软雅黑"/>
+              </a:rPr>
+              <a:t>零一数科</a:t>
+            </a:r>
+          </a:p>
+        </p:txBody>
+      </p:sp>
+      <p:sp>
+        <p:nvSpPr>
+          <p:cNvPr id="144" name="TextBox 143"/>
+          <p:cNvSpPr txBox="1"/>
+          <p:nvPr/>
+        </p:nvSpPr>
+        <p:spPr>
+          <a:xfrm>
+            <a:off x="8229600" y="5404103"/>
+            <a:ext cx="170688" cy="75438"/>
+          </a:xfrm>
+          <a:prstGeom prst="rect">
+            <a:avLst/>
+          </a:prstGeom>
+          <a:noFill/>
+        </p:spPr>
+        <p:txBody>
+          <a:bodyPr wrap="square" lIns="0" rIns="0" tIns="0" bIns="0" anchor="t">
+            <a:spAutoFit/>
+          </a:bodyPr>
+          <a:lstStyle/>
+          <a:p>
+            <a:pPr algn="l">
+              <a:lnSpc>
+                <a:spcPct val="100000"/>
+              </a:lnSpc>
+            </a:pPr>
+            <a:r>
+              <a:rPr sz="740" b="1">
+                <a:solidFill>
+                  <a:srgbClr val="B5333B"/>
+                </a:solidFill>
+                <a:latin typeface="微软雅黑"/>
+                <a:ea typeface="微软雅黑"/>
+                <a:cs typeface="微软雅黑"/>
+              </a:rPr>
+              <a:t>5</a:t>
+            </a:r>
+          </a:p>
+        </p:txBody>
+      </p:sp>
+      <p:sp>
+        <p:nvSpPr>
+          <p:cNvPr id="145" name="TextBox 144"/>
+          <p:cNvSpPr txBox="1"/>
+          <p:nvPr/>
+        </p:nvSpPr>
+        <p:spPr>
+          <a:xfrm>
+            <a:off x="8424672" y="5404103"/>
+            <a:ext cx="2621280" cy="75438"/>
+          </a:xfrm>
+          <a:prstGeom prst="rect">
+            <a:avLst/>
+          </a:prstGeom>
+          <a:noFill/>
+        </p:spPr>
+        <p:txBody>
+          <a:bodyPr wrap="square" lIns="0" rIns="0" tIns="0" bIns="0" anchor="t">
+            <a:spAutoFit/>
+          </a:bodyPr>
+          <a:lstStyle/>
+          <a:p>
+            <a:pPr algn="l">
+              <a:lnSpc>
+                <a:spcPct val="100000"/>
+              </a:lnSpc>
+            </a:pPr>
+            <a:r>
+              <a:rPr sz="720" b="1">
+                <a:solidFill>
+                  <a:srgbClr val="1A1A1C"/>
+                </a:solidFill>
+                <a:latin typeface="微软雅黑"/>
+                <a:ea typeface="微软雅黑"/>
+                <a:cs typeface="微软雅黑"/>
+              </a:rPr>
+              <a:t>钢联AI - 智能问数</a:t>
+            </a:r>
+          </a:p>
+        </p:txBody>
+      </p:sp>
+      <p:sp>
+        <p:nvSpPr>
+          <p:cNvPr id="146" name="TextBox 145"/>
+          <p:cNvSpPr txBox="1"/>
+          <p:nvPr/>
+        </p:nvSpPr>
+        <p:spPr>
+          <a:xfrm>
+            <a:off x="11131296" y="5404103"/>
+            <a:ext cx="609600" cy="75438"/>
+          </a:xfrm>
+          <a:prstGeom prst="rect">
+            <a:avLst/>
+          </a:prstGeom>
+          <a:noFill/>
+        </p:spPr>
+        <p:txBody>
+          <a:bodyPr wrap="square" lIns="0" rIns="0" tIns="0" bIns="0" anchor="t">
+            <a:spAutoFit/>
+          </a:bodyPr>
+          <a:lstStyle/>
+          <a:p>
+            <a:pPr algn="r">
+              <a:lnSpc>
+                <a:spcPct val="100000"/>
+              </a:lnSpc>
+            </a:pPr>
+            <a:r>
+              <a:rPr sz="720" b="0">
+                <a:solidFill>
+                  <a:srgbClr val="5B616B"/>
+                </a:solidFill>
+                <a:latin typeface="微软雅黑"/>
+                <a:ea typeface="微软雅黑"/>
+                <a:cs typeface="微软雅黑"/>
+              </a:rPr>
+              <a:t>667,903</a:t>
+            </a:r>
+          </a:p>
+        </p:txBody>
+      </p:sp>
+      <p:sp>
+        <p:nvSpPr>
+          <p:cNvPr id="147" name="TextBox 146"/>
+          <p:cNvSpPr txBox="1"/>
+          <p:nvPr/>
+        </p:nvSpPr>
+        <p:spPr>
+          <a:xfrm>
+            <a:off x="8424672" y="5506974"/>
+            <a:ext cx="3291840" cy="61721"/>
+          </a:xfrm>
+          <a:prstGeom prst="rect">
+            <a:avLst/>
+          </a:prstGeom>
+          <a:noFill/>
+        </p:spPr>
+        <p:txBody>
+          <a:bodyPr wrap="square" lIns="0" rIns="0" tIns="0" bIns="0" anchor="t">
+            <a:spAutoFit/>
+          </a:bodyPr>
+          <a:lstStyle/>
+          <a:p>
+            <a:pPr algn="l">
+              <a:lnSpc>
+                <a:spcPct val="100000"/>
+              </a:lnSpc>
+            </a:pPr>
+            <a:r>
+              <a:rPr sz="620" b="0">
+                <a:solidFill>
+                  <a:srgbClr val="5B616B"/>
+                </a:solidFill>
+                <a:latin typeface="微软雅黑"/>
+                <a:ea typeface="微软雅黑"/>
+                <a:cs typeface="微软雅黑"/>
+              </a:rPr>
+              <a:t>上海钢联电子商务股份有限公司</a:t>
+            </a:r>
+          </a:p>
+        </p:txBody>
+      </p:sp>
+      <p:sp>
+        <p:nvSpPr>
+          <p:cNvPr id="148" name="TextBox 147"/>
+          <p:cNvSpPr txBox="1"/>
+          <p:nvPr/>
+        </p:nvSpPr>
+        <p:spPr>
+          <a:xfrm>
+            <a:off x="8229600" y="5575554"/>
+            <a:ext cx="170688" cy="75438"/>
+          </a:xfrm>
+          <a:prstGeom prst="rect">
+            <a:avLst/>
+          </a:prstGeom>
+          <a:noFill/>
+        </p:spPr>
+        <p:txBody>
+          <a:bodyPr wrap="square" lIns="0" rIns="0" tIns="0" bIns="0" anchor="t">
+            <a:spAutoFit/>
+          </a:bodyPr>
+          <a:lstStyle/>
+          <a:p>
+            <a:pPr algn="l">
+              <a:lnSpc>
+                <a:spcPct val="100000"/>
+              </a:lnSpc>
+            </a:pPr>
+            <a:r>
+              <a:rPr sz="740" b="1">
+                <a:solidFill>
+                  <a:srgbClr val="B5333B"/>
+                </a:solidFill>
+                <a:latin typeface="微软雅黑"/>
+                <a:ea typeface="微软雅黑"/>
+                <a:cs typeface="微软雅黑"/>
+              </a:rPr>
+              <a:t>6</a:t>
+            </a:r>
+          </a:p>
+        </p:txBody>
+      </p:sp>
+      <p:sp>
+        <p:nvSpPr>
+          <p:cNvPr id="149" name="TextBox 148"/>
+          <p:cNvSpPr txBox="1"/>
+          <p:nvPr/>
+        </p:nvSpPr>
+        <p:spPr>
+          <a:xfrm>
+            <a:off x="8424672" y="5575554"/>
+            <a:ext cx="2621280" cy="75438"/>
+          </a:xfrm>
+          <a:prstGeom prst="rect">
+            <a:avLst/>
+          </a:prstGeom>
+          <a:noFill/>
+        </p:spPr>
+        <p:txBody>
+          <a:bodyPr wrap="square" lIns="0" rIns="0" tIns="0" bIns="0" anchor="t">
+            <a:spAutoFit/>
+          </a:bodyPr>
+          <a:lstStyle/>
+          <a:p>
+            <a:pPr algn="l">
+              <a:lnSpc>
+                <a:spcPct val="100000"/>
+              </a:lnSpc>
+            </a:pPr>
+            <a:r>
+              <a:rPr sz="720" b="1">
+                <a:solidFill>
+                  <a:srgbClr val="1A1A1C"/>
+                </a:solidFill>
+                <a:latin typeface="微软雅黑"/>
+                <a:ea typeface="微软雅黑"/>
+                <a:cs typeface="微软雅黑"/>
+              </a:rPr>
+              <a:t>ima-skills</a:t>
+            </a:r>
+          </a:p>
+        </p:txBody>
+      </p:sp>
+      <p:sp>
+        <p:nvSpPr>
+          <p:cNvPr id="150" name="TextBox 149"/>
+          <p:cNvSpPr txBox="1"/>
+          <p:nvPr/>
+        </p:nvSpPr>
+        <p:spPr>
+          <a:xfrm>
+            <a:off x="11131296" y="5575554"/>
+            <a:ext cx="609600" cy="75438"/>
+          </a:xfrm>
+          <a:prstGeom prst="rect">
+            <a:avLst/>
+          </a:prstGeom>
+          <a:noFill/>
+        </p:spPr>
+        <p:txBody>
+          <a:bodyPr wrap="square" lIns="0" rIns="0" tIns="0" bIns="0" anchor="t">
+            <a:spAutoFit/>
+          </a:bodyPr>
+          <a:lstStyle/>
+          <a:p>
+            <a:pPr algn="r">
+              <a:lnSpc>
+                <a:spcPct val="100000"/>
+              </a:lnSpc>
+            </a:pPr>
+            <a:r>
+              <a:rPr sz="720" b="0">
+                <a:solidFill>
+                  <a:srgbClr val="5B616B"/>
+                </a:solidFill>
+                <a:latin typeface="微软雅黑"/>
+                <a:ea typeface="微软雅黑"/>
+                <a:cs typeface="微软雅黑"/>
+              </a:rPr>
+              <a:t>663,062</a:t>
+            </a:r>
+          </a:p>
+        </p:txBody>
+      </p:sp>
+      <p:sp>
+        <p:nvSpPr>
+          <p:cNvPr id="151" name="TextBox 150"/>
+          <p:cNvSpPr txBox="1"/>
+          <p:nvPr/>
+        </p:nvSpPr>
+        <p:spPr>
+          <a:xfrm>
+            <a:off x="8424672" y="5678424"/>
+            <a:ext cx="3291840" cy="61721"/>
+          </a:xfrm>
+          <a:prstGeom prst="rect">
+            <a:avLst/>
+          </a:prstGeom>
+          <a:noFill/>
+        </p:spPr>
+        <p:txBody>
+          <a:bodyPr wrap="square" lIns="0" rIns="0" tIns="0" bIns="0" anchor="t">
+            <a:spAutoFit/>
+          </a:bodyPr>
+          <a:lstStyle/>
+          <a:p>
+            <a:pPr algn="l">
+              <a:lnSpc>
+                <a:spcPct val="100000"/>
+              </a:lnSpc>
+            </a:pPr>
+            <a:r>
+              <a:rPr sz="620" b="0">
+                <a:solidFill>
+                  <a:srgbClr val="5B616B"/>
+                </a:solidFill>
+                <a:latin typeface="微软雅黑"/>
+                <a:ea typeface="微软雅黑"/>
+                <a:cs typeface="微软雅黑"/>
+              </a:rPr>
+              <a:t>tencent-ima</a:t>
+            </a:r>
+          </a:p>
+        </p:txBody>
+      </p:sp>
+      <p:sp>
+        <p:nvSpPr>
+          <p:cNvPr id="152" name="TextBox 151"/>
+          <p:cNvSpPr txBox="1"/>
+          <p:nvPr/>
+        </p:nvSpPr>
+        <p:spPr>
+          <a:xfrm>
+            <a:off x="426720" y="5863590"/>
+            <a:ext cx="11338560" cy="178308"/>
+          </a:xfrm>
+          <a:prstGeom prst="rect">
+            <a:avLst/>
+          </a:prstGeom>
+          <a:noFill/>
+        </p:spPr>
+        <p:txBody>
+          <a:bodyPr wrap="square" lIns="0" rIns="0" tIns="0" bIns="0" anchor="t">
+            <a:spAutoFit/>
+          </a:bodyPr>
+          <a:lstStyle/>
+          <a:p>
+            <a:pPr algn="l">
+              <a:lnSpc>
+                <a:spcPct val="100000"/>
+              </a:lnSpc>
+            </a:pPr>
+            <a:r>
+              <a:rPr sz="950" b="0">
+                <a:solidFill>
+                  <a:srgbClr val="5B616B"/>
+                </a:solidFill>
+                <a:latin typeface="微软雅黑"/>
+                <a:ea typeface="微软雅黑"/>
+                <a:cs typeface="微软雅黑"/>
+              </a:rPr>
+              <a:t>免费拿走了头部下载；Payskill 是付费标签，API Key 是接入要求，两者可同时成立。</a:t>
             </a:r>
           </a:p>
         </p:txBody>

</xml_diff>

<commit_message>
Match SkillPay sequence diagram to SkillHub flow style
</commit_message>
<xml_diff>
--- a/skill-final-v1.pptx
+++ b/skill-final-v1.pptx
@@ -5360,1281 +5360,6 @@
           </a:p>
         </p:txBody>
       </p:sp>
-      <p:sp>
-        <p:nvSpPr>
-          <p:cNvPr id="24" name="文字 24"/>
-          <p:cNvSpPr txBox="1"/>
-          <p:nvPr/>
-        </p:nvSpPr>
-        <p:spPr>
-          <a:xfrm>
-            <a:off x="457200" y="1954510"/>
-            <a:ext cx="2584450" cy="247650"/>
-          </a:xfrm>
-          <a:prstGeom prst="rect">
-            <a:avLst/>
-          </a:prstGeom>
-          <a:noFill/>
-          <a:ln>
-            <a:noFill/>
-          </a:ln>
-        </p:spPr>
-        <p:txBody>
-          <a:bodyPr wrap="none" anchor="t" lIns="0" tIns="0" rIns="0" bIns="0">
-            <a:noAutofit/>
-          </a:bodyPr>
-          <a:lstStyle/>
-          <a:p>
-            <a:pPr algn="l" marL="0" marR="0" indent="0">
-              <a:spcBef>
-                <a:spcPts val="0"/>
-              </a:spcBef>
-              <a:spcAft>
-                <a:spcPts val="0"/>
-              </a:spcAft>
-              <a:buNone/>
-              <a:defRPr sz="1200" b="1">
-                <a:latin typeface="微软雅黑"/>
-              </a:defRPr>
-            </a:pPr>
-            <a:r>
-              <a:rPr sz="1200" b="1" i="0" u="none" spc="-50">
-                <a:solidFill>
-                  <a:srgbClr val="1A1A1C">
-                    <a:alpha val="100000"/>
-                  </a:srgbClr>
-                </a:solidFill>
-                <a:latin typeface="微软雅黑"/>
-                <a:ea typeface="微软雅黑"/>
-                <a:cs typeface="微软雅黑"/>
-              </a:rPr>
-              <a:t xml:space="preserve">同一购买握手，取得不同商品权益</a:t>
-            </a:r>
-            <a:endParaRPr/>
-          </a:p>
-        </p:txBody>
-      </p:sp>
-      <p:sp>
-        <p:nvSpPr>
-          <p:cNvPr id="25" name="形状 25"/>
-          <p:cNvSpPr/>
-          <p:nvPr/>
-        </p:nvSpPr>
-        <p:spPr>
-          <a:xfrm>
-            <a:off x="457200" y="2341860"/>
-            <a:ext cx="1460500" cy="647700"/>
-          </a:xfrm>
-          <a:prstGeom prst="roundRect">
-            <a:avLst>
-              <a:gd name="adj" fmla="val 13725"/>
-            </a:avLst>
-          </a:prstGeom>
-          <a:solidFill>
-            <a:srgbClr val="FFFFFF">
-              <a:alpha val="100000"/>
-            </a:srgbClr>
-          </a:solidFill>
-          <a:ln w="6350">
-            <a:solidFill>
-              <a:srgbClr val="D9DDE2">
-                <a:alpha val="100000"/>
-              </a:srgbClr>
-            </a:solidFill>
-            <a:prstDash val="solid"/>
-          </a:ln>
-        </p:spPr>
-        <p:txBody>
-          <a:bodyPr/>
-          <a:p/>
-        </p:txBody>
-      </p:sp>
-      <p:sp>
-        <p:nvSpPr>
-          <p:cNvPr id="26" name="文字 26"/>
-          <p:cNvSpPr txBox="1"/>
-          <p:nvPr/>
-        </p:nvSpPr>
-        <p:spPr>
-          <a:xfrm>
-            <a:off x="647700" y="2456160"/>
-            <a:ext cx="1092101" cy="222250"/>
-          </a:xfrm>
-          <a:prstGeom prst="rect">
-            <a:avLst/>
-          </a:prstGeom>
-          <a:noFill/>
-          <a:ln>
-            <a:noFill/>
-          </a:ln>
-        </p:spPr>
-        <p:txBody>
-          <a:bodyPr wrap="none" anchor="t" lIns="0" tIns="0" rIns="0" bIns="0">
-            <a:noAutofit/>
-          </a:bodyPr>
-          <a:lstStyle/>
-          <a:p>
-            <a:pPr algn="l" marL="0" marR="0" indent="0">
-              <a:spcBef>
-                <a:spcPts val="0"/>
-              </a:spcBef>
-              <a:spcAft>
-                <a:spcPts val="0"/>
-              </a:spcAft>
-              <a:buNone/>
-              <a:defRPr sz="1000">
-                <a:latin typeface="微软雅黑"/>
-              </a:defRPr>
-            </a:pPr>
-            <a:r>
-              <a:rPr sz="1000" b="1" i="0" u="none" spc="-100">
-                <a:solidFill>
-                  <a:srgbClr val="1A1A1C">
-                    <a:alpha val="100000"/>
-                  </a:srgbClr>
-                </a:solidFill>
-                <a:latin typeface="微软雅黑"/>
-                <a:ea typeface="微软雅黑"/>
-                <a:cs typeface="微软雅黑"/>
-              </a:rPr>
-              <a:t xml:space="preserve">Agent 请求资源</a:t>
-            </a:r>
-            <a:endParaRPr/>
-          </a:p>
-        </p:txBody>
-      </p:sp>
-      <p:sp>
-        <p:nvSpPr>
-          <p:cNvPr id="27" name="文字 27"/>
-          <p:cNvSpPr txBox="1"/>
-          <p:nvPr/>
-        </p:nvSpPr>
-        <p:spPr>
-          <a:xfrm>
-            <a:off x="787400" y="2705001"/>
-            <a:ext cx="812800" cy="190500"/>
-          </a:xfrm>
-          <a:prstGeom prst="rect">
-            <a:avLst/>
-          </a:prstGeom>
-          <a:noFill/>
-          <a:ln>
-            <a:noFill/>
-          </a:ln>
-        </p:spPr>
-        <p:txBody>
-          <a:bodyPr wrap="none" anchor="t" lIns="0" tIns="0" rIns="0" bIns="0">
-            <a:noAutofit/>
-          </a:bodyPr>
-          <a:lstStyle/>
-          <a:p>
-            <a:pPr algn="l" marL="0" marR="0" indent="0">
-              <a:spcBef>
-                <a:spcPts val="0"/>
-              </a:spcBef>
-              <a:spcAft>
-                <a:spcPts val="0"/>
-              </a:spcAft>
-              <a:buNone/>
-              <a:defRPr sz="1000">
-                <a:latin typeface="微软雅黑"/>
-              </a:defRPr>
-            </a:pPr>
-            <a:r>
-              <a:rPr sz="1000" b="0" i="0" u="none" spc="-100">
-                <a:solidFill>
-                  <a:srgbClr val="585860">
-                    <a:alpha val="100000"/>
-                  </a:srgbClr>
-                </a:solidFill>
-                <a:latin typeface="微软雅黑"/>
-                <a:ea typeface="微软雅黑"/>
-                <a:cs typeface="微软雅黑"/>
-              </a:rPr>
-              <a:t xml:space="preserve">没有有效权益</a:t>
-            </a:r>
-            <a:endParaRPr/>
-          </a:p>
-        </p:txBody>
-      </p:sp>
-      <p:cxnSp>
-        <p:nvCxnSpPr>
-          <p:cNvPr id="28" name="Editable line 28"/>
-          <p:cNvCxnSpPr/>
-          <p:nvPr/>
-        </p:nvCxnSpPr>
-        <p:spPr>
-          <a:xfrm>
-            <a:off x="1920946" y="2673118"/>
-            <a:ext cx="574463" cy="0"/>
-          </a:xfrm>
-          <a:prstGeom prst="line">
-            <a:avLst/>
-          </a:prstGeom>
-          <a:ln w="8226" cap="flat">
-            <a:solidFill>
-              <a:srgbClr val="566472"/>
-            </a:solidFill>
-            <a:prstDash val="solid"/>
-          </a:ln>
-        </p:spPr>
-      </p:cxnSp>
-      <p:sp>
-        <p:nvSpPr>
-          <p:cNvPr id="29" name="文字 29"/>
-          <p:cNvSpPr/>
-          <p:nvPr/>
-        </p:nvSpPr>
-        <p:spPr>
-          <a:xfrm rot="5400000">
-            <a:off x="2413000" y="2633960"/>
-            <a:ext cx="88900" cy="88900"/>
-          </a:xfrm>
-          <a:prstGeom prst="triangle">
-            <a:avLst/>
-          </a:prstGeom>
-          <a:solidFill>
-            <a:srgbClr val="566472"/>
-          </a:solidFill>
-          <a:ln>
-            <a:noFill/>
-          </a:ln>
-        </p:spPr>
-        <p:txBody>
-          <a:bodyPr/>
-          <a:p/>
-        </p:txBody>
-      </p:sp>
-      <p:sp>
-        <p:nvSpPr>
-          <p:cNvPr id="30" name="形状 30"/>
-          <p:cNvSpPr/>
-          <p:nvPr/>
-        </p:nvSpPr>
-        <p:spPr>
-          <a:xfrm>
-            <a:off x="2501900" y="2341860"/>
-            <a:ext cx="1765300" cy="647700"/>
-          </a:xfrm>
-          <a:prstGeom prst="roundRect">
-            <a:avLst>
-              <a:gd name="adj" fmla="val 13725"/>
-            </a:avLst>
-          </a:prstGeom>
-          <a:solidFill>
-            <a:srgbClr val="FFFFFF">
-              <a:alpha val="100000"/>
-            </a:srgbClr>
-          </a:solidFill>
-          <a:ln w="6350">
-            <a:solidFill>
-              <a:srgbClr val="D9DDE2">
-                <a:alpha val="100000"/>
-              </a:srgbClr>
-            </a:solidFill>
-            <a:prstDash val="solid"/>
-          </a:ln>
-        </p:spPr>
-        <p:txBody>
-          <a:bodyPr/>
-          <a:p/>
-        </p:txBody>
-      </p:sp>
-      <p:sp>
-        <p:nvSpPr>
-          <p:cNvPr id="31" name="文字 31"/>
-          <p:cNvSpPr txBox="1"/>
-          <p:nvPr/>
-        </p:nvSpPr>
-        <p:spPr>
-          <a:xfrm>
-            <a:off x="2865338" y="2456160"/>
-            <a:ext cx="1051024" cy="222250"/>
-          </a:xfrm>
-          <a:prstGeom prst="rect">
-            <a:avLst/>
-          </a:prstGeom>
-          <a:noFill/>
-          <a:ln>
-            <a:noFill/>
-          </a:ln>
-        </p:spPr>
-        <p:txBody>
-          <a:bodyPr wrap="none" anchor="t" lIns="0" tIns="0" rIns="0" bIns="0">
-            <a:noAutofit/>
-          </a:bodyPr>
-          <a:lstStyle/>
-          <a:p>
-            <a:pPr algn="l" marL="0" marR="0" indent="0">
-              <a:spcBef>
-                <a:spcPts val="0"/>
-              </a:spcBef>
-              <a:spcAft>
-                <a:spcPts val="0"/>
-              </a:spcAft>
-              <a:buNone/>
-              <a:defRPr sz="1000">
-                <a:latin typeface="微软雅黑"/>
-              </a:defRPr>
-            </a:pPr>
-            <a:r>
-              <a:rPr sz="1000" b="1" i="0" u="none" spc="-100">
-                <a:solidFill>
-                  <a:srgbClr val="1A1A1C">
-                    <a:alpha val="100000"/>
-                  </a:srgbClr>
-                </a:solidFill>
-                <a:latin typeface="微软雅黑"/>
-                <a:ea typeface="微软雅黑"/>
-                <a:cs typeface="微软雅黑"/>
-              </a:rPr>
-              <a:t xml:space="preserve">402 + 付款要求</a:t>
-            </a:r>
-            <a:endParaRPr/>
-          </a:p>
-        </p:txBody>
-      </p:sp>
-      <p:sp>
-        <p:nvSpPr>
-          <p:cNvPr id="32" name="文字 32"/>
-          <p:cNvSpPr txBox="1"/>
-          <p:nvPr/>
-        </p:nvSpPr>
-        <p:spPr>
-          <a:xfrm>
-            <a:off x="2851150" y="2705001"/>
-            <a:ext cx="1079500" cy="190500"/>
-          </a:xfrm>
-          <a:prstGeom prst="rect">
-            <a:avLst/>
-          </a:prstGeom>
-          <a:noFill/>
-          <a:ln>
-            <a:noFill/>
-          </a:ln>
-        </p:spPr>
-        <p:txBody>
-          <a:bodyPr wrap="none" anchor="t" lIns="0" tIns="0" rIns="0" bIns="0">
-            <a:noAutofit/>
-          </a:bodyPr>
-          <a:lstStyle/>
-          <a:p>
-            <a:pPr algn="l" marL="0" marR="0" indent="0">
-              <a:spcBef>
-                <a:spcPts val="0"/>
-              </a:spcBef>
-              <a:spcAft>
-                <a:spcPts val="0"/>
-              </a:spcAft>
-              <a:buNone/>
-              <a:defRPr sz="1000">
-                <a:latin typeface="微软雅黑"/>
-              </a:defRPr>
-            </a:pPr>
-            <a:r>
-              <a:rPr sz="1000" b="0" i="0" u="none" spc="-100">
-                <a:solidFill>
-                  <a:srgbClr val="585860">
-                    <a:alpha val="100000"/>
-                  </a:srgbClr>
-                </a:solidFill>
-                <a:latin typeface="微软雅黑"/>
-                <a:ea typeface="微软雅黑"/>
-                <a:cs typeface="微软雅黑"/>
-              </a:rPr>
-              <a:t xml:space="preserve">保留原请求上下文</a:t>
-            </a:r>
-            <a:endParaRPr/>
-          </a:p>
-        </p:txBody>
-      </p:sp>
-      <p:cxnSp>
-        <p:nvCxnSpPr>
-          <p:cNvPr id="33" name="Editable line 33"/>
-          <p:cNvCxnSpPr/>
-          <p:nvPr/>
-        </p:nvCxnSpPr>
-        <p:spPr>
-          <a:xfrm>
-            <a:off x="4270447" y="2673118"/>
-            <a:ext cx="565006" cy="0"/>
-          </a:xfrm>
-          <a:prstGeom prst="line">
-            <a:avLst/>
-          </a:prstGeom>
-          <a:ln w="8226" cap="flat">
-            <a:solidFill>
-              <a:srgbClr val="566472"/>
-            </a:solidFill>
-            <a:prstDash val="solid"/>
-          </a:ln>
-        </p:spPr>
-      </p:cxnSp>
-      <p:sp>
-        <p:nvSpPr>
-          <p:cNvPr id="34" name="文字 34"/>
-          <p:cNvSpPr/>
-          <p:nvPr/>
-        </p:nvSpPr>
-        <p:spPr>
-          <a:xfrm rot="5400000">
-            <a:off x="4749800" y="2633960"/>
-            <a:ext cx="88900" cy="88900"/>
-          </a:xfrm>
-          <a:prstGeom prst="triangle">
-            <a:avLst/>
-          </a:prstGeom>
-          <a:solidFill>
-            <a:srgbClr val="566472"/>
-          </a:solidFill>
-          <a:ln>
-            <a:noFill/>
-          </a:ln>
-        </p:spPr>
-        <p:txBody>
-          <a:bodyPr/>
-          <a:p/>
-        </p:txBody>
-      </p:sp>
-      <p:sp>
-        <p:nvSpPr>
-          <p:cNvPr id="35" name="形状 35"/>
-          <p:cNvSpPr/>
-          <p:nvPr/>
-        </p:nvSpPr>
-        <p:spPr>
-          <a:xfrm>
-            <a:off x="4838700" y="2341860"/>
-            <a:ext cx="2603500" cy="647700"/>
-          </a:xfrm>
-          <a:prstGeom prst="roundRect">
-            <a:avLst>
-              <a:gd name="adj" fmla="val 13725"/>
-            </a:avLst>
-          </a:prstGeom>
-          <a:solidFill>
-            <a:srgbClr val="FFFFFF">
-              <a:alpha val="100000"/>
-            </a:srgbClr>
-          </a:solidFill>
-          <a:ln w="6350">
-            <a:solidFill>
-              <a:srgbClr val="D9DDE2">
-                <a:alpha val="100000"/>
-              </a:srgbClr>
-            </a:solidFill>
-            <a:prstDash val="solid"/>
-          </a:ln>
-        </p:spPr>
-        <p:txBody>
-          <a:bodyPr/>
-          <a:p/>
-        </p:txBody>
-      </p:sp>
-      <p:sp>
-        <p:nvSpPr>
-          <p:cNvPr id="36" name="文字 36"/>
-          <p:cNvSpPr txBox="1"/>
-          <p:nvPr/>
-        </p:nvSpPr>
-        <p:spPr>
-          <a:xfrm>
-            <a:off x="5302250" y="2456160"/>
-            <a:ext cx="1689100" cy="222250"/>
-          </a:xfrm>
-          <a:prstGeom prst="rect">
-            <a:avLst/>
-          </a:prstGeom>
-          <a:noFill/>
-          <a:ln>
-            <a:noFill/>
-          </a:ln>
-        </p:spPr>
-        <p:txBody>
-          <a:bodyPr wrap="none" anchor="t" lIns="0" tIns="0" rIns="0" bIns="0">
-            <a:noAutofit/>
-          </a:bodyPr>
-          <a:lstStyle/>
-          <a:p>
-            <a:pPr algn="l" marL="0" marR="0" indent="0">
-              <a:spcBef>
-                <a:spcPts val="0"/>
-              </a:spcBef>
-              <a:spcAft>
-                <a:spcPts val="0"/>
-              </a:spcAft>
-              <a:buNone/>
-              <a:defRPr sz="1000">
-                <a:latin typeface="微软雅黑"/>
-              </a:defRPr>
-            </a:pPr>
-            <a:r>
-              <a:rPr sz="1000" b="1" i="0" u="none" spc="-100">
-                <a:solidFill>
-                  <a:srgbClr val="1A1A1C">
-                    <a:alpha val="100000"/>
-                  </a:srgbClr>
-                </a:solidFill>
-                <a:latin typeface="微软雅黑"/>
-                <a:ea typeface="微软雅黑"/>
-                <a:cs typeface="微软雅黑"/>
-              </a:rPr>
-              <a:t xml:space="preserve">支付宝付款后恢复原请求</a:t>
-            </a:r>
-            <a:endParaRPr/>
-          </a:p>
-        </p:txBody>
-      </p:sp>
-      <p:sp>
-        <p:nvSpPr>
-          <p:cNvPr id="37" name="文字 37"/>
-          <p:cNvSpPr txBox="1"/>
-          <p:nvPr/>
-        </p:nvSpPr>
-        <p:spPr>
-          <a:xfrm>
-            <a:off x="5414863" y="2705001"/>
-            <a:ext cx="1463775" cy="190500"/>
-          </a:xfrm>
-          <a:prstGeom prst="rect">
-            <a:avLst/>
-          </a:prstGeom>
-          <a:noFill/>
-          <a:ln>
-            <a:noFill/>
-          </a:ln>
-        </p:spPr>
-        <p:txBody>
-          <a:bodyPr wrap="none" anchor="t" lIns="0" tIns="0" rIns="0" bIns="0">
-            <a:noAutofit/>
-          </a:bodyPr>
-          <a:lstStyle/>
-          <a:p>
-            <a:pPr algn="l" marL="0" marR="0" indent="0">
-              <a:spcBef>
-                <a:spcPts val="0"/>
-              </a:spcBef>
-              <a:spcAft>
-                <a:spcPts val="0"/>
-              </a:spcAft>
-              <a:buNone/>
-              <a:defRPr sz="1000">
-                <a:latin typeface="微软雅黑"/>
-              </a:defRPr>
-            </a:pPr>
-            <a:r>
-              <a:rPr sz="1000" b="0" i="0" u="none" spc="-100">
-                <a:solidFill>
-                  <a:srgbClr val="585860">
-                    <a:alpha val="100000"/>
-                  </a:srgbClr>
-                </a:solidFill>
-                <a:latin typeface="微软雅黑"/>
-                <a:ea typeface="微软雅黑"/>
-                <a:cs typeface="微软雅黑"/>
-              </a:rPr>
-              <a:t xml:space="preserve">SkillPay 验付并建立权益</a:t>
-            </a:r>
-            <a:endParaRPr/>
-          </a:p>
-        </p:txBody>
-      </p:sp>
-      <p:cxnSp>
-        <p:nvCxnSpPr>
-          <p:cNvPr id="38" name="Editable line 38"/>
-          <p:cNvCxnSpPr/>
-          <p:nvPr/>
-        </p:nvCxnSpPr>
-        <p:spPr>
-          <a:xfrm>
-            <a:off x="6147858" y="2992793"/>
-            <a:ext cx="0" cy="349135"/>
-          </a:xfrm>
-          <a:prstGeom prst="line">
-            <a:avLst/>
-          </a:prstGeom>
-          <a:ln w="8226" cap="flat">
-            <a:solidFill>
-              <a:srgbClr val="566472"/>
-            </a:solidFill>
-            <a:prstDash val="solid"/>
-          </a:ln>
-        </p:spPr>
-      </p:cxnSp>
-      <p:cxnSp>
-        <p:nvCxnSpPr>
-          <p:cNvPr id="39" name="Editable line 39"/>
-          <p:cNvCxnSpPr/>
-          <p:nvPr/>
-        </p:nvCxnSpPr>
-        <p:spPr>
-          <a:xfrm>
-            <a:off x="2143218" y="3352568"/>
-            <a:ext cx="3993963" cy="0"/>
-          </a:xfrm>
-          <a:prstGeom prst="line">
-            <a:avLst/>
-          </a:prstGeom>
-          <a:ln w="8218" cap="flat">
-            <a:solidFill>
-              <a:srgbClr val="566472"/>
-            </a:solidFill>
-            <a:prstDash val="solid"/>
-          </a:ln>
-        </p:spPr>
-      </p:cxnSp>
-      <p:cxnSp>
-        <p:nvCxnSpPr>
-          <p:cNvPr id="40" name="Editable line 40"/>
-          <p:cNvCxnSpPr/>
-          <p:nvPr/>
-        </p:nvCxnSpPr>
-        <p:spPr>
-          <a:xfrm>
-            <a:off x="2145242" y="3351510"/>
-            <a:ext cx="0" cy="231775"/>
-          </a:xfrm>
-          <a:prstGeom prst="line">
-            <a:avLst/>
-          </a:prstGeom>
-          <a:ln w="8209" cap="flat">
-            <a:solidFill>
-              <a:srgbClr val="566472"/>
-            </a:solidFill>
-            <a:prstDash val="solid"/>
-          </a:ln>
-        </p:spPr>
-      </p:cxnSp>
-      <p:sp>
-        <p:nvSpPr>
-          <p:cNvPr id="41" name="文字 41"/>
-          <p:cNvSpPr/>
-          <p:nvPr/>
-        </p:nvSpPr>
-        <p:spPr>
-          <a:xfrm rot="10800000">
-            <a:off x="2101850" y="3510260"/>
-            <a:ext cx="88900" cy="88900"/>
-          </a:xfrm>
-          <a:prstGeom prst="triangle">
-            <a:avLst/>
-          </a:prstGeom>
-          <a:solidFill>
-            <a:srgbClr val="566472"/>
-          </a:solidFill>
-          <a:ln>
-            <a:noFill/>
-          </a:ln>
-        </p:spPr>
-        <p:txBody>
-          <a:bodyPr/>
-          <a:p/>
-        </p:txBody>
-      </p:sp>
-      <p:cxnSp>
-        <p:nvCxnSpPr>
-          <p:cNvPr id="42" name="Editable line 42"/>
-          <p:cNvCxnSpPr/>
-          <p:nvPr/>
-        </p:nvCxnSpPr>
-        <p:spPr>
-          <a:xfrm>
-            <a:off x="5765800" y="3351510"/>
-            <a:ext cx="0" cy="231775"/>
-          </a:xfrm>
-          <a:prstGeom prst="line">
-            <a:avLst/>
-          </a:prstGeom>
-          <a:ln w="8218" cap="flat">
-            <a:solidFill>
-              <a:srgbClr val="566472"/>
-            </a:solidFill>
-            <a:prstDash val="solid"/>
-          </a:ln>
-        </p:spPr>
-      </p:cxnSp>
-      <p:sp>
-        <p:nvSpPr>
-          <p:cNvPr id="43" name="文字 43"/>
-          <p:cNvSpPr/>
-          <p:nvPr/>
-        </p:nvSpPr>
-        <p:spPr>
-          <a:xfrm rot="10800000">
-            <a:off x="5721350" y="3510260"/>
-            <a:ext cx="88900" cy="88900"/>
-          </a:xfrm>
-          <a:prstGeom prst="triangle">
-            <a:avLst/>
-          </a:prstGeom>
-          <a:solidFill>
-            <a:srgbClr val="566472"/>
-          </a:solidFill>
-          <a:ln>
-            <a:noFill/>
-          </a:ln>
-        </p:spPr>
-        <p:txBody>
-          <a:bodyPr/>
-          <a:p/>
-        </p:txBody>
-      </p:sp>
-      <p:sp>
-        <p:nvSpPr>
-          <p:cNvPr id="44" name="形状 44"/>
-          <p:cNvSpPr/>
-          <p:nvPr/>
-        </p:nvSpPr>
-        <p:spPr>
-          <a:xfrm>
-            <a:off x="457200" y="3586460"/>
-            <a:ext cx="3365500" cy="1365250"/>
-          </a:xfrm>
-          <a:prstGeom prst="roundRect">
-            <a:avLst>
-              <a:gd name="adj" fmla="val 6512"/>
-            </a:avLst>
-          </a:prstGeom>
-          <a:solidFill>
-            <a:srgbClr val="FFFFFF">
-              <a:alpha val="100000"/>
-            </a:srgbClr>
-          </a:solidFill>
-          <a:ln w="6350">
-            <a:solidFill>
-              <a:srgbClr val="D9DDE2">
-                <a:alpha val="100000"/>
-              </a:srgbClr>
-            </a:solidFill>
-            <a:prstDash val="solid"/>
-          </a:ln>
-        </p:spPr>
-        <p:txBody>
-          <a:bodyPr/>
-          <a:p/>
-        </p:txBody>
-      </p:sp>
-      <p:sp>
-        <p:nvSpPr>
-          <p:cNvPr id="45" name="文字 45"/>
-          <p:cNvSpPr txBox="1"/>
-          <p:nvPr/>
-        </p:nvSpPr>
-        <p:spPr>
-          <a:xfrm>
-            <a:off x="1377950" y="3700760"/>
-            <a:ext cx="1536700" cy="222250"/>
-          </a:xfrm>
-          <a:prstGeom prst="rect">
-            <a:avLst/>
-          </a:prstGeom>
-          <a:noFill/>
-          <a:ln>
-            <a:noFill/>
-          </a:ln>
-        </p:spPr>
-        <p:txBody>
-          <a:bodyPr wrap="none" anchor="t" lIns="0" tIns="0" rIns="0" bIns="0">
-            <a:noAutofit/>
-          </a:bodyPr>
-          <a:lstStyle/>
-          <a:p>
-            <a:pPr algn="l" marL="0" marR="0" indent="0">
-              <a:spcBef>
-                <a:spcPts val="0"/>
-              </a:spcBef>
-              <a:spcAft>
-                <a:spcPts val="0"/>
-              </a:spcAft>
-              <a:buNone/>
-              <a:defRPr sz="1000">
-                <a:latin typeface="微软雅黑"/>
-              </a:defRPr>
-            </a:pPr>
-            <a:r>
-              <a:rPr sz="1000" b="1" i="0" u="none" spc="-100">
-                <a:solidFill>
-                  <a:srgbClr val="1A1A1C">
-                    <a:alpha val="100000"/>
-                  </a:srgbClr>
-                </a:solidFill>
-                <a:latin typeface="微软雅黑"/>
-                <a:ea typeface="微软雅黑"/>
-                <a:cs typeface="微软雅黑"/>
-              </a:rPr>
-              <a:t xml:space="preserve">买断：交付完整源文件</a:t>
-            </a:r>
-            <a:endParaRPr/>
-          </a:p>
-        </p:txBody>
-      </p:sp>
-      <p:sp>
-        <p:nvSpPr>
-          <p:cNvPr id="46" name="文字 46"/>
-          <p:cNvSpPr txBox="1"/>
-          <p:nvPr/>
-        </p:nvSpPr>
-        <p:spPr>
-          <a:xfrm>
-            <a:off x="1382713" y="3949601"/>
-            <a:ext cx="1527175" cy="190500"/>
-          </a:xfrm>
-          <a:prstGeom prst="rect">
-            <a:avLst/>
-          </a:prstGeom>
-          <a:noFill/>
-          <a:ln>
-            <a:noFill/>
-          </a:ln>
-        </p:spPr>
-        <p:txBody>
-          <a:bodyPr wrap="none" anchor="t" lIns="0" tIns="0" rIns="0" bIns="0">
-            <a:noAutofit/>
-          </a:bodyPr>
-          <a:lstStyle/>
-          <a:p>
-            <a:pPr algn="l" marL="0" marR="0" indent="0">
-              <a:spcBef>
-                <a:spcPts val="0"/>
-              </a:spcBef>
-              <a:spcAft>
-                <a:spcPts val="0"/>
-              </a:spcAft>
-              <a:buNone/>
-              <a:defRPr sz="1000">
-                <a:latin typeface="微软雅黑"/>
-              </a:defRPr>
-            </a:pPr>
-            <a:r>
-              <a:rPr sz="1000" b="0" i="0" u="none" spc="-100">
-                <a:solidFill>
-                  <a:srgbClr val="585860">
-                    <a:alpha val="100000"/>
-                  </a:srgbClr>
-                </a:solidFill>
-                <a:latin typeface="微软雅黑"/>
-                <a:ea typeface="微软雅黑"/>
-                <a:cs typeface="微软雅黑"/>
-              </a:rPr>
-              <a:t xml:space="preserve">完整 Skill 进入本地 Agent</a:t>
-            </a:r>
-            <a:endParaRPr/>
-          </a:p>
-        </p:txBody>
-      </p:sp>
-      <p:sp>
-        <p:nvSpPr>
-          <p:cNvPr id="47" name="文字 47"/>
-          <p:cNvSpPr txBox="1"/>
-          <p:nvPr/>
-        </p:nvSpPr>
-        <p:spPr>
-          <a:xfrm>
-            <a:off x="1177230" y="4136231"/>
-            <a:ext cx="1938139" cy="190500"/>
-          </a:xfrm>
-          <a:prstGeom prst="rect">
-            <a:avLst/>
-          </a:prstGeom>
-          <a:noFill/>
-          <a:ln>
-            <a:noFill/>
-          </a:ln>
-        </p:spPr>
-        <p:txBody>
-          <a:bodyPr wrap="none" anchor="t" lIns="0" tIns="0" rIns="0" bIns="0">
-            <a:noAutofit/>
-          </a:bodyPr>
-          <a:lstStyle/>
-          <a:p>
-            <a:pPr algn="l" marL="0" marR="0" indent="0">
-              <a:spcBef>
-                <a:spcPts val="0"/>
-              </a:spcBef>
-              <a:spcAft>
-                <a:spcPts val="0"/>
-              </a:spcAft>
-              <a:buNone/>
-              <a:defRPr sz="1000">
-                <a:latin typeface="微软雅黑"/>
-              </a:defRPr>
-            </a:pPr>
-            <a:r>
-              <a:rPr sz="1000" b="0" i="0" u="none" spc="-100">
-                <a:solidFill>
-                  <a:srgbClr val="585860">
-                    <a:alpha val="100000"/>
-                  </a:srgbClr>
-                </a:solidFill>
-                <a:latin typeface="微软雅黑"/>
-                <a:ea typeface="微软雅黑"/>
-                <a:cs typeface="微软雅黑"/>
-              </a:rPr>
-              <a:t xml:space="preserve">一次购买可下载该 Skill 全部版本</a:t>
-            </a:r>
-            <a:endParaRPr/>
-          </a:p>
-        </p:txBody>
-      </p:sp>
-      <p:sp>
-        <p:nvSpPr>
-          <p:cNvPr id="48" name="文字 48"/>
-          <p:cNvSpPr txBox="1"/>
-          <p:nvPr/>
-        </p:nvSpPr>
-        <p:spPr>
-          <a:xfrm>
-            <a:off x="1273175" y="4322862"/>
-            <a:ext cx="1746250" cy="190500"/>
-          </a:xfrm>
-          <a:prstGeom prst="rect">
-            <a:avLst/>
-          </a:prstGeom>
-          <a:noFill/>
-          <a:ln>
-            <a:noFill/>
-          </a:ln>
-        </p:spPr>
-        <p:txBody>
-          <a:bodyPr wrap="none" anchor="t" lIns="0" tIns="0" rIns="0" bIns="0">
-            <a:noAutofit/>
-          </a:bodyPr>
-          <a:lstStyle/>
-          <a:p>
-            <a:pPr algn="l" marL="0" marR="0" indent="0">
-              <a:spcBef>
-                <a:spcPts val="0"/>
-              </a:spcBef>
-              <a:spcAft>
-                <a:spcPts val="0"/>
-              </a:spcAft>
-              <a:buNone/>
-              <a:defRPr sz="1000">
-                <a:latin typeface="微软雅黑"/>
-              </a:defRPr>
-            </a:pPr>
-            <a:r>
-              <a:rPr sz="1000" b="0" i="0" u="none" spc="-100">
-                <a:solidFill>
-                  <a:srgbClr val="585860">
-                    <a:alpha val="100000"/>
-                  </a:srgbClr>
-                </a:solidFill>
-                <a:latin typeface="微软雅黑"/>
-                <a:ea typeface="微软雅黑"/>
-                <a:cs typeface="微软雅黑"/>
-              </a:rPr>
-              <a:t xml:space="preserve">后续由本地读取、执行和保存</a:t>
-            </a:r>
-            <a:endParaRPr/>
-          </a:p>
-        </p:txBody>
-      </p:sp>
-      <p:sp>
-        <p:nvSpPr>
-          <p:cNvPr id="49" name="形状 49"/>
-          <p:cNvSpPr/>
-          <p:nvPr/>
-        </p:nvSpPr>
-        <p:spPr>
-          <a:xfrm>
-            <a:off x="4076700" y="3586460"/>
-            <a:ext cx="3365500" cy="1365250"/>
-          </a:xfrm>
-          <a:prstGeom prst="roundRect">
-            <a:avLst>
-              <a:gd name="adj" fmla="val 6512"/>
-            </a:avLst>
-          </a:prstGeom>
-          <a:solidFill>
-            <a:srgbClr val="FFFFFF">
-              <a:alpha val="100000"/>
-            </a:srgbClr>
-          </a:solidFill>
-          <a:ln w="6350">
-            <a:solidFill>
-              <a:srgbClr val="D9DDE2">
-                <a:alpha val="100000"/>
-              </a:srgbClr>
-            </a:solidFill>
-            <a:prstDash val="solid"/>
-          </a:ln>
-        </p:spPr>
-        <p:txBody>
-          <a:bodyPr/>
-          <a:p/>
-        </p:txBody>
-      </p:sp>
-      <p:sp>
-        <p:nvSpPr>
-          <p:cNvPr id="50" name="文字 50"/>
-          <p:cNvSpPr txBox="1"/>
-          <p:nvPr/>
-        </p:nvSpPr>
-        <p:spPr>
-          <a:xfrm>
-            <a:off x="4921250" y="3700760"/>
-            <a:ext cx="1689100" cy="222250"/>
-          </a:xfrm>
-          <a:prstGeom prst="rect">
-            <a:avLst/>
-          </a:prstGeom>
-          <a:noFill/>
-          <a:ln>
-            <a:noFill/>
-          </a:ln>
-        </p:spPr>
-        <p:txBody>
-          <a:bodyPr wrap="none" anchor="t" lIns="0" tIns="0" rIns="0" bIns="0">
-            <a:noAutofit/>
-          </a:bodyPr>
-          <a:lstStyle/>
-          <a:p>
-            <a:pPr algn="l" marL="0" marR="0" indent="0">
-              <a:spcBef>
-                <a:spcPts val="0"/>
-              </a:spcBef>
-              <a:spcAft>
-                <a:spcPts val="0"/>
-              </a:spcAft>
-              <a:buNone/>
-              <a:defRPr sz="1000">
-                <a:latin typeface="微软雅黑"/>
-              </a:defRPr>
-            </a:pPr>
-            <a:r>
-              <a:rPr sz="1000" b="1" i="0" u="none" spc="-100">
-                <a:solidFill>
-                  <a:srgbClr val="1A1A1C">
-                    <a:alpha val="100000"/>
-                  </a:srgbClr>
-                </a:solidFill>
-                <a:latin typeface="微软雅黑"/>
-                <a:ea typeface="微软雅黑"/>
-                <a:cs typeface="微软雅黑"/>
-              </a:rPr>
-              <a:t xml:space="preserve">订阅：交付期限内使用权</a:t>
-            </a:r>
-            <a:endParaRPr/>
-          </a:p>
-        </p:txBody>
-      </p:sp>
-      <p:sp>
-        <p:nvSpPr>
-          <p:cNvPr id="51" name="文字 51"/>
-          <p:cNvSpPr txBox="1"/>
-          <p:nvPr/>
-        </p:nvSpPr>
-        <p:spPr>
-          <a:xfrm>
-            <a:off x="5026025" y="3949601"/>
-            <a:ext cx="1479550" cy="190500"/>
-          </a:xfrm>
-          <a:prstGeom prst="rect">
-            <a:avLst/>
-          </a:prstGeom>
-          <a:noFill/>
-          <a:ln>
-            <a:noFill/>
-          </a:ln>
-        </p:spPr>
-        <p:txBody>
-          <a:bodyPr wrap="none" anchor="t" lIns="0" tIns="0" rIns="0" bIns="0">
-            <a:noAutofit/>
-          </a:bodyPr>
-          <a:lstStyle/>
-          <a:p>
-            <a:pPr algn="l" marL="0" marR="0" indent="0">
-              <a:spcBef>
-                <a:spcPts val="0"/>
-              </a:spcBef>
-              <a:spcAft>
-                <a:spcPts val="0"/>
-              </a:spcAft>
-              <a:buNone/>
-              <a:defRPr sz="1000">
-                <a:latin typeface="微软雅黑"/>
-              </a:defRPr>
-            </a:pPr>
-            <a:r>
-              <a:rPr sz="1000" b="0" i="0" u="none" spc="-100">
-                <a:solidFill>
-                  <a:srgbClr val="585860">
-                    <a:alpha val="100000"/>
-                  </a:srgbClr>
-                </a:solidFill>
-                <a:latin typeface="微软雅黑"/>
-                <a:ea typeface="微软雅黑"/>
-                <a:cs typeface="微软雅黑"/>
-              </a:rPr>
-              <a:t xml:space="preserve">本地保留入口与公开资源</a:t>
-            </a:r>
-            <a:endParaRPr/>
-          </a:p>
-        </p:txBody>
-      </p:sp>
-      <p:sp>
-        <p:nvSpPr>
-          <p:cNvPr id="52" name="文字 52"/>
-          <p:cNvSpPr txBox="1"/>
-          <p:nvPr/>
-        </p:nvSpPr>
-        <p:spPr>
-          <a:xfrm>
-            <a:off x="4759325" y="4136231"/>
-            <a:ext cx="2012950" cy="190500"/>
-          </a:xfrm>
-          <a:prstGeom prst="rect">
-            <a:avLst/>
-          </a:prstGeom>
-          <a:noFill/>
-          <a:ln>
-            <a:noFill/>
-          </a:ln>
-        </p:spPr>
-        <p:txBody>
-          <a:bodyPr wrap="none" anchor="t" lIns="0" tIns="0" rIns="0" bIns="0">
-            <a:noAutofit/>
-          </a:bodyPr>
-          <a:lstStyle/>
-          <a:p>
-            <a:pPr algn="l" marL="0" marR="0" indent="0">
-              <a:spcBef>
-                <a:spcPts val="0"/>
-              </a:spcBef>
-              <a:spcAft>
-                <a:spcPts val="0"/>
-              </a:spcAft>
-              <a:buNone/>
-              <a:defRPr sz="1000">
-                <a:latin typeface="微软雅黑"/>
-              </a:defRPr>
-            </a:pPr>
-            <a:r>
-              <a:rPr sz="1000" b="0" i="0" u="none" spc="-100">
-                <a:solidFill>
-                  <a:srgbClr val="585860">
-                    <a:alpha val="100000"/>
-                  </a:srgbClr>
-                </a:solidFill>
-                <a:latin typeface="微软雅黑"/>
-                <a:ea typeface="微软雅黑"/>
-                <a:cs typeface="微软雅黑"/>
-              </a:rPr>
-              <a:t xml:space="preserve">完整原文留云端，按任务提供指导</a:t>
-            </a:r>
-            <a:endParaRPr/>
-          </a:p>
-        </p:txBody>
-      </p:sp>
-      <p:sp>
-        <p:nvSpPr>
-          <p:cNvPr id="53" name="文字 53"/>
-          <p:cNvSpPr txBox="1"/>
-          <p:nvPr/>
-        </p:nvSpPr>
-        <p:spPr>
-          <a:xfrm>
-            <a:off x="4692650" y="4322862"/>
-            <a:ext cx="2146300" cy="190500"/>
-          </a:xfrm>
-          <a:prstGeom prst="rect">
-            <a:avLst/>
-          </a:prstGeom>
-          <a:noFill/>
-          <a:ln>
-            <a:noFill/>
-          </a:ln>
-        </p:spPr>
-        <p:txBody>
-          <a:bodyPr wrap="none" anchor="t" lIns="0" tIns="0" rIns="0" bIns="0">
-            <a:noAutofit/>
-          </a:bodyPr>
-          <a:lstStyle/>
-          <a:p>
-            <a:pPr algn="l" marL="0" marR="0" indent="0">
-              <a:spcBef>
-                <a:spcPts val="0"/>
-              </a:spcBef>
-              <a:spcAft>
-                <a:spcPts val="0"/>
-              </a:spcAft>
-              <a:buNone/>
-              <a:defRPr sz="1000">
-                <a:latin typeface="微软雅黑"/>
-              </a:defRPr>
-            </a:pPr>
-            <a:r>
-              <a:rPr sz="1000" b="0" i="0" u="none" spc="-100">
-                <a:solidFill>
-                  <a:srgbClr val="585860">
-                    <a:alpha val="100000"/>
-                  </a:srgbClr>
-                </a:solidFill>
-                <a:latin typeface="微软雅黑"/>
-                <a:ea typeface="微软雅黑"/>
-                <a:cs typeface="微软雅黑"/>
-              </a:rPr>
-              <a:t xml:space="preserve">当前不自动续费，到期重新取得权益</a:t>
-            </a:r>
-            <a:endParaRPr/>
-          </a:p>
-        </p:txBody>
-      </p:sp>
-      <p:sp>
-        <p:nvSpPr>
-          <p:cNvPr id="54" name="文字 54"/>
-          <p:cNvSpPr txBox="1"/>
-          <p:nvPr/>
-        </p:nvSpPr>
-        <p:spPr>
-          <a:xfrm>
-            <a:off x="457200" y="5104110"/>
-            <a:ext cx="3479800" cy="190500"/>
-          </a:xfrm>
-          <a:prstGeom prst="rect">
-            <a:avLst/>
-          </a:prstGeom>
-          <a:noFill/>
-          <a:ln>
-            <a:noFill/>
-          </a:ln>
-        </p:spPr>
-        <p:txBody>
-          <a:bodyPr wrap="none" anchor="t" lIns="0" tIns="0" rIns="0" bIns="0">
-            <a:noAutofit/>
-          </a:bodyPr>
-          <a:lstStyle/>
-          <a:p>
-            <a:pPr algn="l" marL="0" marR="0" indent="0">
-              <a:spcBef>
-                <a:spcPts val="0"/>
-              </a:spcBef>
-              <a:spcAft>
-                <a:spcPts val="0"/>
-              </a:spcAft>
-              <a:buNone/>
-              <a:defRPr sz="1000">
-                <a:latin typeface="微软雅黑"/>
-              </a:defRPr>
-            </a:pPr>
-            <a:r>
-              <a:rPr sz="1000" b="0" i="0" u="none" spc="-100">
-                <a:solidFill>
-                  <a:srgbClr val="B5333B">
-                    <a:alpha val="100000"/>
-                  </a:srgbClr>
-                </a:solidFill>
-                <a:latin typeface="微软雅黑"/>
-                <a:ea typeface="微软雅黑"/>
-                <a:cs typeface="微软雅黑"/>
-              </a:rPr>
-              <a:t xml:space="preserve">支付后按商品模式分叉，订阅并不等于每次任务重新扣款。</a:t>
-            </a:r>
-            <a:endParaRPr/>
-          </a:p>
-        </p:txBody>
-      </p:sp>
       <p:cxnSp>
         <p:nvCxnSpPr>
           <p:cNvPr id="55" name="Editable line 55"/>
@@ -7675,6 +6400,974 @@
           </a:prstGeom>
         </p:spPr>
       </p:pic>
+      <p:sp>
+        <p:nvSpPr>
+          <p:cNvPr id="77" name="TextBox 76"/>
+          <p:cNvSpPr txBox="1"/>
+          <p:nvPr/>
+        </p:nvSpPr>
+        <p:spPr>
+          <a:xfrm>
+            <a:off x="121919" y="1933955"/>
+            <a:ext cx="2316480" cy="150876"/>
+          </a:xfrm>
+          <a:prstGeom prst="rect">
+            <a:avLst/>
+          </a:prstGeom>
+          <a:noFill/>
+        </p:spPr>
+        <p:txBody>
+          <a:bodyPr wrap="square" lIns="0" rIns="0" tIns="0" bIns="0" anchor="t">
+            <a:spAutoFit/>
+          </a:bodyPr>
+          <a:lstStyle/>
+          <a:p>
+            <a:pPr algn="ctr">
+              <a:lnSpc>
+                <a:spcPct val="100000"/>
+              </a:lnSpc>
+            </a:pPr>
+            <a:r>
+              <a:rPr sz="1200" b="1">
+                <a:solidFill>
+                  <a:srgbClr val="1A1A1C"/>
+                </a:solidFill>
+                <a:latin typeface="微软雅黑"/>
+                <a:ea typeface="微软雅黑"/>
+                <a:cs typeface="微软雅黑"/>
+              </a:rPr>
+              <a:t>用户</a:t>
+            </a:r>
+          </a:p>
+        </p:txBody>
+      </p:sp>
+      <p:cxnSp>
+        <p:nvCxnSpPr>
+          <p:cNvPr id="78" name="Connector 77"/>
+          <p:cNvCxnSpPr/>
+          <p:nvPr/>
+        </p:nvCxnSpPr>
+        <p:spPr>
+          <a:xfrm>
+            <a:off x="1280160" y="2125980"/>
+            <a:ext cx="0" cy="2606040"/>
+          </a:xfrm>
+          <a:prstGeom prst="line">
+            <a:avLst/>
+          </a:prstGeom>
+          <a:ln w="10160">
+            <a:solidFill>
+              <a:srgbClr val="C4C8CD"/>
+            </a:solidFill>
+            <a:prstDash val="sysDot"/>
+          </a:ln>
+        </p:spPr>
+        <p:style>
+          <a:lnRef idx="2">
+            <a:schemeClr val="accent1"/>
+          </a:lnRef>
+          <a:fillRef idx="0">
+            <a:schemeClr val="accent1"/>
+          </a:fillRef>
+          <a:effectRef idx="1">
+            <a:schemeClr val="accent1"/>
+          </a:effectRef>
+          <a:fontRef idx="minor">
+            <a:schemeClr val="tx1"/>
+          </a:fontRef>
+        </p:style>
+      </p:cxnSp>
+      <p:sp>
+        <p:nvSpPr>
+          <p:cNvPr id="79" name="TextBox 78"/>
+          <p:cNvSpPr txBox="1"/>
+          <p:nvPr/>
+        </p:nvSpPr>
+        <p:spPr>
+          <a:xfrm>
+            <a:off x="1950720" y="1933955"/>
+            <a:ext cx="2316480" cy="150876"/>
+          </a:xfrm>
+          <a:prstGeom prst="rect">
+            <a:avLst/>
+          </a:prstGeom>
+          <a:noFill/>
+        </p:spPr>
+        <p:txBody>
+          <a:bodyPr wrap="square" lIns="0" rIns="0" tIns="0" bIns="0" anchor="t">
+            <a:spAutoFit/>
+          </a:bodyPr>
+          <a:lstStyle/>
+          <a:p>
+            <a:pPr algn="ctr">
+              <a:lnSpc>
+                <a:spcPct val="100000"/>
+              </a:lnSpc>
+            </a:pPr>
+            <a:r>
+              <a:rPr sz="1200" b="1">
+                <a:solidFill>
+                  <a:srgbClr val="1A1A1C"/>
+                </a:solidFill>
+                <a:latin typeface="微软雅黑"/>
+                <a:ea typeface="微软雅黑"/>
+                <a:cs typeface="微软雅黑"/>
+              </a:rPr>
+              <a:t>用户 Agent</a:t>
+            </a:r>
+          </a:p>
+        </p:txBody>
+      </p:sp>
+      <p:cxnSp>
+        <p:nvCxnSpPr>
+          <p:cNvPr id="80" name="Connector 79"/>
+          <p:cNvCxnSpPr/>
+          <p:nvPr/>
+        </p:nvCxnSpPr>
+        <p:spPr>
+          <a:xfrm>
+            <a:off x="3108960" y="2125980"/>
+            <a:ext cx="0" cy="2606040"/>
+          </a:xfrm>
+          <a:prstGeom prst="line">
+            <a:avLst/>
+          </a:prstGeom>
+          <a:ln w="10160">
+            <a:solidFill>
+              <a:srgbClr val="C4C8CD"/>
+            </a:solidFill>
+            <a:prstDash val="sysDot"/>
+          </a:ln>
+        </p:spPr>
+        <p:style>
+          <a:lnRef idx="2">
+            <a:schemeClr val="accent1"/>
+          </a:lnRef>
+          <a:fillRef idx="0">
+            <a:schemeClr val="accent1"/>
+          </a:fillRef>
+          <a:effectRef idx="1">
+            <a:schemeClr val="accent1"/>
+          </a:effectRef>
+          <a:fontRef idx="minor">
+            <a:schemeClr val="tx1"/>
+          </a:fontRef>
+        </p:style>
+      </p:cxnSp>
+      <p:sp>
+        <p:nvSpPr>
+          <p:cNvPr id="81" name="TextBox 80"/>
+          <p:cNvSpPr txBox="1"/>
+          <p:nvPr/>
+        </p:nvSpPr>
+        <p:spPr>
+          <a:xfrm>
+            <a:off x="3779520" y="1933955"/>
+            <a:ext cx="2316480" cy="150876"/>
+          </a:xfrm>
+          <a:prstGeom prst="rect">
+            <a:avLst/>
+          </a:prstGeom>
+          <a:noFill/>
+        </p:spPr>
+        <p:txBody>
+          <a:bodyPr wrap="square" lIns="0" rIns="0" tIns="0" bIns="0" anchor="t">
+            <a:spAutoFit/>
+          </a:bodyPr>
+          <a:lstStyle/>
+          <a:p>
+            <a:pPr algn="ctr">
+              <a:lnSpc>
+                <a:spcPct val="100000"/>
+              </a:lnSpc>
+            </a:pPr>
+            <a:r>
+              <a:rPr sz="1200" b="1">
+                <a:solidFill>
+                  <a:srgbClr val="1A1A1C"/>
+                </a:solidFill>
+                <a:latin typeface="微软雅黑"/>
+                <a:ea typeface="微软雅黑"/>
+                <a:cs typeface="微软雅黑"/>
+              </a:rPr>
+              <a:t>支付宝 SkillPay</a:t>
+            </a:r>
+          </a:p>
+        </p:txBody>
+      </p:sp>
+      <p:cxnSp>
+        <p:nvCxnSpPr>
+          <p:cNvPr id="82" name="Connector 81"/>
+          <p:cNvCxnSpPr/>
+          <p:nvPr/>
+        </p:nvCxnSpPr>
+        <p:spPr>
+          <a:xfrm>
+            <a:off x="4937760" y="2125980"/>
+            <a:ext cx="0" cy="2606040"/>
+          </a:xfrm>
+          <a:prstGeom prst="line">
+            <a:avLst/>
+          </a:prstGeom>
+          <a:ln w="10160">
+            <a:solidFill>
+              <a:srgbClr val="C4C8CD"/>
+            </a:solidFill>
+            <a:prstDash val="sysDot"/>
+          </a:ln>
+        </p:spPr>
+        <p:style>
+          <a:lnRef idx="2">
+            <a:schemeClr val="accent1"/>
+          </a:lnRef>
+          <a:fillRef idx="0">
+            <a:schemeClr val="accent1"/>
+          </a:fillRef>
+          <a:effectRef idx="1">
+            <a:schemeClr val="accent1"/>
+          </a:effectRef>
+          <a:fontRef idx="minor">
+            <a:schemeClr val="tx1"/>
+          </a:fontRef>
+        </p:style>
+      </p:cxnSp>
+      <p:sp>
+        <p:nvSpPr>
+          <p:cNvPr id="83" name="TextBox 82"/>
+          <p:cNvSpPr txBox="1"/>
+          <p:nvPr/>
+        </p:nvSpPr>
+        <p:spPr>
+          <a:xfrm>
+            <a:off x="5608320" y="1933955"/>
+            <a:ext cx="2316480" cy="150876"/>
+          </a:xfrm>
+          <a:prstGeom prst="rect">
+            <a:avLst/>
+          </a:prstGeom>
+          <a:noFill/>
+        </p:spPr>
+        <p:txBody>
+          <a:bodyPr wrap="square" lIns="0" rIns="0" tIns="0" bIns="0" anchor="t">
+            <a:spAutoFit/>
+          </a:bodyPr>
+          <a:lstStyle/>
+          <a:p>
+            <a:pPr algn="ctr">
+              <a:lnSpc>
+                <a:spcPct val="100000"/>
+              </a:lnSpc>
+            </a:pPr>
+            <a:r>
+              <a:rPr sz="1200" b="1">
+                <a:solidFill>
+                  <a:srgbClr val="1A1A1C"/>
+                </a:solidFill>
+                <a:latin typeface="微软雅黑"/>
+                <a:ea typeface="微软雅黑"/>
+                <a:cs typeface="微软雅黑"/>
+              </a:rPr>
+              <a:t>商品履约</a:t>
+            </a:r>
+          </a:p>
+        </p:txBody>
+      </p:sp>
+      <p:cxnSp>
+        <p:nvCxnSpPr>
+          <p:cNvPr id="84" name="Connector 83"/>
+          <p:cNvCxnSpPr/>
+          <p:nvPr/>
+        </p:nvCxnSpPr>
+        <p:spPr>
+          <a:xfrm>
+            <a:off x="6766560" y="2125980"/>
+            <a:ext cx="0" cy="2606040"/>
+          </a:xfrm>
+          <a:prstGeom prst="line">
+            <a:avLst/>
+          </a:prstGeom>
+          <a:ln w="10160">
+            <a:solidFill>
+              <a:srgbClr val="C4C8CD"/>
+            </a:solidFill>
+            <a:prstDash val="sysDot"/>
+          </a:ln>
+        </p:spPr>
+        <p:style>
+          <a:lnRef idx="2">
+            <a:schemeClr val="accent1"/>
+          </a:lnRef>
+          <a:fillRef idx="0">
+            <a:schemeClr val="accent1"/>
+          </a:fillRef>
+          <a:effectRef idx="1">
+            <a:schemeClr val="accent1"/>
+          </a:effectRef>
+          <a:fontRef idx="minor">
+            <a:schemeClr val="tx1"/>
+          </a:fontRef>
+        </p:style>
+      </p:cxnSp>
+      <p:cxnSp>
+        <p:nvCxnSpPr>
+          <p:cNvPr id="85" name="Connector 84"/>
+          <p:cNvCxnSpPr/>
+          <p:nvPr/>
+        </p:nvCxnSpPr>
+        <p:spPr>
+          <a:xfrm>
+            <a:off x="1280160" y="2434590"/>
+            <a:ext cx="1828800" cy="0"/>
+          </a:xfrm>
+          <a:prstGeom prst="line">
+            <a:avLst/>
+          </a:prstGeom>
+          <a:ln w="11430">
+            <a:solidFill>
+              <a:srgbClr val="5B616B"/>
+            </a:solidFill>
+            <a:tailEnd type="triangle" w="sm" len="sm"/>
+          </a:ln>
+        </p:spPr>
+        <p:style>
+          <a:lnRef idx="2">
+            <a:schemeClr val="accent1"/>
+          </a:lnRef>
+          <a:fillRef idx="0">
+            <a:schemeClr val="accent1"/>
+          </a:fillRef>
+          <a:effectRef idx="1">
+            <a:schemeClr val="accent1"/>
+          </a:effectRef>
+          <a:fontRef idx="minor">
+            <a:schemeClr val="tx1"/>
+          </a:fontRef>
+        </p:style>
+      </p:cxnSp>
+      <p:sp>
+        <p:nvSpPr>
+          <p:cNvPr id="86" name="TextBox 85"/>
+          <p:cNvSpPr txBox="1"/>
+          <p:nvPr/>
+        </p:nvSpPr>
+        <p:spPr>
+          <a:xfrm>
+            <a:off x="1341120" y="2228850"/>
+            <a:ext cx="1706880" cy="109728"/>
+          </a:xfrm>
+          <a:prstGeom prst="rect">
+            <a:avLst/>
+          </a:prstGeom>
+          <a:noFill/>
+        </p:spPr>
+        <p:txBody>
+          <a:bodyPr wrap="square" lIns="0" rIns="0" tIns="0" bIns="0" anchor="t">
+            <a:spAutoFit/>
+          </a:bodyPr>
+          <a:lstStyle/>
+          <a:p>
+            <a:pPr algn="ctr">
+              <a:lnSpc>
+                <a:spcPct val="100000"/>
+              </a:lnSpc>
+            </a:pPr>
+            <a:r>
+              <a:rPr sz="900" b="0">
+                <a:solidFill>
+                  <a:srgbClr val="5B616B"/>
+                </a:solidFill>
+                <a:latin typeface="微软雅黑"/>
+                <a:ea typeface="微软雅黑"/>
+                <a:cs typeface="微软雅黑"/>
+              </a:rPr>
+              <a:t>① 提出任务</a:t>
+            </a:r>
+          </a:p>
+        </p:txBody>
+      </p:sp>
+      <p:cxnSp>
+        <p:nvCxnSpPr>
+          <p:cNvPr id="87" name="Connector 86"/>
+          <p:cNvCxnSpPr/>
+          <p:nvPr/>
+        </p:nvCxnSpPr>
+        <p:spPr>
+          <a:xfrm>
+            <a:off x="3108960" y="2722626"/>
+            <a:ext cx="1828800" cy="0"/>
+          </a:xfrm>
+          <a:prstGeom prst="line">
+            <a:avLst/>
+          </a:prstGeom>
+          <a:ln w="11430">
+            <a:solidFill>
+              <a:srgbClr val="5B616B"/>
+            </a:solidFill>
+            <a:tailEnd type="triangle" w="sm" len="sm"/>
+          </a:ln>
+        </p:spPr>
+        <p:style>
+          <a:lnRef idx="2">
+            <a:schemeClr val="accent1"/>
+          </a:lnRef>
+          <a:fillRef idx="0">
+            <a:schemeClr val="accent1"/>
+          </a:fillRef>
+          <a:effectRef idx="1">
+            <a:schemeClr val="accent1"/>
+          </a:effectRef>
+          <a:fontRef idx="minor">
+            <a:schemeClr val="tx1"/>
+          </a:fontRef>
+        </p:style>
+      </p:cxnSp>
+      <p:sp>
+        <p:nvSpPr>
+          <p:cNvPr id="88" name="TextBox 87"/>
+          <p:cNvSpPr txBox="1"/>
+          <p:nvPr/>
+        </p:nvSpPr>
+        <p:spPr>
+          <a:xfrm>
+            <a:off x="3169920" y="2516886"/>
+            <a:ext cx="1706880" cy="109728"/>
+          </a:xfrm>
+          <a:prstGeom prst="rect">
+            <a:avLst/>
+          </a:prstGeom>
+          <a:noFill/>
+        </p:spPr>
+        <p:txBody>
+          <a:bodyPr wrap="square" lIns="0" rIns="0" tIns="0" bIns="0" anchor="t">
+            <a:spAutoFit/>
+          </a:bodyPr>
+          <a:lstStyle/>
+          <a:p>
+            <a:pPr algn="ctr">
+              <a:lnSpc>
+                <a:spcPct val="100000"/>
+              </a:lnSpc>
+            </a:pPr>
+            <a:r>
+              <a:rPr sz="900" b="0">
+                <a:solidFill>
+                  <a:srgbClr val="5B616B"/>
+                </a:solidFill>
+                <a:latin typeface="微软雅黑"/>
+                <a:ea typeface="微软雅黑"/>
+                <a:cs typeface="微软雅黑"/>
+              </a:rPr>
+              <a:t>② 请求调用</a:t>
+            </a:r>
+          </a:p>
+        </p:txBody>
+      </p:sp>
+      <p:cxnSp>
+        <p:nvCxnSpPr>
+          <p:cNvPr id="89" name="Connector 88"/>
+          <p:cNvCxnSpPr/>
+          <p:nvPr/>
+        </p:nvCxnSpPr>
+        <p:spPr>
+          <a:xfrm flipH="1">
+            <a:off x="3108960" y="3010662"/>
+            <a:ext cx="1828800" cy="0"/>
+          </a:xfrm>
+          <a:prstGeom prst="line">
+            <a:avLst/>
+          </a:prstGeom>
+          <a:ln w="11430">
+            <a:solidFill>
+              <a:srgbClr val="B5333B"/>
+            </a:solidFill>
+            <a:prstDash val="dash"/>
+            <a:tailEnd type="triangle" w="sm" len="sm"/>
+          </a:ln>
+        </p:spPr>
+        <p:style>
+          <a:lnRef idx="2">
+            <a:schemeClr val="accent1"/>
+          </a:lnRef>
+          <a:fillRef idx="0">
+            <a:schemeClr val="accent1"/>
+          </a:fillRef>
+          <a:effectRef idx="1">
+            <a:schemeClr val="accent1"/>
+          </a:effectRef>
+          <a:fontRef idx="minor">
+            <a:schemeClr val="tx1"/>
+          </a:fontRef>
+        </p:style>
+      </p:cxnSp>
+      <p:sp>
+        <p:nvSpPr>
+          <p:cNvPr id="90" name="TextBox 89"/>
+          <p:cNvSpPr txBox="1"/>
+          <p:nvPr/>
+        </p:nvSpPr>
+        <p:spPr>
+          <a:xfrm>
+            <a:off x="2865120" y="2804922"/>
+            <a:ext cx="2316480" cy="109728"/>
+          </a:xfrm>
+          <a:prstGeom prst="rect">
+            <a:avLst/>
+          </a:prstGeom>
+          <a:noFill/>
+        </p:spPr>
+        <p:txBody>
+          <a:bodyPr wrap="square" lIns="0" rIns="0" tIns="0" bIns="0" anchor="t">
+            <a:spAutoFit/>
+          </a:bodyPr>
+          <a:lstStyle/>
+          <a:p>
+            <a:pPr algn="ctr">
+              <a:lnSpc>
+                <a:spcPct val="100000"/>
+              </a:lnSpc>
+            </a:pPr>
+            <a:r>
+              <a:rPr sz="900" b="0">
+                <a:solidFill>
+                  <a:srgbClr val="B5333B"/>
+                </a:solidFill>
+                <a:latin typeface="微软雅黑"/>
+                <a:ea typeface="微软雅黑"/>
+                <a:cs typeface="微软雅黑"/>
+              </a:rPr>
+              <a:t>③ HTTP 402 + 支付要求</a:t>
+            </a:r>
+          </a:p>
+        </p:txBody>
+      </p:sp>
+      <p:cxnSp>
+        <p:nvCxnSpPr>
+          <p:cNvPr id="91" name="Connector 90"/>
+          <p:cNvCxnSpPr/>
+          <p:nvPr/>
+        </p:nvCxnSpPr>
+        <p:spPr>
+          <a:xfrm flipH="1">
+            <a:off x="1280160" y="3298698"/>
+            <a:ext cx="1828800" cy="0"/>
+          </a:xfrm>
+          <a:prstGeom prst="line">
+            <a:avLst/>
+          </a:prstGeom>
+          <a:ln w="11430">
+            <a:solidFill>
+              <a:srgbClr val="5B616B"/>
+            </a:solidFill>
+            <a:prstDash val="dash"/>
+            <a:tailEnd type="triangle" w="sm" len="sm"/>
+          </a:ln>
+        </p:spPr>
+        <p:style>
+          <a:lnRef idx="2">
+            <a:schemeClr val="accent1"/>
+          </a:lnRef>
+          <a:fillRef idx="0">
+            <a:schemeClr val="accent1"/>
+          </a:fillRef>
+          <a:effectRef idx="1">
+            <a:schemeClr val="accent1"/>
+          </a:effectRef>
+          <a:fontRef idx="minor">
+            <a:schemeClr val="tx1"/>
+          </a:fontRef>
+        </p:style>
+      </p:cxnSp>
+      <p:sp>
+        <p:nvSpPr>
+          <p:cNvPr id="92" name="TextBox 91"/>
+          <p:cNvSpPr txBox="1"/>
+          <p:nvPr/>
+        </p:nvSpPr>
+        <p:spPr>
+          <a:xfrm>
+            <a:off x="975360" y="3092958"/>
+            <a:ext cx="2438400" cy="109728"/>
+          </a:xfrm>
+          <a:prstGeom prst="rect">
+            <a:avLst/>
+          </a:prstGeom>
+          <a:noFill/>
+        </p:spPr>
+        <p:txBody>
+          <a:bodyPr wrap="square" lIns="0" rIns="0" tIns="0" bIns="0" anchor="t">
+            <a:spAutoFit/>
+          </a:bodyPr>
+          <a:lstStyle/>
+          <a:p>
+            <a:pPr algn="ctr">
+              <a:lnSpc>
+                <a:spcPct val="100000"/>
+              </a:lnSpc>
+            </a:pPr>
+            <a:r>
+              <a:rPr sz="900" b="0">
+                <a:solidFill>
+                  <a:srgbClr val="5B616B"/>
+                </a:solidFill>
+                <a:latin typeface="微软雅黑"/>
+                <a:ea typeface="微软雅黑"/>
+                <a:cs typeface="微软雅黑"/>
+              </a:rPr>
+              <a:t>④ 说明价格并请求确认</a:t>
+            </a:r>
+          </a:p>
+        </p:txBody>
+      </p:sp>
+      <p:cxnSp>
+        <p:nvCxnSpPr>
+          <p:cNvPr id="93" name="Connector 92"/>
+          <p:cNvCxnSpPr/>
+          <p:nvPr/>
+        </p:nvCxnSpPr>
+        <p:spPr>
+          <a:xfrm>
+            <a:off x="1280160" y="3586734"/>
+            <a:ext cx="1828800" cy="0"/>
+          </a:xfrm>
+          <a:prstGeom prst="line">
+            <a:avLst/>
+          </a:prstGeom>
+          <a:ln w="11430">
+            <a:solidFill>
+              <a:srgbClr val="B5333B"/>
+            </a:solidFill>
+            <a:tailEnd type="triangle" w="sm" len="sm"/>
+          </a:ln>
+        </p:spPr>
+        <p:style>
+          <a:lnRef idx="2">
+            <a:schemeClr val="accent1"/>
+          </a:lnRef>
+          <a:fillRef idx="0">
+            <a:schemeClr val="accent1"/>
+          </a:fillRef>
+          <a:effectRef idx="1">
+            <a:schemeClr val="accent1"/>
+          </a:effectRef>
+          <a:fontRef idx="minor">
+            <a:schemeClr val="tx1"/>
+          </a:fontRef>
+        </p:style>
+      </p:cxnSp>
+      <p:sp>
+        <p:nvSpPr>
+          <p:cNvPr id="94" name="TextBox 93"/>
+          <p:cNvSpPr txBox="1"/>
+          <p:nvPr/>
+        </p:nvSpPr>
+        <p:spPr>
+          <a:xfrm>
+            <a:off x="1341120" y="3380994"/>
+            <a:ext cx="1706880" cy="109728"/>
+          </a:xfrm>
+          <a:prstGeom prst="rect">
+            <a:avLst/>
+          </a:prstGeom>
+          <a:noFill/>
+        </p:spPr>
+        <p:txBody>
+          <a:bodyPr wrap="square" lIns="0" rIns="0" tIns="0" bIns="0" anchor="t">
+            <a:spAutoFit/>
+          </a:bodyPr>
+          <a:lstStyle/>
+          <a:p>
+            <a:pPr algn="ctr">
+              <a:lnSpc>
+                <a:spcPct val="100000"/>
+              </a:lnSpc>
+            </a:pPr>
+            <a:r>
+              <a:rPr sz="900" b="0">
+                <a:solidFill>
+                  <a:srgbClr val="B5333B"/>
+                </a:solidFill>
+                <a:latin typeface="微软雅黑"/>
+                <a:ea typeface="微软雅黑"/>
+                <a:cs typeface="微软雅黑"/>
+              </a:rPr>
+              <a:t>⑤ 确认支付</a:t>
+            </a:r>
+          </a:p>
+        </p:txBody>
+      </p:sp>
+      <p:cxnSp>
+        <p:nvCxnSpPr>
+          <p:cNvPr id="95" name="Connector 94"/>
+          <p:cNvCxnSpPr/>
+          <p:nvPr/>
+        </p:nvCxnSpPr>
+        <p:spPr>
+          <a:xfrm>
+            <a:off x="3108960" y="3874769"/>
+            <a:ext cx="1828800" cy="0"/>
+          </a:xfrm>
+          <a:prstGeom prst="line">
+            <a:avLst/>
+          </a:prstGeom>
+          <a:ln w="11430">
+            <a:solidFill>
+              <a:srgbClr val="B5333B"/>
+            </a:solidFill>
+            <a:tailEnd type="triangle" w="sm" len="sm"/>
+          </a:ln>
+        </p:spPr>
+        <p:style>
+          <a:lnRef idx="2">
+            <a:schemeClr val="accent1"/>
+          </a:lnRef>
+          <a:fillRef idx="0">
+            <a:schemeClr val="accent1"/>
+          </a:fillRef>
+          <a:effectRef idx="1">
+            <a:schemeClr val="accent1"/>
+          </a:effectRef>
+          <a:fontRef idx="minor">
+            <a:schemeClr val="tx1"/>
+          </a:fontRef>
+        </p:style>
+      </p:cxnSp>
+      <p:sp>
+        <p:nvSpPr>
+          <p:cNvPr id="96" name="TextBox 95"/>
+          <p:cNvSpPr txBox="1"/>
+          <p:nvPr/>
+        </p:nvSpPr>
+        <p:spPr>
+          <a:xfrm>
+            <a:off x="2865120" y="3669029"/>
+            <a:ext cx="2316480" cy="109728"/>
+          </a:xfrm>
+          <a:prstGeom prst="rect">
+            <a:avLst/>
+          </a:prstGeom>
+          <a:noFill/>
+        </p:spPr>
+        <p:txBody>
+          <a:bodyPr wrap="square" lIns="0" rIns="0" tIns="0" bIns="0" anchor="t">
+            <a:spAutoFit/>
+          </a:bodyPr>
+          <a:lstStyle/>
+          <a:p>
+            <a:pPr algn="ctr">
+              <a:lnSpc>
+                <a:spcPct val="100000"/>
+              </a:lnSpc>
+            </a:pPr>
+            <a:r>
+              <a:rPr sz="900" b="0">
+                <a:solidFill>
+                  <a:srgbClr val="B5333B"/>
+                </a:solidFill>
+                <a:latin typeface="微软雅黑"/>
+                <a:ea typeface="微软雅黑"/>
+                <a:cs typeface="微软雅黑"/>
+              </a:rPr>
+              <a:t>⑥ 携带支付结果重试</a:t>
+            </a:r>
+          </a:p>
+        </p:txBody>
+      </p:sp>
+      <p:cxnSp>
+        <p:nvCxnSpPr>
+          <p:cNvPr id="97" name="Connector 96"/>
+          <p:cNvCxnSpPr/>
+          <p:nvPr/>
+        </p:nvCxnSpPr>
+        <p:spPr>
+          <a:xfrm>
+            <a:off x="4937760" y="4162806"/>
+            <a:ext cx="1828800" cy="0"/>
+          </a:xfrm>
+          <a:prstGeom prst="line">
+            <a:avLst/>
+          </a:prstGeom>
+          <a:ln w="11430">
+            <a:solidFill>
+              <a:srgbClr val="B5333B"/>
+            </a:solidFill>
+            <a:tailEnd type="triangle" w="sm" len="sm"/>
+          </a:ln>
+        </p:spPr>
+        <p:style>
+          <a:lnRef idx="2">
+            <a:schemeClr val="accent1"/>
+          </a:lnRef>
+          <a:fillRef idx="0">
+            <a:schemeClr val="accent1"/>
+          </a:fillRef>
+          <a:effectRef idx="1">
+            <a:schemeClr val="accent1"/>
+          </a:effectRef>
+          <a:fontRef idx="minor">
+            <a:schemeClr val="tx1"/>
+          </a:fontRef>
+        </p:style>
+      </p:cxnSp>
+      <p:sp>
+        <p:nvSpPr>
+          <p:cNvPr id="98" name="TextBox 97"/>
+          <p:cNvSpPr txBox="1"/>
+          <p:nvPr/>
+        </p:nvSpPr>
+        <p:spPr>
+          <a:xfrm>
+            <a:off x="4328160" y="3957066"/>
+            <a:ext cx="3048000" cy="109728"/>
+          </a:xfrm>
+          <a:prstGeom prst="rect">
+            <a:avLst/>
+          </a:prstGeom>
+          <a:noFill/>
+        </p:spPr>
+        <p:txBody>
+          <a:bodyPr wrap="square" lIns="0" rIns="0" tIns="0" bIns="0" anchor="t">
+            <a:spAutoFit/>
+          </a:bodyPr>
+          <a:lstStyle/>
+          <a:p>
+            <a:pPr algn="ctr">
+              <a:lnSpc>
+                <a:spcPct val="100000"/>
+              </a:lnSpc>
+            </a:pPr>
+            <a:r>
+              <a:rPr sz="900" b="0">
+                <a:solidFill>
+                  <a:srgbClr val="B5333B"/>
+                </a:solidFill>
+                <a:latin typeface="微软雅黑"/>
+                <a:ea typeface="微软雅黑"/>
+                <a:cs typeface="微软雅黑"/>
+              </a:rPr>
+              <a:t>⑦ 一次性交付 / 创建订阅权益</a:t>
+            </a:r>
+          </a:p>
+        </p:txBody>
+      </p:sp>
+      <p:cxnSp>
+        <p:nvCxnSpPr>
+          <p:cNvPr id="99" name="Connector 98"/>
+          <p:cNvCxnSpPr/>
+          <p:nvPr/>
+        </p:nvCxnSpPr>
+        <p:spPr>
+          <a:xfrm flipH="1">
+            <a:off x="3108960" y="4450842"/>
+            <a:ext cx="3657600" cy="0"/>
+          </a:xfrm>
+          <a:prstGeom prst="line">
+            <a:avLst/>
+          </a:prstGeom>
+          <a:ln w="11430">
+            <a:solidFill>
+              <a:srgbClr val="5B616B"/>
+            </a:solidFill>
+            <a:prstDash val="dash"/>
+            <a:tailEnd type="triangle" w="sm" len="sm"/>
+          </a:ln>
+        </p:spPr>
+        <p:style>
+          <a:lnRef idx="2">
+            <a:schemeClr val="accent1"/>
+          </a:lnRef>
+          <a:fillRef idx="0">
+            <a:schemeClr val="accent1"/>
+          </a:fillRef>
+          <a:effectRef idx="1">
+            <a:schemeClr val="accent1"/>
+          </a:effectRef>
+          <a:fontRef idx="minor">
+            <a:schemeClr val="tx1"/>
+          </a:fontRef>
+        </p:style>
+      </p:cxnSp>
+      <p:sp>
+        <p:nvSpPr>
+          <p:cNvPr id="100" name="TextBox 99"/>
+          <p:cNvSpPr txBox="1"/>
+          <p:nvPr/>
+        </p:nvSpPr>
+        <p:spPr>
+          <a:xfrm>
+            <a:off x="2865120" y="4245102"/>
+            <a:ext cx="4145280" cy="109728"/>
+          </a:xfrm>
+          <a:prstGeom prst="rect">
+            <a:avLst/>
+          </a:prstGeom>
+          <a:noFill/>
+        </p:spPr>
+        <p:txBody>
+          <a:bodyPr wrap="square" lIns="0" rIns="0" tIns="0" bIns="0" anchor="t">
+            <a:spAutoFit/>
+          </a:bodyPr>
+          <a:lstStyle/>
+          <a:p>
+            <a:pPr algn="ctr">
+              <a:lnSpc>
+                <a:spcPct val="100000"/>
+              </a:lnSpc>
+            </a:pPr>
+            <a:r>
+              <a:rPr sz="900" b="0">
+                <a:solidFill>
+                  <a:srgbClr val="5B616B"/>
+                </a:solidFill>
+                <a:latin typeface="微软雅黑"/>
+                <a:ea typeface="微软雅黑"/>
+                <a:cs typeface="微软雅黑"/>
+              </a:rPr>
+              <a:t>⑧ 恢复安装或调用，继续原任务</a:t>
+            </a:r>
+          </a:p>
+        </p:txBody>
+      </p:sp>
+      <p:sp>
+        <p:nvSpPr>
+          <p:cNvPr id="101" name="TextBox 100"/>
+          <p:cNvSpPr txBox="1"/>
+          <p:nvPr/>
+        </p:nvSpPr>
+        <p:spPr>
+          <a:xfrm>
+            <a:off x="426720" y="4869180"/>
+            <a:ext cx="7193280" cy="116586"/>
+          </a:xfrm>
+          <a:prstGeom prst="rect">
+            <a:avLst/>
+          </a:prstGeom>
+          <a:noFill/>
+        </p:spPr>
+        <p:txBody>
+          <a:bodyPr wrap="square" lIns="0" rIns="0" tIns="0" bIns="0" anchor="t">
+            <a:spAutoFit/>
+          </a:bodyPr>
+          <a:lstStyle/>
+          <a:p>
+            <a:pPr algn="l">
+              <a:lnSpc>
+                <a:spcPct val="100000"/>
+              </a:lnSpc>
+            </a:pPr>
+            <a:r>
+              <a:rPr sz="819" b="0">
+                <a:solidFill>
+                  <a:srgbClr val="5B616B"/>
+                </a:solidFill>
+                <a:latin typeface="微软雅黑"/>
+                <a:ea typeface="微软雅黑"/>
+                <a:cs typeface="微软雅黑"/>
+              </a:rPr>
+              <a:t>交付分叉：买断=源文件；订阅=使用权；支付成功≠交付成功。</a:t>
+            </a:r>
+          </a:p>
+        </p:txBody>
+      </p:sp>
     </p:spTree>
   </p:cSld>
   <p:clrMapOvr>

</xml_diff>